<commit_message>
Slides: qualify the DNS-first answer in the sd-10-001 deck
Co-Authored-By: Claude Sonnet 5.5 <noreply@anthropic.com>
Claude-Session: https://claude.ai/code/session_01E4oCkXXqBf2c7oMUzFxEr2
</commit_message>
<xml_diff>
--- a/system-design-101/vi/lessons/sd-10-001/slides/sd-10-001.pptx
+++ b/system-design-101/vi/lessons/sd-10-001/slides/sd-10-001.pptx
@@ -18504,6 +18504,1017 @@
         </p:nvSpPr>
         <p:spPr>
           <a:xfrm>
+            <a:off x="914400" y="6667500"/>
+            <a:ext cx="5334000" cy="685800"/>
+          </a:xfrm>
+          <a:prstGeom prst="roundRect">
+            <a:avLst>
+              <a:gd name="adj" fmla="val 50000"/>
+            </a:avLst>
+          </a:prstGeom>
+          <a:solidFill>
+            <a:srgbClr val="E8472B"/>
+          </a:solidFill>
+          <a:ln/>
+        </p:spPr>
+        <p:txBody>
+          <a:bodyPr wrap="square" lIns="0" tIns="0" rIns="0" bIns="0" rtlCol="0" anchor="ctr"/>
+          <a:lstStyle/>
+          <a:p>
+            <a:pPr algn="ctr" indent="0" marL="0">
+              <a:buNone/>
+            </a:pPr>
+            <a:r>
+              <a:rPr lang="en-US" sz="2250" b="1" dirty="0" spc="5" kern="0">
+                <a:solidFill>
+                  <a:srgbClr val="F3EEE3"/>
+                </a:solidFill>
+                <a:latin typeface="Be Vietnam Pro" pitchFamily="34" charset="0"/>
+                <a:ea typeface="Be Vietnam Pro" pitchFamily="34" charset="-122"/>
+                <a:cs typeface="Be Vietnam Pro" pitchFamily="34" charset="-120"/>
+              </a:rPr>
+              <a:t>Thử</a:t>
+            </a:r>
+            <a:r>
+              <a:rPr lang="en-US" sz="2250" b="1" dirty="0" spc="-10" kern="0">
+                <a:solidFill>
+                  <a:srgbClr val="F3EEE3"/>
+                </a:solidFill>
+                <a:latin typeface="Be Vietnam Pro" pitchFamily="34" charset="0"/>
+                <a:ea typeface="Be Vietnam Pro" pitchFamily="34" charset="-122"/>
+                <a:cs typeface="Be Vietnam Pro" pitchFamily="34" charset="-120"/>
+              </a:rPr>
+              <a:t> trả</a:t>
+            </a:r>
+            <a:r>
+              <a:rPr lang="en-US" sz="2250" b="1" dirty="0" spc="4" kern="0">
+                <a:solidFill>
+                  <a:srgbClr val="F3EEE3"/>
+                </a:solidFill>
+                <a:latin typeface="Be Vietnam Pro" pitchFamily="34" charset="0"/>
+                <a:ea typeface="Be Vietnam Pro" pitchFamily="34" charset="-122"/>
+                <a:cs typeface="Be Vietnam Pro" pitchFamily="34" charset="-120"/>
+              </a:rPr>
+              <a:t> lời</a:t>
+            </a:r>
+            <a:r>
+              <a:rPr lang="en-US" sz="2250" b="1" dirty="0" spc="-8" kern="0">
+                <a:solidFill>
+                  <a:srgbClr val="F3EEE3"/>
+                </a:solidFill>
+                <a:latin typeface="Be Vietnam Pro" pitchFamily="34" charset="0"/>
+                <a:ea typeface="Be Vietnam Pro" pitchFamily="34" charset="-122"/>
+                <a:cs typeface="Be Vietnam Pro" pitchFamily="34" charset="-120"/>
+              </a:rPr>
+              <a:t> rồi</a:t>
+            </a:r>
+            <a:r>
+              <a:rPr lang="en-US" sz="2250" b="1" dirty="0" spc="-19" kern="0">
+                <a:solidFill>
+                  <a:srgbClr val="F3EEE3"/>
+                </a:solidFill>
+                <a:latin typeface="Be Vietnam Pro" pitchFamily="34" charset="0"/>
+                <a:ea typeface="Be Vietnam Pro" pitchFamily="34" charset="-122"/>
+                <a:cs typeface="Be Vietnam Pro" pitchFamily="34" charset="-120"/>
+              </a:rPr>
+              <a:t> xem</a:t>
+            </a:r>
+            <a:r>
+              <a:rPr lang="en-US" sz="2250" b="1" dirty="0" spc="10" kern="0">
+                <a:solidFill>
+                  <a:srgbClr val="F3EEE3"/>
+                </a:solidFill>
+                <a:latin typeface="Be Vietnam Pro" pitchFamily="34" charset="0"/>
+                <a:ea typeface="Be Vietnam Pro" pitchFamily="34" charset="-122"/>
+                <a:cs typeface="Be Vietnam Pro" pitchFamily="34" charset="-120"/>
+              </a:rPr>
+              <a:t> đáp</a:t>
+            </a:r>
+            <a:r>
+              <a:rPr lang="en-US" sz="2250" b="1" dirty="0" spc="3" kern="0">
+                <a:solidFill>
+                  <a:srgbClr val="F3EEE3"/>
+                </a:solidFill>
+                <a:latin typeface="Be Vietnam Pro" pitchFamily="34" charset="0"/>
+                <a:ea typeface="Be Vietnam Pro" pitchFamily="34" charset="-122"/>
+                <a:cs typeface="Be Vietnam Pro" pitchFamily="34" charset="-120"/>
+              </a:rPr>
+              <a:t> án</a:t>
+            </a:r>
+            <a:endParaRPr lang="en-US" sz="2250" dirty="0"/>
+          </a:p>
+        </p:txBody>
+      </p:sp>
+      <p:sp>
+        <p:nvSpPr>
+          <p:cNvPr id="5" name="Shape 3"/>
+          <p:cNvSpPr/>
+          <p:nvPr/>
+        </p:nvSpPr>
+        <p:spPr>
+          <a:xfrm>
+            <a:off x="9144000" y="914400"/>
+            <a:ext cx="8229600" cy="7848600"/>
+          </a:xfrm>
+          <a:prstGeom prst="roundRect">
+            <a:avLst>
+              <a:gd name="adj" fmla="val 3398"/>
+            </a:avLst>
+          </a:prstGeom>
+          <a:solidFill>
+            <a:srgbClr val="FBF8F2"/>
+          </a:solidFill>
+          <a:ln w="19050">
+            <a:solidFill>
+              <a:srgbClr val="DDD5C1"/>
+            </a:solidFill>
+            <a:prstDash val="solid"/>
+          </a:ln>
+        </p:spPr>
+      </p:sp>
+      <p:sp>
+        <p:nvSpPr>
+          <p:cNvPr id="6" name="Text 4"/>
+          <p:cNvSpPr/>
+          <p:nvPr/>
+        </p:nvSpPr>
+        <p:spPr>
+          <a:xfrm>
+            <a:off x="9525000" y="1428750"/>
+            <a:ext cx="7467600" cy="342900"/>
+          </a:xfrm>
+          <a:prstGeom prst="rect">
+            <a:avLst/>
+          </a:prstGeom>
+          <a:noFill/>
+          <a:ln/>
+        </p:spPr>
+        <p:txBody>
+          <a:bodyPr wrap="square" lIns="0" tIns="0" rIns="0" bIns="0" rtlCol="0" anchor="t"/>
+          <a:lstStyle/>
+          <a:p>
+            <a:pPr algn="l" indent="0" marL="0">
+              <a:buNone/>
+            </a:pPr>
+            <a:r>
+              <a:rPr lang="en-US" sz="1950" b="1" spc="200" kern="0" dirty="0">
+                <a:solidFill>
+                  <a:srgbClr val="E8472B"/>
+                </a:solidFill>
+                <a:latin typeface="Be Vietnam Pro" pitchFamily="34" charset="0"/>
+                <a:ea typeface="Be Vietnam Pro" pitchFamily="34" charset="-122"/>
+                <a:cs typeface="Be Vietnam Pro" pitchFamily="34" charset="-120"/>
+              </a:rPr>
+              <a:t>ĐÁP</a:t>
+            </a:r>
+            <a:r>
+              <a:rPr lang="en-US" sz="1950" b="1" spc="223" kern="0" dirty="0">
+                <a:solidFill>
+                  <a:srgbClr val="E8472B"/>
+                </a:solidFill>
+                <a:latin typeface="Be Vietnam Pro" pitchFamily="34" charset="0"/>
+                <a:ea typeface="Be Vietnam Pro" pitchFamily="34" charset="-122"/>
+                <a:cs typeface="Be Vietnam Pro" pitchFamily="34" charset="-120"/>
+              </a:rPr>
+              <a:t> ÁN</a:t>
+            </a:r>
+            <a:endParaRPr lang="en-US" sz="1950" dirty="0"/>
+          </a:p>
+        </p:txBody>
+      </p:sp>
+      <p:sp>
+        <p:nvSpPr>
+          <p:cNvPr id="7" name="Shape 5"/>
+          <p:cNvSpPr/>
+          <p:nvPr/>
+        </p:nvSpPr>
+        <p:spPr>
+          <a:xfrm>
+            <a:off x="9525000" y="2190750"/>
+            <a:ext cx="7467600" cy="1809750"/>
+          </a:xfrm>
+          <a:prstGeom prst="roundRect">
+            <a:avLst>
+              <a:gd name="adj" fmla="val 12632"/>
+            </a:avLst>
+          </a:prstGeom>
+          <a:solidFill>
+            <a:srgbClr val="FFFFFF"/>
+          </a:solidFill>
+          <a:ln w="28575">
+            <a:solidFill>
+              <a:srgbClr val="0F766E"/>
+            </a:solidFill>
+            <a:prstDash val="solid"/>
+          </a:ln>
+        </p:spPr>
+      </p:sp>
+      <p:sp>
+        <p:nvSpPr>
+          <p:cNvPr id="8" name="Text 6"/>
+          <p:cNvSpPr/>
+          <p:nvPr/>
+        </p:nvSpPr>
+        <p:spPr>
+          <a:xfrm>
+            <a:off x="9810750" y="2847975"/>
+            <a:ext cx="609600" cy="609600"/>
+          </a:xfrm>
+          <a:prstGeom prst="roundRect">
+            <a:avLst>
+              <a:gd name="adj" fmla="val 50000"/>
+            </a:avLst>
+          </a:prstGeom>
+          <a:solidFill>
+            <a:srgbClr val="0F766E"/>
+          </a:solidFill>
+          <a:ln/>
+        </p:spPr>
+        <p:txBody>
+          <a:bodyPr wrap="square" lIns="0" tIns="0" rIns="0" bIns="0" rtlCol="0" anchor="ctr"/>
+          <a:lstStyle/>
+          <a:p>
+            <a:pPr algn="ctr" indent="0" marL="0">
+              <a:buNone/>
+            </a:pPr>
+            <a:r>
+              <a:rPr lang="en-US" sz="2550" b="1" dirty="0" spc="-1" kern="0">
+                <a:solidFill>
+                  <a:srgbClr val="F3EEE3"/>
+                </a:solidFill>
+                <a:latin typeface="Be Vietnam Pro" pitchFamily="34" charset="0"/>
+                <a:ea typeface="Be Vietnam Pro" pitchFamily="34" charset="-122"/>
+                <a:cs typeface="Be Vietnam Pro" pitchFamily="34" charset="-120"/>
+              </a:rPr>
+              <a:t>1</a:t>
+            </a:r>
+            <a:endParaRPr lang="en-US" sz="2550" dirty="0"/>
+          </a:p>
+        </p:txBody>
+      </p:sp>
+      <p:sp>
+        <p:nvSpPr>
+          <p:cNvPr id="9" name="Shape 7"/>
+          <p:cNvSpPr/>
+          <p:nvPr/>
+        </p:nvSpPr>
+        <p:spPr>
+          <a:xfrm>
+            <a:off x="9525000" y="4286250"/>
+            <a:ext cx="7467600" cy="1809750"/>
+          </a:xfrm>
+          <a:prstGeom prst="roundRect">
+            <a:avLst>
+              <a:gd name="adj" fmla="val 12632"/>
+            </a:avLst>
+          </a:prstGeom>
+          <a:solidFill>
+            <a:srgbClr val="FFFFFF"/>
+          </a:solidFill>
+          <a:ln w="28575">
+            <a:solidFill>
+              <a:srgbClr val="1F3FD1"/>
+            </a:solidFill>
+            <a:prstDash val="solid"/>
+          </a:ln>
+        </p:spPr>
+      </p:sp>
+      <p:sp>
+        <p:nvSpPr>
+          <p:cNvPr id="10" name="Text 8"/>
+          <p:cNvSpPr/>
+          <p:nvPr/>
+        </p:nvSpPr>
+        <p:spPr>
+          <a:xfrm>
+            <a:off x="9810750" y="4943475"/>
+            <a:ext cx="609600" cy="609600"/>
+          </a:xfrm>
+          <a:prstGeom prst="roundRect">
+            <a:avLst>
+              <a:gd name="adj" fmla="val 50000"/>
+            </a:avLst>
+          </a:prstGeom>
+          <a:solidFill>
+            <a:srgbClr val="1F3FD1"/>
+          </a:solidFill>
+          <a:ln/>
+        </p:spPr>
+        <p:txBody>
+          <a:bodyPr wrap="square" lIns="0" tIns="0" rIns="0" bIns="0" rtlCol="0" anchor="ctr"/>
+          <a:lstStyle/>
+          <a:p>
+            <a:pPr algn="ctr" indent="0" marL="0">
+              <a:buNone/>
+            </a:pPr>
+            <a:r>
+              <a:rPr lang="en-US" sz="2550" b="1" dirty="0" spc="6" kern="0">
+                <a:solidFill>
+                  <a:srgbClr val="F3EEE3"/>
+                </a:solidFill>
+                <a:latin typeface="Be Vietnam Pro" pitchFamily="34" charset="0"/>
+                <a:ea typeface="Be Vietnam Pro" pitchFamily="34" charset="-122"/>
+                <a:cs typeface="Be Vietnam Pro" pitchFamily="34" charset="-120"/>
+              </a:rPr>
+              <a:t>2</a:t>
+            </a:r>
+            <a:endParaRPr lang="en-US" sz="2550" dirty="0"/>
+          </a:p>
+        </p:txBody>
+      </p:sp>
+      <p:sp>
+        <p:nvSpPr>
+          <p:cNvPr id="11" name="Text 9"/>
+          <p:cNvSpPr/>
+          <p:nvPr/>
+        </p:nvSpPr>
+        <p:spPr>
+          <a:xfrm>
+            <a:off x="10687050" y="4476750"/>
+            <a:ext cx="6096000" cy="1428750"/>
+          </a:xfrm>
+          <a:prstGeom prst="rect">
+            <a:avLst/>
+          </a:prstGeom>
+          <a:noFill/>
+          <a:ln/>
+        </p:spPr>
+        <p:txBody>
+          <a:bodyPr wrap="square" lIns="0" tIns="9700" rIns="0" bIns="-9700" rtlCol="0" anchor="ctr"/>
+          <a:lstStyle/>
+          <a:p>
+            <a:pPr algn="l" indent="0" marL="0">
+              <a:lnSpc>
+                <a:spcPts val="3443"/>
+              </a:lnSpc>
+              <a:buNone/>
+            </a:pPr>
+            <a:r>
+              <a:rPr lang="en-US" sz="2550" dirty="0" spc="-42" kern="0">
+                <a:solidFill>
+                  <a:srgbClr val="14161C"/>
+                </a:solidFill>
+                <a:latin typeface="Be Vietnam Pro" pitchFamily="34" charset="0"/>
+                <a:ea typeface="Be Vietnam Pro" pitchFamily="34" charset="-122"/>
+                <a:cs typeface="Be Vietnam Pro" pitchFamily="34" charset="-120"/>
+              </a:rPr>
+              <a:t>Rồi</a:t>
+            </a:r>
+            <a:r>
+              <a:rPr lang="en-US" sz="2550" dirty="0" spc="-12" kern="0">
+                <a:solidFill>
+                  <a:srgbClr val="14161C"/>
+                </a:solidFill>
+                <a:latin typeface="Be Vietnam Pro" pitchFamily="34" charset="0"/>
+                <a:ea typeface="Be Vietnam Pro" pitchFamily="34" charset="-122"/>
+                <a:cs typeface="Be Vietnam Pro" pitchFamily="34" charset="-120"/>
+              </a:rPr>
+              <a:t> tới</a:t>
+            </a:r>
+            <a:r>
+              <a:rPr lang="en-US" sz="2550" dirty="0" spc="-9" kern="0">
+                <a:solidFill>
+                  <a:srgbClr val="14161C"/>
+                </a:solidFill>
+                <a:latin typeface="Be Vietnam Pro" pitchFamily="34" charset="0"/>
+                <a:ea typeface="Be Vietnam Pro" pitchFamily="34" charset="-122"/>
+                <a:cs typeface="Be Vietnam Pro" pitchFamily="34" charset="-120"/>
+              </a:rPr>
+              <a:t> máy</a:t>
+            </a:r>
+            <a:r>
+              <a:rPr lang="en-US" sz="2550" dirty="0" spc="-2" kern="0">
+                <a:solidFill>
+                  <a:srgbClr val="14161C"/>
+                </a:solidFill>
+                <a:latin typeface="Be Vietnam Pro" pitchFamily="34" charset="0"/>
+                <a:ea typeface="Be Vietnam Pro" pitchFamily="34" charset="-122"/>
+                <a:cs typeface="Be Vietnam Pro" pitchFamily="34" charset="-120"/>
+              </a:rPr>
+              <a:t> chủ</a:t>
+            </a:r>
+            <a:r>
+              <a:rPr lang="en-US" sz="2550" dirty="0" spc="-9" kern="0">
+                <a:solidFill>
+                  <a:srgbClr val="14161C"/>
+                </a:solidFill>
+                <a:latin typeface="Be Vietnam Pro" pitchFamily="34" charset="0"/>
+                <a:ea typeface="Be Vietnam Pro" pitchFamily="34" charset="-122"/>
+                <a:cs typeface="Be Vietnam Pro" pitchFamily="34" charset="-120"/>
+              </a:rPr>
+              <a:t> web,</a:t>
+            </a:r>
+            <a:r>
+              <a:rPr lang="en-US" sz="2550" dirty="0" spc="0" kern="0">
+                <a:solidFill>
+                  <a:srgbClr val="14161C"/>
+                </a:solidFill>
+                <a:latin typeface="Be Vietnam Pro" pitchFamily="34" charset="0"/>
+                <a:ea typeface="Be Vietnam Pro" pitchFamily="34" charset="-122"/>
+                <a:cs typeface="Be Vietnam Pro" pitchFamily="34" charset="-120"/>
+              </a:rPr>
+              <a:t> có</a:t>
+            </a:r>
+            <a:r>
+              <a:rPr lang="en-US" sz="2550" dirty="0" spc="1" kern="0">
+                <a:solidFill>
+                  <a:srgbClr val="14161C"/>
+                </a:solidFill>
+                <a:latin typeface="Be Vietnam Pro" pitchFamily="34" charset="0"/>
+                <a:ea typeface="Be Vietnam Pro" pitchFamily="34" charset="-122"/>
+                <a:cs typeface="Be Vietnam Pro" pitchFamily="34" charset="-120"/>
+              </a:rPr>
+              <a:t> thể qua</a:t>
+            </a:r>
+            <a:r>
+              <a:rPr lang="en-US" sz="2550" dirty="0" spc="-25" kern="0">
+                <a:solidFill>
+                  <a:srgbClr val="14161C"/>
+                </a:solidFill>
+                <a:latin typeface="Be Vietnam Pro" pitchFamily="34" charset="0"/>
+                <a:ea typeface="Be Vietnam Pro" pitchFamily="34" charset="-122"/>
+                <a:cs typeface="Be Vietnam Pro" pitchFamily="34" charset="-120"/>
+              </a:rPr>
+              <a:t> proxy.</a:t>
+            </a:r>
+            <a:endParaRPr lang="en-US" sz="2550" dirty="0"/>
+          </a:p>
+        </p:txBody>
+      </p:sp>
+      <p:sp>
+        <p:nvSpPr>
+          <p:cNvPr id="12" name="Shape 10"/>
+          <p:cNvSpPr/>
+          <p:nvPr/>
+        </p:nvSpPr>
+        <p:spPr>
+          <a:xfrm>
+            <a:off x="9525000" y="6381750"/>
+            <a:ext cx="7467600" cy="1809750"/>
+          </a:xfrm>
+          <a:prstGeom prst="roundRect">
+            <a:avLst>
+              <a:gd name="adj" fmla="val 12632"/>
+            </a:avLst>
+          </a:prstGeom>
+          <a:solidFill>
+            <a:srgbClr val="FFFFFF"/>
+          </a:solidFill>
+          <a:ln w="28575">
+            <a:solidFill>
+              <a:srgbClr val="1F3FD1"/>
+            </a:solidFill>
+            <a:prstDash val="solid"/>
+          </a:ln>
+        </p:spPr>
+      </p:sp>
+      <p:sp>
+        <p:nvSpPr>
+          <p:cNvPr id="13" name="Text 11"/>
+          <p:cNvSpPr/>
+          <p:nvPr/>
+        </p:nvSpPr>
+        <p:spPr>
+          <a:xfrm>
+            <a:off x="9810750" y="7038975"/>
+            <a:ext cx="609600" cy="609600"/>
+          </a:xfrm>
+          <a:prstGeom prst="roundRect">
+            <a:avLst>
+              <a:gd name="adj" fmla="val 50000"/>
+            </a:avLst>
+          </a:prstGeom>
+          <a:solidFill>
+            <a:srgbClr val="1F3FD1"/>
+          </a:solidFill>
+          <a:ln/>
+        </p:spPr>
+        <p:txBody>
+          <a:bodyPr wrap="square" lIns="0" tIns="0" rIns="0" bIns="0" rtlCol="0" anchor="ctr"/>
+          <a:lstStyle/>
+          <a:p>
+            <a:pPr algn="ctr" indent="0" marL="0">
+              <a:buNone/>
+            </a:pPr>
+            <a:r>
+              <a:rPr lang="en-US" sz="2550" b="1" dirty="0" spc="-4" kern="0">
+                <a:solidFill>
+                  <a:srgbClr val="F3EEE3"/>
+                </a:solidFill>
+                <a:latin typeface="Be Vietnam Pro" pitchFamily="34" charset="0"/>
+                <a:ea typeface="Be Vietnam Pro" pitchFamily="34" charset="-122"/>
+                <a:cs typeface="Be Vietnam Pro" pitchFamily="34" charset="-120"/>
+              </a:rPr>
+              <a:t>3</a:t>
+            </a:r>
+            <a:endParaRPr lang="en-US" sz="2550" dirty="0"/>
+          </a:p>
+        </p:txBody>
+      </p:sp>
+      <p:sp>
+        <p:nvSpPr>
+          <p:cNvPr id="14" name="Text 12"/>
+          <p:cNvSpPr/>
+          <p:nvPr/>
+        </p:nvSpPr>
+        <p:spPr>
+          <a:xfrm>
+            <a:off x="10687050" y="6572250"/>
+            <a:ext cx="6096000" cy="1428750"/>
+          </a:xfrm>
+          <a:prstGeom prst="rect">
+            <a:avLst/>
+          </a:prstGeom>
+          <a:noFill/>
+          <a:ln/>
+        </p:spPr>
+        <p:txBody>
+          <a:bodyPr wrap="square" lIns="0" tIns="9700" rIns="0" bIns="-9700" rtlCol="0" anchor="ctr"/>
+          <a:lstStyle/>
+          <a:p>
+            <a:pPr algn="l" indent="0" marL="0">
+              <a:lnSpc>
+                <a:spcPts val="3443"/>
+              </a:lnSpc>
+              <a:buNone/>
+            </a:pPr>
+            <a:r>
+              <a:rPr lang="en-US" sz="2550" dirty="0" spc="1" kern="0">
+                <a:solidFill>
+                  <a:srgbClr val="14161C"/>
+                </a:solidFill>
+                <a:latin typeface="Be Vietnam Pro" pitchFamily="34" charset="0"/>
+                <a:ea typeface="Be Vietnam Pro" pitchFamily="34" charset="-122"/>
+                <a:cs typeface="Be Vietnam Pro" pitchFamily="34" charset="-120"/>
+              </a:rPr>
+              <a:t>Có</a:t>
+            </a:r>
+            <a:r>
+              <a:rPr lang="en-US" sz="2550" dirty="0" spc="-3" kern="0">
+                <a:solidFill>
+                  <a:srgbClr val="14161C"/>
+                </a:solidFill>
+                <a:latin typeface="Be Vietnam Pro" pitchFamily="34" charset="0"/>
+                <a:ea typeface="Be Vietnam Pro" pitchFamily="34" charset="-122"/>
+                <a:cs typeface="Be Vietnam Pro" pitchFamily="34" charset="-120"/>
+              </a:rPr>
+              <a:t> bản</a:t>
+            </a:r>
+            <a:r>
+              <a:rPr lang="en-US" sz="2550" dirty="0" spc="-1" kern="0">
+                <a:solidFill>
+                  <a:srgbClr val="14161C"/>
+                </a:solidFill>
+                <a:latin typeface="Be Vietnam Pro" pitchFamily="34" charset="0"/>
+                <a:ea typeface="Be Vietnam Pro" pitchFamily="34" charset="-122"/>
+                <a:cs typeface="Be Vietnam Pro" pitchFamily="34" charset="-120"/>
+              </a:rPr>
+              <a:t> ở</a:t>
+            </a:r>
+            <a:r>
+              <a:rPr lang="en-US" sz="2550" dirty="0" spc="-9" kern="0">
+                <a:solidFill>
+                  <a:srgbClr val="14161C"/>
+                </a:solidFill>
+                <a:latin typeface="Be Vietnam Pro" pitchFamily="34" charset="0"/>
+                <a:ea typeface="Be Vietnam Pro" pitchFamily="34" charset="-122"/>
+                <a:cs typeface="Be Vietnam Pro" pitchFamily="34" charset="-120"/>
+              </a:rPr>
+              <a:t> máy</a:t>
+            </a:r>
+            <a:r>
+              <a:rPr lang="en-US" sz="2550" dirty="0" spc="-1" kern="0">
+                <a:solidFill>
+                  <a:srgbClr val="14161C"/>
+                </a:solidFill>
+                <a:latin typeface="Be Vietnam Pro" pitchFamily="34" charset="0"/>
+                <a:ea typeface="Be Vietnam Pro" pitchFamily="34" charset="-122"/>
+                <a:cs typeface="Be Vietnam Pro" pitchFamily="34" charset="-120"/>
+              </a:rPr>
+              <a:t> chủ biên</a:t>
+            </a:r>
+            <a:r>
+              <a:rPr lang="en-US" sz="2550" dirty="0" spc="2" kern="0">
+                <a:solidFill>
+                  <a:srgbClr val="14161C"/>
+                </a:solidFill>
+                <a:latin typeface="Be Vietnam Pro" pitchFamily="34" charset="0"/>
+                <a:ea typeface="Be Vietnam Pro" pitchFamily="34" charset="-122"/>
+                <a:cs typeface="Be Vietnam Pro" pitchFamily="34" charset="-120"/>
+              </a:rPr>
+              <a:t> thì</a:t>
+            </a:r>
+            <a:r>
+              <a:rPr lang="en-US" sz="2550" dirty="0" spc="0" kern="0">
+                <a:solidFill>
+                  <a:srgbClr val="14161C"/>
+                </a:solidFill>
+                <a:latin typeface="Be Vietnam Pro" pitchFamily="34" charset="0"/>
+                <a:ea typeface="Be Vietnam Pro" pitchFamily="34" charset="-122"/>
+                <a:cs typeface="Be Vietnam Pro" pitchFamily="34" charset="-120"/>
+              </a:rPr>
+              <a:t> nhận</a:t>
+            </a:r>
+            <a:r>
+              <a:rPr lang="en-US" sz="2550" dirty="0" spc="-2" kern="0">
+                <a:solidFill>
+                  <a:srgbClr val="14161C"/>
+                </a:solidFill>
+                <a:latin typeface="Be Vietnam Pro" pitchFamily="34" charset="0"/>
+                <a:ea typeface="Be Vietnam Pro" pitchFamily="34" charset="-122"/>
+                <a:cs typeface="Be Vietnam Pro" pitchFamily="34" charset="-120"/>
+              </a:rPr>
+              <a:t> từ</a:t>
+            </a:r>
+            <a:r>
+              <a:rPr lang="en-US" sz="2550" dirty="0" spc="14" kern="0">
+                <a:solidFill>
+                  <a:srgbClr val="14161C"/>
+                </a:solidFill>
+                <a:latin typeface="Be Vietnam Pro" pitchFamily="34" charset="0"/>
+                <a:ea typeface="Be Vietnam Pro" pitchFamily="34" charset="-122"/>
+                <a:cs typeface="Be Vietnam Pro" pitchFamily="34" charset="-120"/>
+              </a:rPr>
+              <a:t> đó.</a:t>
+            </a:r>
+            <a:endParaRPr lang="en-US" sz="2550" dirty="0"/>
+          </a:p>
+        </p:txBody>
+      </p:sp>
+      <p:sp>
+        <p:nvSpPr>
+          <p:cNvPr id="15" name="Shape 13"/>
+          <p:cNvSpPr/>
+          <p:nvPr/>
+        </p:nvSpPr>
+        <p:spPr>
+          <a:xfrm>
+            <a:off x="981075" y="9439275"/>
+            <a:ext cx="133350" cy="133350"/>
+          </a:xfrm>
+          <a:prstGeom prst="ellipse">
+            <a:avLst/>
+          </a:prstGeom>
+          <a:solidFill>
+            <a:srgbClr val="14161C"/>
+          </a:solidFill>
+          <a:ln w="19050">
+            <a:solidFill>
+              <a:srgbClr val="14161C"/>
+            </a:solidFill>
+            <a:prstDash val="solid"/>
+          </a:ln>
+        </p:spPr>
+      </p:sp>
+      <p:sp>
+        <p:nvSpPr>
+          <p:cNvPr id="16" name="Shape 14"/>
+          <p:cNvSpPr/>
+          <p:nvPr/>
+        </p:nvSpPr>
+        <p:spPr>
+          <a:xfrm>
+            <a:off x="1323975" y="9439275"/>
+            <a:ext cx="133350" cy="133350"/>
+          </a:xfrm>
+          <a:prstGeom prst="ellipse">
+            <a:avLst/>
+          </a:prstGeom>
+          <a:solidFill>
+            <a:srgbClr val="14161C"/>
+          </a:solidFill>
+          <a:ln w="19050">
+            <a:solidFill>
+              <a:srgbClr val="14161C"/>
+            </a:solidFill>
+            <a:prstDash val="solid"/>
+          </a:ln>
+        </p:spPr>
+      </p:sp>
+      <p:sp>
+        <p:nvSpPr>
+          <p:cNvPr id="17" name="Shape 15"/>
+          <p:cNvSpPr/>
+          <p:nvPr/>
+        </p:nvSpPr>
+        <p:spPr>
+          <a:xfrm>
+            <a:off x="1666875" y="9439275"/>
+            <a:ext cx="133350" cy="133350"/>
+          </a:xfrm>
+          <a:prstGeom prst="ellipse">
+            <a:avLst/>
+          </a:prstGeom>
+          <a:solidFill>
+            <a:srgbClr val="14161C"/>
+          </a:solidFill>
+          <a:ln w="19050">
+            <a:solidFill>
+              <a:srgbClr val="14161C"/>
+            </a:solidFill>
+            <a:prstDash val="solid"/>
+          </a:ln>
+        </p:spPr>
+      </p:sp>
+      <p:sp>
+        <p:nvSpPr>
+          <p:cNvPr id="18" name="Shape 16"/>
+          <p:cNvSpPr/>
+          <p:nvPr/>
+        </p:nvSpPr>
+        <p:spPr>
+          <a:xfrm>
+            <a:off x="2009775" y="9439275"/>
+            <a:ext cx="133350" cy="133350"/>
+          </a:xfrm>
+          <a:prstGeom prst="ellipse">
+            <a:avLst/>
+          </a:prstGeom>
+          <a:solidFill>
+            <a:srgbClr val="14161C"/>
+          </a:solidFill>
+          <a:ln w="19050">
+            <a:solidFill>
+              <a:srgbClr val="14161C"/>
+            </a:solidFill>
+            <a:prstDash val="solid"/>
+          </a:ln>
+        </p:spPr>
+      </p:sp>
+      <p:sp>
+        <p:nvSpPr>
+          <p:cNvPr id="19" name="Shape 17"/>
+          <p:cNvSpPr/>
+          <p:nvPr/>
+        </p:nvSpPr>
+        <p:spPr>
+          <a:xfrm>
+            <a:off x="2352675" y="9439275"/>
+            <a:ext cx="133350" cy="133350"/>
+          </a:xfrm>
+          <a:prstGeom prst="ellipse">
+            <a:avLst/>
+          </a:prstGeom>
+          <a:solidFill>
+            <a:srgbClr val="14161C"/>
+          </a:solidFill>
+          <a:ln w="19050">
+            <a:solidFill>
+              <a:srgbClr val="14161C"/>
+            </a:solidFill>
+            <a:prstDash val="solid"/>
+          </a:ln>
+        </p:spPr>
+      </p:sp>
+      <p:sp>
+        <p:nvSpPr>
+          <p:cNvPr id="20" name="Shape 18"/>
+          <p:cNvSpPr/>
+          <p:nvPr/>
+        </p:nvSpPr>
+        <p:spPr>
+          <a:xfrm>
+            <a:off x="2695575" y="9439275"/>
+            <a:ext cx="133350" cy="133350"/>
+          </a:xfrm>
+          <a:prstGeom prst="ellipse">
+            <a:avLst/>
+          </a:prstGeom>
+          <a:solidFill>
+            <a:srgbClr val="14161C"/>
+          </a:solidFill>
+          <a:ln w="19050">
+            <a:solidFill>
+              <a:srgbClr val="14161C"/>
+            </a:solidFill>
+            <a:prstDash val="solid"/>
+          </a:ln>
+        </p:spPr>
+      </p:sp>
+      <p:sp>
+        <p:nvSpPr>
+          <p:cNvPr id="21" name="Shape 19"/>
+          <p:cNvSpPr/>
+          <p:nvPr/>
+        </p:nvSpPr>
+        <p:spPr>
+          <a:xfrm>
+            <a:off x="3038475" y="9439275"/>
+            <a:ext cx="133350" cy="133350"/>
+          </a:xfrm>
+          <a:prstGeom prst="ellipse">
+            <a:avLst/>
+          </a:prstGeom>
+          <a:solidFill>
+            <a:srgbClr val="14161C"/>
+          </a:solidFill>
+          <a:ln w="19050">
+            <a:solidFill>
+              <a:srgbClr val="14161C"/>
+            </a:solidFill>
+            <a:prstDash val="solid"/>
+          </a:ln>
+        </p:spPr>
+      </p:sp>
+      <p:sp>
+        <p:nvSpPr>
+          <p:cNvPr id="22" name="Shape 20"/>
+          <p:cNvSpPr/>
+          <p:nvPr/>
+        </p:nvSpPr>
+        <p:spPr>
+          <a:xfrm>
+            <a:off x="3381375" y="9439275"/>
+            <a:ext cx="133350" cy="133350"/>
+          </a:xfrm>
+          <a:prstGeom prst="ellipse">
+            <a:avLst/>
+          </a:prstGeom>
+          <a:solidFill>
+            <a:srgbClr val="14161C"/>
+          </a:solidFill>
+          <a:ln w="19050">
+            <a:solidFill>
+              <a:srgbClr val="14161C"/>
+            </a:solidFill>
+            <a:prstDash val="solid"/>
+          </a:ln>
+        </p:spPr>
+      </p:sp>
+      <p:sp>
+        <p:nvSpPr>
+          <p:cNvPr id="23" name="Shape 21"/>
+          <p:cNvSpPr/>
+          <p:nvPr/>
+        </p:nvSpPr>
+        <p:spPr>
+          <a:xfrm>
+            <a:off x="3724275" y="9439275"/>
+            <a:ext cx="133350" cy="133350"/>
+          </a:xfrm>
+          <a:prstGeom prst="ellipse">
+            <a:avLst/>
+          </a:prstGeom>
+          <a:solidFill>
+            <a:srgbClr val="E8472B"/>
+          </a:solidFill>
+          <a:ln w="19050">
+            <a:solidFill>
+              <a:srgbClr val="E8472B"/>
+            </a:solidFill>
+            <a:prstDash val="solid"/>
+          </a:ln>
+        </p:spPr>
+      </p:sp>
+      <p:sp>
+        <p:nvSpPr>
+          <p:cNvPr id="24" name="Shape 22"/>
+          <p:cNvSpPr/>
+          <p:nvPr/>
+        </p:nvSpPr>
+        <p:spPr>
+          <a:xfrm>
+            <a:off x="4067175" y="9439275"/>
+            <a:ext cx="133350" cy="133350"/>
+          </a:xfrm>
+          <a:prstGeom prst="ellipse">
+            <a:avLst/>
+          </a:prstGeom>
+          <a:solidFill>
+            <a:srgbClr val="F3EEE3"/>
+          </a:solidFill>
+          <a:ln w="19050">
+            <a:solidFill>
+              <a:srgbClr val="6B6A66"/>
+            </a:solidFill>
+            <a:prstDash val="solid"/>
+          </a:ln>
+        </p:spPr>
+      </p:sp>
+      <p:sp>
+        <p:nvSpPr>
+          <p:cNvPr id="25" name="Text 23"/>
+          <p:cNvSpPr/>
+          <p:nvPr/>
+        </p:nvSpPr>
+        <p:spPr>
+          <a:xfrm>
+            <a:off x="914400" y="9696450"/>
+            <a:ext cx="7620000" cy="323850"/>
+          </a:xfrm>
+          <a:prstGeom prst="rect">
+            <a:avLst/>
+          </a:prstGeom>
+          <a:noFill/>
+          <a:ln/>
+        </p:spPr>
+        <p:txBody>
+          <a:bodyPr wrap="square" lIns="0" tIns="0" rIns="0" bIns="0" rtlCol="0" anchor="t"/>
+          <a:lstStyle/>
+          <a:p>
+            <a:pPr algn="l" indent="0" marL="0">
+              <a:buNone/>
+            </a:pPr>
+            <a:r>
+              <a:rPr lang="en-US" sz="1650" dirty="0" spc="-12" kern="0">
+                <a:solidFill>
+                  <a:srgbClr val="6B6A66"/>
+                </a:solidFill>
+                <a:latin typeface="Be Vietnam Pro" pitchFamily="34" charset="0"/>
+                <a:ea typeface="Be Vietnam Pro" pitchFamily="34" charset="-122"/>
+                <a:cs typeface="Be Vietnam Pro" pitchFamily="34" charset="-120"/>
+              </a:rPr>
+              <a:t>System</a:t>
+            </a:r>
+            <a:r>
+              <a:rPr lang="en-US" sz="1650" dirty="0" spc="0" kern="0">
+                <a:solidFill>
+                  <a:srgbClr val="6B6A66"/>
+                </a:solidFill>
+                <a:latin typeface="Be Vietnam Pro" pitchFamily="34" charset="0"/>
+                <a:ea typeface="Be Vietnam Pro" pitchFamily="34" charset="-122"/>
+                <a:cs typeface="Be Vietnam Pro" pitchFamily="34" charset="-120"/>
+              </a:rPr>
+              <a:t> Design</a:t>
+            </a:r>
+            <a:r>
+              <a:rPr lang="en-US" sz="1650" dirty="0" spc="1" kern="0">
+                <a:solidFill>
+                  <a:srgbClr val="6B6A66"/>
+                </a:solidFill>
+                <a:latin typeface="Be Vietnam Pro" pitchFamily="34" charset="0"/>
+                <a:ea typeface="Be Vietnam Pro" pitchFamily="34" charset="-122"/>
+                <a:cs typeface="Be Vietnam Pro" pitchFamily="34" charset="-120"/>
+              </a:rPr>
+              <a:t> 101</a:t>
+            </a:r>
+            <a:r>
+              <a:rPr lang="en-US" sz="1650" dirty="0" spc="0" kern="0">
+                <a:solidFill>
+                  <a:srgbClr val="6B6A66"/>
+                </a:solidFill>
+                <a:latin typeface="Be Vietnam Pro" pitchFamily="34" charset="0"/>
+                <a:ea typeface="Be Vietnam Pro" pitchFamily="34" charset="-122"/>
+                <a:cs typeface="Be Vietnam Pro" pitchFamily="34" charset="-120"/>
+              </a:rPr>
+              <a:t> ·</a:t>
+            </a:r>
+            <a:r>
+              <a:rPr lang="en-US" sz="1650" dirty="0" spc="1" kern="0">
+                <a:solidFill>
+                  <a:srgbClr val="6B6A66"/>
+                </a:solidFill>
+                <a:latin typeface="Be Vietnam Pro" pitchFamily="34" charset="0"/>
+                <a:ea typeface="Be Vietnam Pro" pitchFamily="34" charset="-122"/>
+                <a:cs typeface="Be Vietnam Pro" pitchFamily="34" charset="-120"/>
+              </a:rPr>
+              <a:t> Bài</a:t>
+            </a:r>
+            <a:r>
+              <a:rPr lang="en-US" sz="1650" dirty="0" spc="2" kern="0">
+                <a:solidFill>
+                  <a:srgbClr val="6B6A66"/>
+                </a:solidFill>
+                <a:latin typeface="Be Vietnam Pro" pitchFamily="34" charset="0"/>
+                <a:ea typeface="Be Vietnam Pro" pitchFamily="34" charset="-122"/>
+                <a:cs typeface="Be Vietnam Pro" pitchFamily="34" charset="-120"/>
+              </a:rPr>
+              <a:t> 01</a:t>
+            </a:r>
+            <a:r>
+              <a:rPr lang="en-US" sz="1650" dirty="0" spc="0" kern="0">
+                <a:solidFill>
+                  <a:srgbClr val="6B6A66"/>
+                </a:solidFill>
+                <a:latin typeface="Be Vietnam Pro" pitchFamily="34" charset="0"/>
+                <a:ea typeface="Be Vietnam Pro" pitchFamily="34" charset="-122"/>
+                <a:cs typeface="Be Vietnam Pro" pitchFamily="34" charset="-120"/>
+              </a:rPr>
+              <a:t> ·</a:t>
+            </a:r>
+            <a:r>
+              <a:rPr lang="en-US" sz="1650" dirty="0" spc="2" kern="0">
+                <a:solidFill>
+                  <a:srgbClr val="6B6A66"/>
+                </a:solidFill>
+                <a:latin typeface="Be Vietnam Pro" pitchFamily="34" charset="0"/>
+                <a:ea typeface="Be Vietnam Pro" pitchFamily="34" charset="-122"/>
+                <a:cs typeface="Be Vietnam Pro" pitchFamily="34" charset="-120"/>
+              </a:rPr>
+              <a:t> 09/10</a:t>
+            </a:r>
+            <a:endParaRPr lang="en-US" sz="1650" dirty="0"/>
+          </a:p>
+        </p:txBody>
+      </p:sp>
+      <p:sp>
+        <p:nvSpPr>
+          <p:cNvPr id="26" name="Text 24"/>
+          <p:cNvSpPr/>
+          <p:nvPr/>
+        </p:nvSpPr>
+        <p:spPr>
+          <a:xfrm>
             <a:off x="914400" y="3810000"/>
             <a:ext cx="7620000" cy="2190750"/>
           </a:xfrm>
@@ -18579,15 +19590,92 @@
               <a:t> website</a:t>
             </a:r>
             <a:r>
-              <a:rPr lang="en-US" sz="2850" dirty="0" spc="-12" kern="0">
-                <a:solidFill>
-                  <a:srgbClr val="14161C"/>
-                </a:solidFill>
-                <a:latin typeface="Be Vietnam Pro" pitchFamily="34" charset="0"/>
-                <a:ea typeface="Be Vietnam Pro" pitchFamily="34" charset="-122"/>
-                <a:cs typeface="Be Vietnam Pro" pitchFamily="34" charset="-120"/>
-              </a:rPr>
-              <a:t> vào</a:t>
+              <a:rPr lang="en-US" sz="2850" dirty="0" spc="0" kern="0">
+                <a:solidFill>
+                  <a:srgbClr val="14161C"/>
+                </a:solidFill>
+                <a:latin typeface="Be Vietnam Pro" pitchFamily="34" charset="0"/>
+                <a:ea typeface="Be Vietnam Pro" pitchFamily="34" charset="-122"/>
+                <a:cs typeface="Be Vietnam Pro" pitchFamily="34" charset="-120"/>
+              </a:rPr>
+              <a:t> lần</a:t>
+            </a:r>
+            <a:r>
+              <a:rPr lang="en-US" sz="2850" dirty="0" spc="12" kern="0">
+                <a:solidFill>
+                  <a:srgbClr val="14161C"/>
+                </a:solidFill>
+                <a:latin typeface="Be Vietnam Pro" pitchFamily="34" charset="0"/>
+                <a:ea typeface="Be Vietnam Pro" pitchFamily="34" charset="-122"/>
+                <a:cs typeface="Be Vietnam Pro" pitchFamily="34" charset="-120"/>
+              </a:rPr>
+              <a:t> đầu,</a:t>
+            </a:r>
+            <a:r>
+              <a:rPr lang="en-US" sz="2850" dirty="0" spc="0" kern="0">
+                <a:solidFill>
+                  <a:srgbClr val="14161C"/>
+                </a:solidFill>
+                <a:latin typeface="Be Vietnam Pro" pitchFamily="34" charset="0"/>
+                <a:ea typeface="Be Vietnam Pro" pitchFamily="34" charset="-122"/>
+                <a:cs typeface="Be Vietnam Pro" pitchFamily="34" charset="-120"/>
+              </a:rPr>
+              <a:t> khi</a:t>
+            </a:r>
+            <a:r>
+              <a:rPr lang="en-US" sz="2850" dirty="0" spc="11" kern="0">
+                <a:solidFill>
+                  <a:srgbClr val="14161C"/>
+                </a:solidFill>
+                <a:latin typeface="Be Vietnam Pro" pitchFamily="34" charset="0"/>
+                <a:ea typeface="Be Vietnam Pro" pitchFamily="34" charset="-122"/>
+                <a:cs typeface="Be Vietnam Pro" pitchFamily="34" charset="-120"/>
+              </a:rPr>
+              <a:t> chưa</a:t>
+            </a:r>
+            <a:r>
+              <a:rPr lang="en-US" sz="2850" dirty="0" spc="-1" kern="0">
+                <a:solidFill>
+                  <a:srgbClr val="14161C"/>
+                </a:solidFill>
+                <a:latin typeface="Be Vietnam Pro" pitchFamily="34" charset="0"/>
+                <a:ea typeface="Be Vietnam Pro" pitchFamily="34" charset="-122"/>
+                <a:cs typeface="Be Vietnam Pro" pitchFamily="34" charset="-120"/>
+              </a:rPr>
+              <a:t> có</a:t>
+            </a:r>
+            <a:r>
+              <a:rPr lang="en-US" sz="2850" dirty="0" spc="31" kern="0">
+                <a:solidFill>
+                  <a:srgbClr val="14161C"/>
+                </a:solidFill>
+                <a:latin typeface="Be Vietnam Pro" pitchFamily="34" charset="0"/>
+                <a:ea typeface="Be Vietnam Pro" pitchFamily="34" charset="-122"/>
+                <a:cs typeface="Be Vietnam Pro" pitchFamily="34" charset="-120"/>
+              </a:rPr>
+              <a:t> địa</a:t>
+            </a:r>
+            <a:r>
+              <a:rPr lang="en-US" sz="2850" dirty="0" spc="0" kern="0">
+                <a:solidFill>
+                  <a:srgbClr val="14161C"/>
+                </a:solidFill>
+                <a:latin typeface="Be Vietnam Pro" pitchFamily="34" charset="0"/>
+                <a:ea typeface="Be Vietnam Pro" pitchFamily="34" charset="-122"/>
+                <a:cs typeface="Be Vietnam Pro" pitchFamily="34" charset="-120"/>
+              </a:rPr>
+              <a:t> chỉ</a:t>
+            </a:r>
+            <a:r>
+              <a:rPr lang="en-US" sz="2850" dirty="0" spc="1" kern="0">
+                <a:solidFill>
+                  <a:srgbClr val="14161C"/>
+                </a:solidFill>
+                <a:latin typeface="Be Vietnam Pro" pitchFamily="34" charset="0"/>
+                <a:ea typeface="Be Vietnam Pro" pitchFamily="34" charset="-122"/>
+                <a:cs typeface="Be Vietnam Pro" pitchFamily="34" charset="-120"/>
+              </a:rPr>
+              <a:t> nào</a:t>
             </a:r>
             <a:r>
               <a:rPr lang="en-US" sz="2850" dirty="0" spc="9" kern="0">
@@ -18598,18 +19686,29 @@
                 <a:ea typeface="Be Vietnam Pro" pitchFamily="34" charset="-122"/>
                 <a:cs typeface="Be Vietnam Pro" pitchFamily="34" charset="-120"/>
               </a:rPr>
-              <a:t> trình</a:t>
-            </a:r>
-            <a:r>
-              <a:rPr lang="en-US" sz="2850" dirty="0" spc="-18" kern="0">
-                <a:solidFill>
-                  <a:srgbClr val="14161C"/>
-                </a:solidFill>
-                <a:latin typeface="Be Vietnam Pro" pitchFamily="34" charset="0"/>
-                <a:ea typeface="Be Vietnam Pro" pitchFamily="34" charset="-122"/>
-                <a:cs typeface="Be Vietnam Pro" pitchFamily="34" charset="-120"/>
-              </a:rPr>
-              <a:t> duyệt.</a:t>
+              <a:t> được</a:t>
+            </a:r>
+            <a:r>
+              <a:rPr lang="en-US" sz="2850" dirty="0" spc="-1" kern="0">
+                <a:solidFill>
+                  <a:srgbClr val="14161C"/>
+                </a:solidFill>
+                <a:latin typeface="Be Vietnam Pro" pitchFamily="34" charset="0"/>
+                <a:ea typeface="Be Vietnam Pro" pitchFamily="34" charset="-122"/>
+                <a:cs typeface="Be Vietnam Pro" pitchFamily="34" charset="-120"/>
+              </a:rPr>
+              <a:t> nhớ</a:t>
+            </a:r>
+            <a:r>
+              <a:rPr lang="en-US" sz="2850" dirty="0" spc="-6" kern="0">
+                <a:solidFill>
+                  <a:srgbClr val="14161C"/>
+                </a:solidFill>
+                <a:latin typeface="Be Vietnam Pro" pitchFamily="34" charset="0"/>
+                <a:ea typeface="Be Vietnam Pro" pitchFamily="34" charset="-122"/>
+                <a:cs typeface="Be Vietnam Pro" pitchFamily="34" charset="-120"/>
+              </a:rPr>
+              <a:t> sẵn.</a:t>
             </a:r>
             <a:r>
               <a:rPr lang="en-US" sz="2850" dirty="0" spc="-51" kern="0">
@@ -18623,7 +19722,7 @@
               <a:t> Trong</a:t>
             </a:r>
             <a:r>
-              <a:rPr lang="en-US" sz="2850" dirty="0" spc="-7" kern="0">
+              <a:rPr lang="en-US" sz="2850" dirty="0" spc="-6" kern="0">
                 <a:solidFill>
                   <a:srgbClr val="14161C"/>
                 </a:solidFill>
@@ -18642,29 +19741,7 @@
                 <a:ea typeface="Be Vietnam Pro" pitchFamily="34" charset="-122"/>
                 <a:cs typeface="Be Vietnam Pro" pitchFamily="34" charset="-120"/>
               </a:rPr>
-              <a:t> loại,</a:t>
-            </a:r>
-            <a:r>
-              <a:rPr lang="en-US" sz="2850" dirty="0" spc="-1" kern="0">
-                <a:solidFill>
-                  <a:srgbClr val="14161C"/>
-                </a:solidFill>
-                <a:latin typeface="Be Vietnam Pro" pitchFamily="34" charset="0"/>
-                <a:ea typeface="Be Vietnam Pro" pitchFamily="34" charset="-122"/>
-                <a:cs typeface="Be Vietnam Pro" pitchFamily="34" charset="-120"/>
-              </a:rPr>
-              <a:t> loại</a:t>
-            </a:r>
-            <a:r>
-              <a:rPr lang="en-US" sz="2850" dirty="0" spc="2" kern="0">
-                <a:solidFill>
-                  <a:srgbClr val="14161C"/>
-                </a:solidFill>
-                <a:latin typeface="Be Vietnam Pro" pitchFamily="34" charset="0"/>
-                <a:ea typeface="Be Vietnam Pro" pitchFamily="34" charset="-122"/>
-                <a:cs typeface="Be Vietnam Pro" pitchFamily="34" charset="-120"/>
-              </a:rPr>
-              <a:t> nào</a:t>
+              <a:t> loại, loại nào</a:t>
             </a:r>
             <a:r>
               <a:rPr lang="en-US" sz="2850" dirty="0" spc="9" kern="0">
@@ -18678,7 +19755,7 @@
               <a:t> được</a:t>
             </a:r>
             <a:r>
-              <a:rPr lang="en-US" sz="2850" dirty="0" spc="0" kern="0">
+              <a:rPr lang="en-US" sz="2850" dirty="0" spc="1" kern="0">
                 <a:solidFill>
                   <a:srgbClr val="14161C"/>
                 </a:solidFill>
@@ -18689,7 +19766,7 @@
               <a:t> hỏi</a:t>
             </a:r>
             <a:r>
-              <a:rPr lang="en-US" sz="2850" dirty="0" spc="7" kern="0">
+              <a:rPr lang="en-US" sz="2850" dirty="0" spc="6" kern="0">
                 <a:solidFill>
                   <a:srgbClr val="14161C"/>
                 </a:solidFill>
@@ -18700,7 +19777,7 @@
               <a:t> trước,</a:t>
             </a:r>
             <a:r>
-              <a:rPr lang="en-US" sz="2850" dirty="0" spc="-17" kern="0">
+              <a:rPr lang="en-US" sz="2850" dirty="0" spc="-15" kern="0">
                 <a:solidFill>
                   <a:srgbClr val="14161C"/>
                 </a:solidFill>
@@ -18749,263 +19826,7 @@
       </p:sp>
       <p:sp>
         <p:nvSpPr>
-          <p:cNvPr id="5" name="Text 3"/>
-          <p:cNvSpPr/>
-          <p:nvPr/>
-        </p:nvSpPr>
-        <p:spPr>
-          <a:xfrm>
-            <a:off x="914400" y="6667500"/>
-            <a:ext cx="5334000" cy="685800"/>
-          </a:xfrm>
-          <a:prstGeom prst="roundRect">
-            <a:avLst>
-              <a:gd name="adj" fmla="val 50000"/>
-            </a:avLst>
-          </a:prstGeom>
-          <a:solidFill>
-            <a:srgbClr val="E8472B"/>
-          </a:solidFill>
-          <a:ln/>
-        </p:spPr>
-        <p:txBody>
-          <a:bodyPr wrap="square" lIns="0" tIns="0" rIns="0" bIns="0" rtlCol="0" anchor="ctr"/>
-          <a:lstStyle/>
-          <a:p>
-            <a:pPr algn="ctr" indent="0" marL="0">
-              <a:buNone/>
-            </a:pPr>
-            <a:r>
-              <a:rPr lang="en-US" sz="2250" b="1" dirty="0" spc="5" kern="0">
-                <a:solidFill>
-                  <a:srgbClr val="F3EEE3"/>
-                </a:solidFill>
-                <a:latin typeface="Be Vietnam Pro" pitchFamily="34" charset="0"/>
-                <a:ea typeface="Be Vietnam Pro" pitchFamily="34" charset="-122"/>
-                <a:cs typeface="Be Vietnam Pro" pitchFamily="34" charset="-120"/>
-              </a:rPr>
-              <a:t>Thử</a:t>
-            </a:r>
-            <a:r>
-              <a:rPr lang="en-US" sz="2250" b="1" dirty="0" spc="-10" kern="0">
-                <a:solidFill>
-                  <a:srgbClr val="F3EEE3"/>
-                </a:solidFill>
-                <a:latin typeface="Be Vietnam Pro" pitchFamily="34" charset="0"/>
-                <a:ea typeface="Be Vietnam Pro" pitchFamily="34" charset="-122"/>
-                <a:cs typeface="Be Vietnam Pro" pitchFamily="34" charset="-120"/>
-              </a:rPr>
-              <a:t> trả</a:t>
-            </a:r>
-            <a:r>
-              <a:rPr lang="en-US" sz="2250" b="1" dirty="0" spc="4" kern="0">
-                <a:solidFill>
-                  <a:srgbClr val="F3EEE3"/>
-                </a:solidFill>
-                <a:latin typeface="Be Vietnam Pro" pitchFamily="34" charset="0"/>
-                <a:ea typeface="Be Vietnam Pro" pitchFamily="34" charset="-122"/>
-                <a:cs typeface="Be Vietnam Pro" pitchFamily="34" charset="-120"/>
-              </a:rPr>
-              <a:t> lời</a:t>
-            </a:r>
-            <a:r>
-              <a:rPr lang="en-US" sz="2250" b="1" dirty="0" spc="-8" kern="0">
-                <a:solidFill>
-                  <a:srgbClr val="F3EEE3"/>
-                </a:solidFill>
-                <a:latin typeface="Be Vietnam Pro" pitchFamily="34" charset="0"/>
-                <a:ea typeface="Be Vietnam Pro" pitchFamily="34" charset="-122"/>
-                <a:cs typeface="Be Vietnam Pro" pitchFamily="34" charset="-120"/>
-              </a:rPr>
-              <a:t> rồi</a:t>
-            </a:r>
-            <a:r>
-              <a:rPr lang="en-US" sz="2250" b="1" dirty="0" spc="-19" kern="0">
-                <a:solidFill>
-                  <a:srgbClr val="F3EEE3"/>
-                </a:solidFill>
-                <a:latin typeface="Be Vietnam Pro" pitchFamily="34" charset="0"/>
-                <a:ea typeface="Be Vietnam Pro" pitchFamily="34" charset="-122"/>
-                <a:cs typeface="Be Vietnam Pro" pitchFamily="34" charset="-120"/>
-              </a:rPr>
-              <a:t> xem</a:t>
-            </a:r>
-            <a:r>
-              <a:rPr lang="en-US" sz="2250" b="1" dirty="0" spc="10" kern="0">
-                <a:solidFill>
-                  <a:srgbClr val="F3EEE3"/>
-                </a:solidFill>
-                <a:latin typeface="Be Vietnam Pro" pitchFamily="34" charset="0"/>
-                <a:ea typeface="Be Vietnam Pro" pitchFamily="34" charset="-122"/>
-                <a:cs typeface="Be Vietnam Pro" pitchFamily="34" charset="-120"/>
-              </a:rPr>
-              <a:t> đáp</a:t>
-            </a:r>
-            <a:r>
-              <a:rPr lang="en-US" sz="2250" b="1" dirty="0" spc="3" kern="0">
-                <a:solidFill>
-                  <a:srgbClr val="F3EEE3"/>
-                </a:solidFill>
-                <a:latin typeface="Be Vietnam Pro" pitchFamily="34" charset="0"/>
-                <a:ea typeface="Be Vietnam Pro" pitchFamily="34" charset="-122"/>
-                <a:cs typeface="Be Vietnam Pro" pitchFamily="34" charset="-120"/>
-              </a:rPr>
-              <a:t> án</a:t>
-            </a:r>
-            <a:endParaRPr lang="en-US" sz="2250" dirty="0"/>
-          </a:p>
-        </p:txBody>
-      </p:sp>
-      <p:sp>
-        <p:nvSpPr>
-          <p:cNvPr id="6" name="Shape 4"/>
-          <p:cNvSpPr/>
-          <p:nvPr/>
-        </p:nvSpPr>
-        <p:spPr>
-          <a:xfrm>
-            <a:off x="9144000" y="914400"/>
-            <a:ext cx="8229600" cy="7848600"/>
-          </a:xfrm>
-          <a:prstGeom prst="roundRect">
-            <a:avLst>
-              <a:gd name="adj" fmla="val 3398"/>
-            </a:avLst>
-          </a:prstGeom>
-          <a:solidFill>
-            <a:srgbClr val="FBF8F2"/>
-          </a:solidFill>
-          <a:ln w="19050">
-            <a:solidFill>
-              <a:srgbClr val="DDD5C1"/>
-            </a:solidFill>
-            <a:prstDash val="solid"/>
-          </a:ln>
-        </p:spPr>
-      </p:sp>
-      <p:sp>
-        <p:nvSpPr>
-          <p:cNvPr id="7" name="Text 5"/>
-          <p:cNvSpPr/>
-          <p:nvPr/>
-        </p:nvSpPr>
-        <p:spPr>
-          <a:xfrm>
-            <a:off x="9525000" y="1428750"/>
-            <a:ext cx="7467600" cy="342900"/>
-          </a:xfrm>
-          <a:prstGeom prst="rect">
-            <a:avLst/>
-          </a:prstGeom>
-          <a:noFill/>
-          <a:ln/>
-        </p:spPr>
-        <p:txBody>
-          <a:bodyPr wrap="square" lIns="0" tIns="0" rIns="0" bIns="0" rtlCol="0" anchor="t"/>
-          <a:lstStyle/>
-          <a:p>
-            <a:pPr algn="l" indent="0" marL="0">
-              <a:buNone/>
-            </a:pPr>
-            <a:r>
-              <a:rPr lang="en-US" sz="1950" b="1" spc="200" kern="0" dirty="0">
-                <a:solidFill>
-                  <a:srgbClr val="E8472B"/>
-                </a:solidFill>
-                <a:latin typeface="Be Vietnam Pro" pitchFamily="34" charset="0"/>
-                <a:ea typeface="Be Vietnam Pro" pitchFamily="34" charset="-122"/>
-                <a:cs typeface="Be Vietnam Pro" pitchFamily="34" charset="-120"/>
-              </a:rPr>
-              <a:t>ĐÁP</a:t>
-            </a:r>
-            <a:r>
-              <a:rPr lang="en-US" sz="1950" b="1" spc="223" kern="0" dirty="0">
-                <a:solidFill>
-                  <a:srgbClr val="E8472B"/>
-                </a:solidFill>
-                <a:latin typeface="Be Vietnam Pro" pitchFamily="34" charset="0"/>
-                <a:ea typeface="Be Vietnam Pro" pitchFamily="34" charset="-122"/>
-                <a:cs typeface="Be Vietnam Pro" pitchFamily="34" charset="-120"/>
-              </a:rPr>
-              <a:t> ÁN</a:t>
-            </a:r>
-            <a:endParaRPr lang="en-US" sz="1950" dirty="0"/>
-          </a:p>
-        </p:txBody>
-      </p:sp>
-      <p:sp>
-        <p:nvSpPr>
-          <p:cNvPr id="8" name="Shape 6"/>
-          <p:cNvSpPr/>
-          <p:nvPr/>
-        </p:nvSpPr>
-        <p:spPr>
-          <a:xfrm>
-            <a:off x="9525000" y="2190750"/>
-            <a:ext cx="7467600" cy="1809750"/>
-          </a:xfrm>
-          <a:prstGeom prst="roundRect">
-            <a:avLst>
-              <a:gd name="adj" fmla="val 12632"/>
-            </a:avLst>
-          </a:prstGeom>
-          <a:solidFill>
-            <a:srgbClr val="FFFFFF"/>
-          </a:solidFill>
-          <a:ln w="28575">
-            <a:solidFill>
-              <a:srgbClr val="0F766E"/>
-            </a:solidFill>
-            <a:prstDash val="solid"/>
-          </a:ln>
-        </p:spPr>
-      </p:sp>
-      <p:sp>
-        <p:nvSpPr>
-          <p:cNvPr id="9" name="Text 7"/>
-          <p:cNvSpPr/>
-          <p:nvPr/>
-        </p:nvSpPr>
-        <p:spPr>
-          <a:xfrm>
-            <a:off x="9810750" y="2847975"/>
-            <a:ext cx="609600" cy="609600"/>
-          </a:xfrm>
-          <a:prstGeom prst="roundRect">
-            <a:avLst>
-              <a:gd name="adj" fmla="val 50000"/>
-            </a:avLst>
-          </a:prstGeom>
-          <a:solidFill>
-            <a:srgbClr val="0F766E"/>
-          </a:solidFill>
-          <a:ln/>
-        </p:spPr>
-        <p:txBody>
-          <a:bodyPr wrap="square" lIns="0" tIns="0" rIns="0" bIns="0" rtlCol="0" anchor="ctr"/>
-          <a:lstStyle/>
-          <a:p>
-            <a:pPr algn="ctr" indent="0" marL="0">
-              <a:buNone/>
-            </a:pPr>
-            <a:r>
-              <a:rPr lang="en-US" sz="2550" b="1" dirty="0" spc="-1" kern="0">
-                <a:solidFill>
-                  <a:srgbClr val="F3EEE3"/>
-                </a:solidFill>
-                <a:latin typeface="Be Vietnam Pro" pitchFamily="34" charset="0"/>
-                <a:ea typeface="Be Vietnam Pro" pitchFamily="34" charset="-122"/>
-                <a:cs typeface="Be Vietnam Pro" pitchFamily="34" charset="-120"/>
-              </a:rPr>
-              <a:t>1</a:t>
-            </a:r>
-            <a:endParaRPr lang="en-US" sz="2550" dirty="0"/>
-          </a:p>
-        </p:txBody>
-      </p:sp>
-      <p:sp>
-        <p:nvSpPr>
-          <p:cNvPr id="10" name="Text 8"/>
+          <p:cNvPr id="27" name="Text 25"/>
           <p:cNvSpPr/>
           <p:nvPr/>
         </p:nvSpPr>
@@ -19094,7 +19915,7 @@
                 <a:ea typeface="Be Vietnam Pro" pitchFamily="34" charset="-122"/>
                 <a:cs typeface="Be Vietnam Pro" pitchFamily="34" charset="-120"/>
               </a:rPr>
-              <a:t> chỉ IP</a:t>
+              <a:t> chỉ IP khi</a:t>
             </a:r>
             <a:r>
               <a:rPr lang="en-US" sz="2550" dirty="0" spc="6" kern="0">
@@ -19105,764 +19926,31 @@
                 <a:ea typeface="Be Vietnam Pro" pitchFamily="34" charset="-122"/>
                 <a:cs typeface="Be Vietnam Pro" pitchFamily="34" charset="-120"/>
               </a:rPr>
-              <a:t> trước.</a:t>
+              <a:t> chưa</a:t>
+            </a:r>
+            <a:r>
+              <a:rPr lang="en-US" sz="2550" dirty="0" spc="0" kern="0">
+                <a:solidFill>
+                  <a:srgbClr val="14161C"/>
+                </a:solidFill>
+                <a:latin typeface="Be Vietnam Pro" pitchFamily="34" charset="0"/>
+                <a:ea typeface="Be Vietnam Pro" pitchFamily="34" charset="-122"/>
+                <a:cs typeface="Be Vietnam Pro" pitchFamily="34" charset="-120"/>
+              </a:rPr>
+              <a:t> có</a:t>
+            </a:r>
+            <a:r>
+              <a:rPr lang="en-US" sz="2550" dirty="0" spc="-5" kern="0">
+                <a:solidFill>
+                  <a:srgbClr val="14161C"/>
+                </a:solidFill>
+                <a:latin typeface="Be Vietnam Pro" pitchFamily="34" charset="0"/>
+                <a:ea typeface="Be Vietnam Pro" pitchFamily="34" charset="-122"/>
+                <a:cs typeface="Be Vietnam Pro" pitchFamily="34" charset="-120"/>
+              </a:rPr>
+              <a:t> sẵn.</a:t>
             </a:r>
             <a:endParaRPr lang="en-US" sz="2550" dirty="0"/>
-          </a:p>
-        </p:txBody>
-      </p:sp>
-      <p:sp>
-        <p:nvSpPr>
-          <p:cNvPr id="11" name="Shape 9"/>
-          <p:cNvSpPr/>
-          <p:nvPr/>
-        </p:nvSpPr>
-        <p:spPr>
-          <a:xfrm>
-            <a:off x="9525000" y="4286250"/>
-            <a:ext cx="7467600" cy="1809750"/>
-          </a:xfrm>
-          <a:prstGeom prst="roundRect">
-            <a:avLst>
-              <a:gd name="adj" fmla="val 12632"/>
-            </a:avLst>
-          </a:prstGeom>
-          <a:solidFill>
-            <a:srgbClr val="FFFFFF"/>
-          </a:solidFill>
-          <a:ln w="28575">
-            <a:solidFill>
-              <a:srgbClr val="1F3FD1"/>
-            </a:solidFill>
-            <a:prstDash val="solid"/>
-          </a:ln>
-        </p:spPr>
-      </p:sp>
-      <p:sp>
-        <p:nvSpPr>
-          <p:cNvPr id="12" name="Text 10"/>
-          <p:cNvSpPr/>
-          <p:nvPr/>
-        </p:nvSpPr>
-        <p:spPr>
-          <a:xfrm>
-            <a:off x="9810750" y="4943475"/>
-            <a:ext cx="609600" cy="609600"/>
-          </a:xfrm>
-          <a:prstGeom prst="roundRect">
-            <a:avLst>
-              <a:gd name="adj" fmla="val 50000"/>
-            </a:avLst>
-          </a:prstGeom>
-          <a:solidFill>
-            <a:srgbClr val="1F3FD1"/>
-          </a:solidFill>
-          <a:ln/>
-        </p:spPr>
-        <p:txBody>
-          <a:bodyPr wrap="square" lIns="0" tIns="0" rIns="0" bIns="0" rtlCol="0" anchor="ctr"/>
-          <a:lstStyle/>
-          <a:p>
-            <a:pPr algn="ctr" indent="0" marL="0">
-              <a:buNone/>
-            </a:pPr>
-            <a:r>
-              <a:rPr lang="en-US" sz="2550" b="1" dirty="0" spc="6" kern="0">
-                <a:solidFill>
-                  <a:srgbClr val="F3EEE3"/>
-                </a:solidFill>
-                <a:latin typeface="Be Vietnam Pro" pitchFamily="34" charset="0"/>
-                <a:ea typeface="Be Vietnam Pro" pitchFamily="34" charset="-122"/>
-                <a:cs typeface="Be Vietnam Pro" pitchFamily="34" charset="-120"/>
-              </a:rPr>
-              <a:t>2</a:t>
-            </a:r>
-            <a:endParaRPr lang="en-US" sz="2550" dirty="0"/>
-          </a:p>
-        </p:txBody>
-      </p:sp>
-      <p:sp>
-        <p:nvSpPr>
-          <p:cNvPr id="13" name="Text 11"/>
-          <p:cNvSpPr/>
-          <p:nvPr/>
-        </p:nvSpPr>
-        <p:spPr>
-          <a:xfrm>
-            <a:off x="10687050" y="4476750"/>
-            <a:ext cx="6096000" cy="1428750"/>
-          </a:xfrm>
-          <a:prstGeom prst="rect">
-            <a:avLst/>
-          </a:prstGeom>
-          <a:noFill/>
-          <a:ln/>
-        </p:spPr>
-        <p:txBody>
-          <a:bodyPr wrap="square" lIns="0" tIns="9700" rIns="0" bIns="-9700" rtlCol="0" anchor="ctr"/>
-          <a:lstStyle/>
-          <a:p>
-            <a:pPr algn="l" indent="0" marL="0">
-              <a:lnSpc>
-                <a:spcPts val="3443"/>
-              </a:lnSpc>
-              <a:buNone/>
-            </a:pPr>
-            <a:r>
-              <a:rPr lang="en-US" sz="2550" dirty="0" spc="-42" kern="0">
-                <a:solidFill>
-                  <a:srgbClr val="14161C"/>
-                </a:solidFill>
-                <a:latin typeface="Be Vietnam Pro" pitchFamily="34" charset="0"/>
-                <a:ea typeface="Be Vietnam Pro" pitchFamily="34" charset="-122"/>
-                <a:cs typeface="Be Vietnam Pro" pitchFamily="34" charset="-120"/>
-              </a:rPr>
-              <a:t>Rồi</a:t>
-            </a:r>
-            <a:r>
-              <a:rPr lang="en-US" sz="2550" dirty="0" spc="-12" kern="0">
-                <a:solidFill>
-                  <a:srgbClr val="14161C"/>
-                </a:solidFill>
-                <a:latin typeface="Be Vietnam Pro" pitchFamily="34" charset="0"/>
-                <a:ea typeface="Be Vietnam Pro" pitchFamily="34" charset="-122"/>
-                <a:cs typeface="Be Vietnam Pro" pitchFamily="34" charset="-120"/>
-              </a:rPr>
-              <a:t> tới</a:t>
-            </a:r>
-            <a:r>
-              <a:rPr lang="en-US" sz="2550" dirty="0" spc="-9" kern="0">
-                <a:solidFill>
-                  <a:srgbClr val="14161C"/>
-                </a:solidFill>
-                <a:latin typeface="Be Vietnam Pro" pitchFamily="34" charset="0"/>
-                <a:ea typeface="Be Vietnam Pro" pitchFamily="34" charset="-122"/>
-                <a:cs typeface="Be Vietnam Pro" pitchFamily="34" charset="-120"/>
-              </a:rPr>
-              <a:t> máy</a:t>
-            </a:r>
-            <a:r>
-              <a:rPr lang="en-US" sz="2550" dirty="0" spc="-2" kern="0">
-                <a:solidFill>
-                  <a:srgbClr val="14161C"/>
-                </a:solidFill>
-                <a:latin typeface="Be Vietnam Pro" pitchFamily="34" charset="0"/>
-                <a:ea typeface="Be Vietnam Pro" pitchFamily="34" charset="-122"/>
-                <a:cs typeface="Be Vietnam Pro" pitchFamily="34" charset="-120"/>
-              </a:rPr>
-              <a:t> chủ</a:t>
-            </a:r>
-            <a:r>
-              <a:rPr lang="en-US" sz="2550" dirty="0" spc="-9" kern="0">
-                <a:solidFill>
-                  <a:srgbClr val="14161C"/>
-                </a:solidFill>
-                <a:latin typeface="Be Vietnam Pro" pitchFamily="34" charset="0"/>
-                <a:ea typeface="Be Vietnam Pro" pitchFamily="34" charset="-122"/>
-                <a:cs typeface="Be Vietnam Pro" pitchFamily="34" charset="-120"/>
-              </a:rPr>
-              <a:t> web,</a:t>
-            </a:r>
-            <a:r>
-              <a:rPr lang="en-US" sz="2550" dirty="0" spc="0" kern="0">
-                <a:solidFill>
-                  <a:srgbClr val="14161C"/>
-                </a:solidFill>
-                <a:latin typeface="Be Vietnam Pro" pitchFamily="34" charset="0"/>
-                <a:ea typeface="Be Vietnam Pro" pitchFamily="34" charset="-122"/>
-                <a:cs typeface="Be Vietnam Pro" pitchFamily="34" charset="-120"/>
-              </a:rPr>
-              <a:t> có</a:t>
-            </a:r>
-            <a:r>
-              <a:rPr lang="en-US" sz="2550" dirty="0" spc="1" kern="0">
-                <a:solidFill>
-                  <a:srgbClr val="14161C"/>
-                </a:solidFill>
-                <a:latin typeface="Be Vietnam Pro" pitchFamily="34" charset="0"/>
-                <a:ea typeface="Be Vietnam Pro" pitchFamily="34" charset="-122"/>
-                <a:cs typeface="Be Vietnam Pro" pitchFamily="34" charset="-120"/>
-              </a:rPr>
-              <a:t> thể qua</a:t>
-            </a:r>
-            <a:r>
-              <a:rPr lang="en-US" sz="2550" dirty="0" spc="-25" kern="0">
-                <a:solidFill>
-                  <a:srgbClr val="14161C"/>
-                </a:solidFill>
-                <a:latin typeface="Be Vietnam Pro" pitchFamily="34" charset="0"/>
-                <a:ea typeface="Be Vietnam Pro" pitchFamily="34" charset="-122"/>
-                <a:cs typeface="Be Vietnam Pro" pitchFamily="34" charset="-120"/>
-              </a:rPr>
-              <a:t> proxy.</a:t>
-            </a:r>
-            <a:endParaRPr lang="en-US" sz="2550" dirty="0"/>
-          </a:p>
-        </p:txBody>
-      </p:sp>
-      <p:sp>
-        <p:nvSpPr>
-          <p:cNvPr id="14" name="Shape 12"/>
-          <p:cNvSpPr/>
-          <p:nvPr/>
-        </p:nvSpPr>
-        <p:spPr>
-          <a:xfrm>
-            <a:off x="9525000" y="6381750"/>
-            <a:ext cx="7467600" cy="1809750"/>
-          </a:xfrm>
-          <a:prstGeom prst="roundRect">
-            <a:avLst>
-              <a:gd name="adj" fmla="val 12632"/>
-            </a:avLst>
-          </a:prstGeom>
-          <a:solidFill>
-            <a:srgbClr val="FFFFFF"/>
-          </a:solidFill>
-          <a:ln w="28575">
-            <a:solidFill>
-              <a:srgbClr val="1F3FD1"/>
-            </a:solidFill>
-            <a:prstDash val="solid"/>
-          </a:ln>
-        </p:spPr>
-      </p:sp>
-      <p:sp>
-        <p:nvSpPr>
-          <p:cNvPr id="15" name="Text 13"/>
-          <p:cNvSpPr/>
-          <p:nvPr/>
-        </p:nvSpPr>
-        <p:spPr>
-          <a:xfrm>
-            <a:off x="9810750" y="7038975"/>
-            <a:ext cx="609600" cy="609600"/>
-          </a:xfrm>
-          <a:prstGeom prst="roundRect">
-            <a:avLst>
-              <a:gd name="adj" fmla="val 50000"/>
-            </a:avLst>
-          </a:prstGeom>
-          <a:solidFill>
-            <a:srgbClr val="1F3FD1"/>
-          </a:solidFill>
-          <a:ln/>
-        </p:spPr>
-        <p:txBody>
-          <a:bodyPr wrap="square" lIns="0" tIns="0" rIns="0" bIns="0" rtlCol="0" anchor="ctr"/>
-          <a:lstStyle/>
-          <a:p>
-            <a:pPr algn="ctr" indent="0" marL="0">
-              <a:buNone/>
-            </a:pPr>
-            <a:r>
-              <a:rPr lang="en-US" sz="2550" b="1" dirty="0" spc="-4" kern="0">
-                <a:solidFill>
-                  <a:srgbClr val="F3EEE3"/>
-                </a:solidFill>
-                <a:latin typeface="Be Vietnam Pro" pitchFamily="34" charset="0"/>
-                <a:ea typeface="Be Vietnam Pro" pitchFamily="34" charset="-122"/>
-                <a:cs typeface="Be Vietnam Pro" pitchFamily="34" charset="-120"/>
-              </a:rPr>
-              <a:t>3</a:t>
-            </a:r>
-            <a:endParaRPr lang="en-US" sz="2550" dirty="0"/>
-          </a:p>
-        </p:txBody>
-      </p:sp>
-      <p:sp>
-        <p:nvSpPr>
-          <p:cNvPr id="16" name="Text 14"/>
-          <p:cNvSpPr/>
-          <p:nvPr/>
-        </p:nvSpPr>
-        <p:spPr>
-          <a:xfrm>
-            <a:off x="10687050" y="6572250"/>
-            <a:ext cx="6096000" cy="1428750"/>
-          </a:xfrm>
-          <a:prstGeom prst="rect">
-            <a:avLst/>
-          </a:prstGeom>
-          <a:noFill/>
-          <a:ln/>
-        </p:spPr>
-        <p:txBody>
-          <a:bodyPr wrap="square" lIns="0" tIns="9700" rIns="0" bIns="-9700" rtlCol="0" anchor="ctr"/>
-          <a:lstStyle/>
-          <a:p>
-            <a:pPr algn="l" indent="0" marL="0">
-              <a:lnSpc>
-                <a:spcPts val="3443"/>
-              </a:lnSpc>
-              <a:buNone/>
-            </a:pPr>
-            <a:r>
-              <a:rPr lang="en-US" sz="2550" dirty="0" spc="1" kern="0">
-                <a:solidFill>
-                  <a:srgbClr val="14161C"/>
-                </a:solidFill>
-                <a:latin typeface="Be Vietnam Pro" pitchFamily="34" charset="0"/>
-                <a:ea typeface="Be Vietnam Pro" pitchFamily="34" charset="-122"/>
-                <a:cs typeface="Be Vietnam Pro" pitchFamily="34" charset="-120"/>
-              </a:rPr>
-              <a:t>Có</a:t>
-            </a:r>
-            <a:r>
-              <a:rPr lang="en-US" sz="2550" dirty="0" spc="-3" kern="0">
-                <a:solidFill>
-                  <a:srgbClr val="14161C"/>
-                </a:solidFill>
-                <a:latin typeface="Be Vietnam Pro" pitchFamily="34" charset="0"/>
-                <a:ea typeface="Be Vietnam Pro" pitchFamily="34" charset="-122"/>
-                <a:cs typeface="Be Vietnam Pro" pitchFamily="34" charset="-120"/>
-              </a:rPr>
-              <a:t> bản</a:t>
-            </a:r>
-            <a:r>
-              <a:rPr lang="en-US" sz="2550" dirty="0" spc="-1" kern="0">
-                <a:solidFill>
-                  <a:srgbClr val="14161C"/>
-                </a:solidFill>
-                <a:latin typeface="Be Vietnam Pro" pitchFamily="34" charset="0"/>
-                <a:ea typeface="Be Vietnam Pro" pitchFamily="34" charset="-122"/>
-                <a:cs typeface="Be Vietnam Pro" pitchFamily="34" charset="-120"/>
-              </a:rPr>
-              <a:t> ở</a:t>
-            </a:r>
-            <a:r>
-              <a:rPr lang="en-US" sz="2550" dirty="0" spc="-9" kern="0">
-                <a:solidFill>
-                  <a:srgbClr val="14161C"/>
-                </a:solidFill>
-                <a:latin typeface="Be Vietnam Pro" pitchFamily="34" charset="0"/>
-                <a:ea typeface="Be Vietnam Pro" pitchFamily="34" charset="-122"/>
-                <a:cs typeface="Be Vietnam Pro" pitchFamily="34" charset="-120"/>
-              </a:rPr>
-              <a:t> máy</a:t>
-            </a:r>
-            <a:r>
-              <a:rPr lang="en-US" sz="2550" dirty="0" spc="-1" kern="0">
-                <a:solidFill>
-                  <a:srgbClr val="14161C"/>
-                </a:solidFill>
-                <a:latin typeface="Be Vietnam Pro" pitchFamily="34" charset="0"/>
-                <a:ea typeface="Be Vietnam Pro" pitchFamily="34" charset="-122"/>
-                <a:cs typeface="Be Vietnam Pro" pitchFamily="34" charset="-120"/>
-              </a:rPr>
-              <a:t> chủ biên</a:t>
-            </a:r>
-            <a:r>
-              <a:rPr lang="en-US" sz="2550" dirty="0" spc="2" kern="0">
-                <a:solidFill>
-                  <a:srgbClr val="14161C"/>
-                </a:solidFill>
-                <a:latin typeface="Be Vietnam Pro" pitchFamily="34" charset="0"/>
-                <a:ea typeface="Be Vietnam Pro" pitchFamily="34" charset="-122"/>
-                <a:cs typeface="Be Vietnam Pro" pitchFamily="34" charset="-120"/>
-              </a:rPr>
-              <a:t> thì</a:t>
-            </a:r>
-            <a:r>
-              <a:rPr lang="en-US" sz="2550" dirty="0" spc="0" kern="0">
-                <a:solidFill>
-                  <a:srgbClr val="14161C"/>
-                </a:solidFill>
-                <a:latin typeface="Be Vietnam Pro" pitchFamily="34" charset="0"/>
-                <a:ea typeface="Be Vietnam Pro" pitchFamily="34" charset="-122"/>
-                <a:cs typeface="Be Vietnam Pro" pitchFamily="34" charset="-120"/>
-              </a:rPr>
-              <a:t> nhận</a:t>
-            </a:r>
-            <a:r>
-              <a:rPr lang="en-US" sz="2550" dirty="0" spc="-2" kern="0">
-                <a:solidFill>
-                  <a:srgbClr val="14161C"/>
-                </a:solidFill>
-                <a:latin typeface="Be Vietnam Pro" pitchFamily="34" charset="0"/>
-                <a:ea typeface="Be Vietnam Pro" pitchFamily="34" charset="-122"/>
-                <a:cs typeface="Be Vietnam Pro" pitchFamily="34" charset="-120"/>
-              </a:rPr>
-              <a:t> từ</a:t>
-            </a:r>
-            <a:r>
-              <a:rPr lang="en-US" sz="2550" dirty="0" spc="14" kern="0">
-                <a:solidFill>
-                  <a:srgbClr val="14161C"/>
-                </a:solidFill>
-                <a:latin typeface="Be Vietnam Pro" pitchFamily="34" charset="0"/>
-                <a:ea typeface="Be Vietnam Pro" pitchFamily="34" charset="-122"/>
-                <a:cs typeface="Be Vietnam Pro" pitchFamily="34" charset="-120"/>
-              </a:rPr>
-              <a:t> đó.</a:t>
-            </a:r>
-            <a:endParaRPr lang="en-US" sz="2550" dirty="0"/>
-          </a:p>
-        </p:txBody>
-      </p:sp>
-      <p:sp>
-        <p:nvSpPr>
-          <p:cNvPr id="17" name="Shape 15"/>
-          <p:cNvSpPr/>
-          <p:nvPr/>
-        </p:nvSpPr>
-        <p:spPr>
-          <a:xfrm>
-            <a:off x="981075" y="9439275"/>
-            <a:ext cx="133350" cy="133350"/>
-          </a:xfrm>
-          <a:prstGeom prst="ellipse">
-            <a:avLst/>
-          </a:prstGeom>
-          <a:solidFill>
-            <a:srgbClr val="14161C"/>
-          </a:solidFill>
-          <a:ln w="19050">
-            <a:solidFill>
-              <a:srgbClr val="14161C"/>
-            </a:solidFill>
-            <a:prstDash val="solid"/>
-          </a:ln>
-        </p:spPr>
-      </p:sp>
-      <p:sp>
-        <p:nvSpPr>
-          <p:cNvPr id="18" name="Shape 16"/>
-          <p:cNvSpPr/>
-          <p:nvPr/>
-        </p:nvSpPr>
-        <p:spPr>
-          <a:xfrm>
-            <a:off x="1323975" y="9439275"/>
-            <a:ext cx="133350" cy="133350"/>
-          </a:xfrm>
-          <a:prstGeom prst="ellipse">
-            <a:avLst/>
-          </a:prstGeom>
-          <a:solidFill>
-            <a:srgbClr val="14161C"/>
-          </a:solidFill>
-          <a:ln w="19050">
-            <a:solidFill>
-              <a:srgbClr val="14161C"/>
-            </a:solidFill>
-            <a:prstDash val="solid"/>
-          </a:ln>
-        </p:spPr>
-      </p:sp>
-      <p:sp>
-        <p:nvSpPr>
-          <p:cNvPr id="19" name="Shape 17"/>
-          <p:cNvSpPr/>
-          <p:nvPr/>
-        </p:nvSpPr>
-        <p:spPr>
-          <a:xfrm>
-            <a:off x="1666875" y="9439275"/>
-            <a:ext cx="133350" cy="133350"/>
-          </a:xfrm>
-          <a:prstGeom prst="ellipse">
-            <a:avLst/>
-          </a:prstGeom>
-          <a:solidFill>
-            <a:srgbClr val="14161C"/>
-          </a:solidFill>
-          <a:ln w="19050">
-            <a:solidFill>
-              <a:srgbClr val="14161C"/>
-            </a:solidFill>
-            <a:prstDash val="solid"/>
-          </a:ln>
-        </p:spPr>
-      </p:sp>
-      <p:sp>
-        <p:nvSpPr>
-          <p:cNvPr id="20" name="Shape 18"/>
-          <p:cNvSpPr/>
-          <p:nvPr/>
-        </p:nvSpPr>
-        <p:spPr>
-          <a:xfrm>
-            <a:off x="2009775" y="9439275"/>
-            <a:ext cx="133350" cy="133350"/>
-          </a:xfrm>
-          <a:prstGeom prst="ellipse">
-            <a:avLst/>
-          </a:prstGeom>
-          <a:solidFill>
-            <a:srgbClr val="14161C"/>
-          </a:solidFill>
-          <a:ln w="19050">
-            <a:solidFill>
-              <a:srgbClr val="14161C"/>
-            </a:solidFill>
-            <a:prstDash val="solid"/>
-          </a:ln>
-        </p:spPr>
-      </p:sp>
-      <p:sp>
-        <p:nvSpPr>
-          <p:cNvPr id="21" name="Shape 19"/>
-          <p:cNvSpPr/>
-          <p:nvPr/>
-        </p:nvSpPr>
-        <p:spPr>
-          <a:xfrm>
-            <a:off x="2352675" y="9439275"/>
-            <a:ext cx="133350" cy="133350"/>
-          </a:xfrm>
-          <a:prstGeom prst="ellipse">
-            <a:avLst/>
-          </a:prstGeom>
-          <a:solidFill>
-            <a:srgbClr val="14161C"/>
-          </a:solidFill>
-          <a:ln w="19050">
-            <a:solidFill>
-              <a:srgbClr val="14161C"/>
-            </a:solidFill>
-            <a:prstDash val="solid"/>
-          </a:ln>
-        </p:spPr>
-      </p:sp>
-      <p:sp>
-        <p:nvSpPr>
-          <p:cNvPr id="22" name="Shape 20"/>
-          <p:cNvSpPr/>
-          <p:nvPr/>
-        </p:nvSpPr>
-        <p:spPr>
-          <a:xfrm>
-            <a:off x="2695575" y="9439275"/>
-            <a:ext cx="133350" cy="133350"/>
-          </a:xfrm>
-          <a:prstGeom prst="ellipse">
-            <a:avLst/>
-          </a:prstGeom>
-          <a:solidFill>
-            <a:srgbClr val="14161C"/>
-          </a:solidFill>
-          <a:ln w="19050">
-            <a:solidFill>
-              <a:srgbClr val="14161C"/>
-            </a:solidFill>
-            <a:prstDash val="solid"/>
-          </a:ln>
-        </p:spPr>
-      </p:sp>
-      <p:sp>
-        <p:nvSpPr>
-          <p:cNvPr id="23" name="Shape 21"/>
-          <p:cNvSpPr/>
-          <p:nvPr/>
-        </p:nvSpPr>
-        <p:spPr>
-          <a:xfrm>
-            <a:off x="3038475" y="9439275"/>
-            <a:ext cx="133350" cy="133350"/>
-          </a:xfrm>
-          <a:prstGeom prst="ellipse">
-            <a:avLst/>
-          </a:prstGeom>
-          <a:solidFill>
-            <a:srgbClr val="14161C"/>
-          </a:solidFill>
-          <a:ln w="19050">
-            <a:solidFill>
-              <a:srgbClr val="14161C"/>
-            </a:solidFill>
-            <a:prstDash val="solid"/>
-          </a:ln>
-        </p:spPr>
-      </p:sp>
-      <p:sp>
-        <p:nvSpPr>
-          <p:cNvPr id="24" name="Shape 22"/>
-          <p:cNvSpPr/>
-          <p:nvPr/>
-        </p:nvSpPr>
-        <p:spPr>
-          <a:xfrm>
-            <a:off x="3381375" y="9439275"/>
-            <a:ext cx="133350" cy="133350"/>
-          </a:xfrm>
-          <a:prstGeom prst="ellipse">
-            <a:avLst/>
-          </a:prstGeom>
-          <a:solidFill>
-            <a:srgbClr val="14161C"/>
-          </a:solidFill>
-          <a:ln w="19050">
-            <a:solidFill>
-              <a:srgbClr val="14161C"/>
-            </a:solidFill>
-            <a:prstDash val="solid"/>
-          </a:ln>
-        </p:spPr>
-      </p:sp>
-      <p:sp>
-        <p:nvSpPr>
-          <p:cNvPr id="25" name="Shape 23"/>
-          <p:cNvSpPr/>
-          <p:nvPr/>
-        </p:nvSpPr>
-        <p:spPr>
-          <a:xfrm>
-            <a:off x="3724275" y="9439275"/>
-            <a:ext cx="133350" cy="133350"/>
-          </a:xfrm>
-          <a:prstGeom prst="ellipse">
-            <a:avLst/>
-          </a:prstGeom>
-          <a:solidFill>
-            <a:srgbClr val="E8472B"/>
-          </a:solidFill>
-          <a:ln w="19050">
-            <a:solidFill>
-              <a:srgbClr val="E8472B"/>
-            </a:solidFill>
-            <a:prstDash val="solid"/>
-          </a:ln>
-        </p:spPr>
-      </p:sp>
-      <p:sp>
-        <p:nvSpPr>
-          <p:cNvPr id="26" name="Shape 24"/>
-          <p:cNvSpPr/>
-          <p:nvPr/>
-        </p:nvSpPr>
-        <p:spPr>
-          <a:xfrm>
-            <a:off x="4067175" y="9439275"/>
-            <a:ext cx="133350" cy="133350"/>
-          </a:xfrm>
-          <a:prstGeom prst="ellipse">
-            <a:avLst/>
-          </a:prstGeom>
-          <a:solidFill>
-            <a:srgbClr val="F3EEE3"/>
-          </a:solidFill>
-          <a:ln w="19050">
-            <a:solidFill>
-              <a:srgbClr val="6B6A66"/>
-            </a:solidFill>
-            <a:prstDash val="solid"/>
-          </a:ln>
-        </p:spPr>
-      </p:sp>
-      <p:sp>
-        <p:nvSpPr>
-          <p:cNvPr id="27" name="Text 25"/>
-          <p:cNvSpPr/>
-          <p:nvPr/>
-        </p:nvSpPr>
-        <p:spPr>
-          <a:xfrm>
-            <a:off x="914400" y="9696450"/>
-            <a:ext cx="7620000" cy="323850"/>
-          </a:xfrm>
-          <a:prstGeom prst="rect">
-            <a:avLst/>
-          </a:prstGeom>
-          <a:noFill/>
-          <a:ln/>
-        </p:spPr>
-        <p:txBody>
-          <a:bodyPr wrap="square" lIns="0" tIns="0" rIns="0" bIns="0" rtlCol="0" anchor="t"/>
-          <a:lstStyle/>
-          <a:p>
-            <a:pPr algn="l" indent="0" marL="0">
-              <a:buNone/>
-            </a:pPr>
-            <a:r>
-              <a:rPr lang="en-US" sz="1650" dirty="0" spc="-12" kern="0">
-                <a:solidFill>
-                  <a:srgbClr val="6B6A66"/>
-                </a:solidFill>
-                <a:latin typeface="Be Vietnam Pro" pitchFamily="34" charset="0"/>
-                <a:ea typeface="Be Vietnam Pro" pitchFamily="34" charset="-122"/>
-                <a:cs typeface="Be Vietnam Pro" pitchFamily="34" charset="-120"/>
-              </a:rPr>
-              <a:t>System</a:t>
-            </a:r>
-            <a:r>
-              <a:rPr lang="en-US" sz="1650" dirty="0" spc="0" kern="0">
-                <a:solidFill>
-                  <a:srgbClr val="6B6A66"/>
-                </a:solidFill>
-                <a:latin typeface="Be Vietnam Pro" pitchFamily="34" charset="0"/>
-                <a:ea typeface="Be Vietnam Pro" pitchFamily="34" charset="-122"/>
-                <a:cs typeface="Be Vietnam Pro" pitchFamily="34" charset="-120"/>
-              </a:rPr>
-              <a:t> Design</a:t>
-            </a:r>
-            <a:r>
-              <a:rPr lang="en-US" sz="1650" dirty="0" spc="1" kern="0">
-                <a:solidFill>
-                  <a:srgbClr val="6B6A66"/>
-                </a:solidFill>
-                <a:latin typeface="Be Vietnam Pro" pitchFamily="34" charset="0"/>
-                <a:ea typeface="Be Vietnam Pro" pitchFamily="34" charset="-122"/>
-                <a:cs typeface="Be Vietnam Pro" pitchFamily="34" charset="-120"/>
-              </a:rPr>
-              <a:t> 101</a:t>
-            </a:r>
-            <a:r>
-              <a:rPr lang="en-US" sz="1650" dirty="0" spc="0" kern="0">
-                <a:solidFill>
-                  <a:srgbClr val="6B6A66"/>
-                </a:solidFill>
-                <a:latin typeface="Be Vietnam Pro" pitchFamily="34" charset="0"/>
-                <a:ea typeface="Be Vietnam Pro" pitchFamily="34" charset="-122"/>
-                <a:cs typeface="Be Vietnam Pro" pitchFamily="34" charset="-120"/>
-              </a:rPr>
-              <a:t> ·</a:t>
-            </a:r>
-            <a:r>
-              <a:rPr lang="en-US" sz="1650" dirty="0" spc="1" kern="0">
-                <a:solidFill>
-                  <a:srgbClr val="6B6A66"/>
-                </a:solidFill>
-                <a:latin typeface="Be Vietnam Pro" pitchFamily="34" charset="0"/>
-                <a:ea typeface="Be Vietnam Pro" pitchFamily="34" charset="-122"/>
-                <a:cs typeface="Be Vietnam Pro" pitchFamily="34" charset="-120"/>
-              </a:rPr>
-              <a:t> Bài</a:t>
-            </a:r>
-            <a:r>
-              <a:rPr lang="en-US" sz="1650" dirty="0" spc="2" kern="0">
-                <a:solidFill>
-                  <a:srgbClr val="6B6A66"/>
-                </a:solidFill>
-                <a:latin typeface="Be Vietnam Pro" pitchFamily="34" charset="0"/>
-                <a:ea typeface="Be Vietnam Pro" pitchFamily="34" charset="-122"/>
-                <a:cs typeface="Be Vietnam Pro" pitchFamily="34" charset="-120"/>
-              </a:rPr>
-              <a:t> 01</a:t>
-            </a:r>
-            <a:r>
-              <a:rPr lang="en-US" sz="1650" dirty="0" spc="0" kern="0">
-                <a:solidFill>
-                  <a:srgbClr val="6B6A66"/>
-                </a:solidFill>
-                <a:latin typeface="Be Vietnam Pro" pitchFamily="34" charset="0"/>
-                <a:ea typeface="Be Vietnam Pro" pitchFamily="34" charset="-122"/>
-                <a:cs typeface="Be Vietnam Pro" pitchFamily="34" charset="-120"/>
-              </a:rPr>
-              <a:t> ·</a:t>
-            </a:r>
-            <a:r>
-              <a:rPr lang="en-US" sz="1650" dirty="0" spc="2" kern="0">
-                <a:solidFill>
-                  <a:srgbClr val="6B6A66"/>
-                </a:solidFill>
-                <a:latin typeface="Be Vietnam Pro" pitchFamily="34" charset="0"/>
-                <a:ea typeface="Be Vietnam Pro" pitchFamily="34" charset="-122"/>
-                <a:cs typeface="Be Vietnam Pro" pitchFamily="34" charset="-120"/>
-              </a:rPr>
-              <a:t> 09/10</a:t>
-            </a:r>
-            <a:endParaRPr lang="en-US" sz="1650" dirty="0"/>
           </a:p>
         </p:txBody>
       </p:sp>

</xml_diff>

<commit_message>
Lesson sd-10-001: explain the six server types in own words from MDN, with the figure, metadata and deck to match
Co-Authored-By: Claude Sonnet 5.5 <noreply@anthropic.com>
Claude-Session: https://claude.ai/code/session_01E4oCkXXqBf2c7oMUzFxEr2
</commit_message>
<xml_diff>
--- a/system-design-101/vi/lessons/sd-10-001/slides/sd-10-001.pptx
+++ b/system-design-101/vi/lessons/sd-10-001/slides/sd-10-001.pptx
@@ -4128,7 +4128,7 @@
               <a:t> tệp</a:t>
             </a:r>
             <a:r>
-              <a:rPr lang="en-US" sz="2550" dirty="0" spc="6" kern="0">
+              <a:rPr lang="en-US" sz="2550" dirty="0" spc="-1" kern="0">
                 <a:solidFill>
                   <a:srgbClr val="F3EEE3"/>
                 </a:solidFill>
@@ -4136,10 +4136,10 @@
                 <a:ea typeface="Be Vietnam Pro" pitchFamily="34" charset="-122"/>
                 <a:cs typeface="Be Vietnam Pro" pitchFamily="34" charset="-120"/>
               </a:rPr>
-              <a:t> giữa</a:t>
-            </a:r>
-            <a:r>
-              <a:rPr lang="en-US" sz="2550" dirty="0" spc="-8" kern="0">
+              <a:t> từ</a:t>
+            </a:r>
+            <a:r>
+              <a:rPr lang="en-US" sz="2550" dirty="0" spc="-9" kern="0">
                 <a:solidFill>
                   <a:srgbClr val="F3EEE3"/>
                 </a:solidFill>
@@ -4147,10 +4147,32 @@
                 <a:ea typeface="Be Vietnam Pro" pitchFamily="34" charset="-122"/>
                 <a:cs typeface="Be Vietnam Pro" pitchFamily="34" charset="-120"/>
               </a:rPr>
+              <a:t> máy này</a:t>
+            </a:r>
+            <a:r>
+              <a:rPr lang="en-US" sz="2550" dirty="0" spc="-6" kern="0">
+                <a:solidFill>
+                  <a:srgbClr val="F3EEE3"/>
+                </a:solidFill>
+                <a:latin typeface="Be Vietnam Pro" pitchFamily="34" charset="0"/>
+                <a:ea typeface="Be Vietnam Pro" pitchFamily="34" charset="-122"/>
+                <a:cs typeface="Be Vietnam Pro" pitchFamily="34" charset="-120"/>
+              </a:rPr>
+              <a:t> sang</a:t>
+            </a:r>
+            <a:r>
+              <a:rPr lang="en-US" sz="2550" dirty="0" spc="-9" kern="0">
+                <a:solidFill>
+                  <a:srgbClr val="F3EEE3"/>
+                </a:solidFill>
+                <a:latin typeface="Be Vietnam Pro" pitchFamily="34" charset="0"/>
+                <a:ea typeface="Be Vietnam Pro" pitchFamily="34" charset="-122"/>
+                <a:cs typeface="Be Vietnam Pro" pitchFamily="34" charset="-120"/>
+              </a:rPr>
               <a:t> máy</a:t>
             </a:r>
             <a:r>
-              <a:rPr lang="en-US" sz="2550" dirty="0" spc="0" kern="0">
+              <a:rPr lang="en-US" sz="2550" dirty="0" spc="1" kern="0">
                 <a:solidFill>
                   <a:srgbClr val="F3EEE3"/>
                 </a:solidFill>
@@ -4158,40 +4180,7 @@
                 <a:ea typeface="Be Vietnam Pro" pitchFamily="34" charset="-122"/>
                 <a:cs typeface="Be Vietnam Pro" pitchFamily="34" charset="-120"/>
               </a:rPr>
-              <a:t> khách</a:t>
-            </a:r>
-            <a:r>
-              <a:rPr lang="en-US" sz="2550" dirty="0" spc="-18" kern="0">
-                <a:solidFill>
-                  <a:srgbClr val="F3EEE3"/>
-                </a:solidFill>
-                <a:latin typeface="Be Vietnam Pro" pitchFamily="34" charset="0"/>
-                <a:ea typeface="Be Vietnam Pro" pitchFamily="34" charset="-122"/>
-                <a:cs typeface="Be Vietnam Pro" pitchFamily="34" charset="-120"/>
-              </a:rPr>
-              <a:t> và</a:t>
-            </a:r>
-            <a:r>
-              <a:rPr lang="en-US" sz="2550" dirty="0" spc="-9" kern="0">
-                <a:solidFill>
-                  <a:srgbClr val="F3EEE3"/>
-                </a:solidFill>
-                <a:latin typeface="Be Vietnam Pro" pitchFamily="34" charset="0"/>
-                <a:ea typeface="Be Vietnam Pro" pitchFamily="34" charset="-122"/>
-                <a:cs typeface="Be Vietnam Pro" pitchFamily="34" charset="-120"/>
-              </a:rPr>
-              <a:t> máy</a:t>
-            </a:r>
-            <a:r>
-              <a:rPr lang="en-US" sz="2550" dirty="0" spc="0" kern="0">
-                <a:solidFill>
-                  <a:srgbClr val="F3EEE3"/>
-                </a:solidFill>
-                <a:latin typeface="Be Vietnam Pro" pitchFamily="34" charset="0"/>
-                <a:ea typeface="Be Vietnam Pro" pitchFamily="34" charset="-122"/>
-                <a:cs typeface="Be Vietnam Pro" pitchFamily="34" charset="-120"/>
-              </a:rPr>
-              <a:t> chủ.</a:t>
+              <a:t> khác.</a:t>
             </a:r>
             <a:endParaRPr lang="en-US" sz="2550" dirty="0"/>
           </a:p>
@@ -4294,6 +4283,39 @@
               <a:t> system-design-101</a:t>
             </a:r>
             <a:r>
+              <a:rPr lang="en-US" sz="2850" dirty="0" spc="-13" kern="0">
+                <a:solidFill>
+                  <a:srgbClr val="F3EEE3"/>
+                </a:solidFill>
+                <a:latin typeface="Be Vietnam Pro" pitchFamily="34" charset="0"/>
+                <a:ea typeface="Be Vietnam Pro" pitchFamily="34" charset="-122"/>
+                <a:cs typeface="Be Vietnam Pro" pitchFamily="34" charset="-120"/>
+              </a:rPr>
+              <a:t> (tên</a:t>
+            </a:r>
+            <a:r>
+              <a:rPr lang="en-US" sz="2850" dirty="0" spc="-6" kern="0">
+                <a:solidFill>
+                  <a:srgbClr val="F3EEE3"/>
+                </a:solidFill>
+                <a:latin typeface="Be Vietnam Pro" pitchFamily="34" charset="0"/>
+                <a:ea typeface="Be Vietnam Pro" pitchFamily="34" charset="-122"/>
+                <a:cs typeface="Be Vietnam Pro" pitchFamily="34" charset="-120"/>
+              </a:rPr>
+              <a:t> sáu</a:t>
+            </a:r>
+            <a:r>
+              <a:rPr lang="en-US" sz="2850" dirty="0" spc="0" kern="0">
+                <a:solidFill>
+                  <a:srgbClr val="F3EEE3"/>
+                </a:solidFill>
+                <a:latin typeface="Be Vietnam Pro" pitchFamily="34" charset="0"/>
+                <a:ea typeface="Be Vietnam Pro" pitchFamily="34" charset="-122"/>
+                <a:cs typeface="Be Vietnam Pro" pitchFamily="34" charset="-120"/>
+              </a:rPr>
+              <a:t> loại)</a:t>
+            </a:r>
+            <a:r>
               <a:rPr lang="en-US" sz="2850" dirty="0" spc="3" kern="0">
                 <a:solidFill>
                   <a:srgbClr val="F3EEE3"/>
@@ -4305,7 +4327,7 @@
               <a:t> ·</a:t>
             </a:r>
             <a:r>
-              <a:rPr lang="en-US" sz="2850" dirty="0" spc="-7" kern="0">
+              <a:rPr lang="en-US" sz="2850" dirty="0" spc="-1" kern="0">
                 <a:solidFill>
                   <a:srgbClr val="F3EEE3"/>
                 </a:solidFill>
@@ -4313,10 +4335,10 @@
                 <a:ea typeface="Be Vietnam Pro" pitchFamily="34" charset="-122"/>
                 <a:cs typeface="Be Vietnam Pro" pitchFamily="34" charset="-120"/>
               </a:rPr>
-              <a:t> sáu</a:t>
-            </a:r>
-            <a:r>
-              <a:rPr lang="en-US" sz="2850" dirty="0" spc="0" kern="0">
+              <a:t> từ</a:t>
+            </a:r>
+            <a:r>
+              <a:rPr lang="en-US" sz="2850" dirty="0" spc="23" kern="0">
                 <a:solidFill>
                   <a:srgbClr val="F3EEE3"/>
                 </a:solidFill>
@@ -4324,7 +4346,7 @@
                 <a:ea typeface="Be Vietnam Pro" pitchFamily="34" charset="-122"/>
                 <a:cs typeface="Be Vietnam Pro" pitchFamily="34" charset="-120"/>
               </a:rPr>
-              <a:t> loại</a:t>
+              <a:t> điển</a:t>
             </a:r>
             <a:r>
               <a:rPr lang="en-US" sz="2850" dirty="0" spc="-11" kern="0">
@@ -4335,7 +4357,7 @@
                 <a:ea typeface="Be Vietnam Pro" pitchFamily="34" charset="-122"/>
                 <a:cs typeface="Be Vietnam Pro" pitchFamily="34" charset="-120"/>
               </a:rPr>
-              <a:t> máy</a:t>
+              <a:t> thuật</a:t>
             </a:r>
             <a:r>
               <a:rPr lang="en-US" sz="2850" dirty="0" spc="-1" kern="0">
@@ -4346,10 +4368,10 @@
                 <a:ea typeface="Be Vietnam Pro" pitchFamily="34" charset="-122"/>
                 <a:cs typeface="Be Vietnam Pro" pitchFamily="34" charset="-120"/>
               </a:rPr>
-              <a:t> chủ</a:t>
-            </a:r>
-            <a:r>
-              <a:rPr lang="en-US" sz="2850" dirty="0" spc="5" kern="0">
+              <a:t> ngữ</a:t>
+            </a:r>
+            <a:r>
+              <a:rPr lang="en-US" sz="2850" dirty="0" spc="2" kern="0">
                 <a:solidFill>
                   <a:srgbClr val="F3EEE3"/>
                 </a:solidFill>
@@ -4357,18 +4379,7 @@
                 <a:ea typeface="Be Vietnam Pro" pitchFamily="34" charset="-122"/>
                 <a:cs typeface="Be Vietnam Pro" pitchFamily="34" charset="-120"/>
               </a:rPr>
-              <a:t> thường</a:t>
-            </a:r>
-            <a:r>
-              <a:rPr lang="en-US" sz="2850" dirty="0" spc="-2" kern="0">
-                <a:solidFill>
-                  <a:srgbClr val="F3EEE3"/>
-                </a:solidFill>
-                <a:latin typeface="Be Vietnam Pro" pitchFamily="34" charset="0"/>
-                <a:ea typeface="Be Vietnam Pro" pitchFamily="34" charset="-122"/>
-                <a:cs typeface="Be Vietnam Pro" pitchFamily="34" charset="-120"/>
-              </a:rPr>
-              <a:t> dùng</a:t>
+              <a:t> MDN</a:t>
             </a:r>
             <a:endParaRPr lang="en-US" sz="2850" dirty="0"/>
           </a:p>
@@ -4451,7 +4462,73 @@
                 <a:ea typeface="Be Vietnam Pro" pitchFamily="34" charset="-122"/>
                 <a:cs typeface="Be Vietnam Pro" pitchFamily="34" charset="-120"/>
               </a:rPr>
-              <a:t> 2026-10-18.</a:t>
+              <a:t> 2026-10-19.</a:t>
+            </a:r>
+            <a:r>
+              <a:rPr lang="en-US" sz="1950" dirty="0" spc="2" kern="0">
+                <a:solidFill>
+                  <a:srgbClr val="9AA0B5"/>
+                </a:solidFill>
+                <a:latin typeface="Be Vietnam Pro" pitchFamily="34" charset="0"/>
+                <a:ea typeface="Be Vietnam Pro" pitchFamily="34" charset="-122"/>
+                <a:cs typeface="Be Vietnam Pro" pitchFamily="34" charset="-120"/>
+              </a:rPr>
+              <a:t> Giải</a:t>
+            </a:r>
+            <a:r>
+              <a:rPr lang="en-US" sz="1950" dirty="0" spc="-2" kern="0">
+                <a:solidFill>
+                  <a:srgbClr val="9AA0B5"/>
+                </a:solidFill>
+                <a:latin typeface="Be Vietnam Pro" pitchFamily="34" charset="0"/>
+                <a:ea typeface="Be Vietnam Pro" pitchFamily="34" charset="-122"/>
+                <a:cs typeface="Be Vietnam Pro" pitchFamily="34" charset="-120"/>
+              </a:rPr>
+              <a:t> thích</a:t>
+            </a:r>
+            <a:r>
+              <a:rPr lang="en-US" sz="1950" dirty="0" spc="8" kern="0">
+                <a:solidFill>
+                  <a:srgbClr val="9AA0B5"/>
+                </a:solidFill>
+                <a:latin typeface="Be Vietnam Pro" pitchFamily="34" charset="0"/>
+                <a:ea typeface="Be Vietnam Pro" pitchFamily="34" charset="-122"/>
+                <a:cs typeface="Be Vietnam Pro" pitchFamily="34" charset="-120"/>
+              </a:rPr>
+              <a:t> dựa</a:t>
+            </a:r>
+            <a:r>
+              <a:rPr lang="en-US" sz="1950" dirty="0" spc="-11" kern="0">
+                <a:solidFill>
+                  <a:srgbClr val="9AA0B5"/>
+                </a:solidFill>
+                <a:latin typeface="Be Vietnam Pro" pitchFamily="34" charset="0"/>
+                <a:ea typeface="Be Vietnam Pro" pitchFamily="34" charset="-122"/>
+                <a:cs typeface="Be Vietnam Pro" pitchFamily="34" charset="-120"/>
+              </a:rPr>
+              <a:t> vào</a:t>
+            </a:r>
+            <a:r>
+              <a:rPr lang="en-US" sz="1950" dirty="0" spc="-1" kern="0">
+                <a:solidFill>
+                  <a:srgbClr val="9AA0B5"/>
+                </a:solidFill>
+                <a:latin typeface="Be Vietnam Pro" pitchFamily="34" charset="0"/>
+                <a:ea typeface="Be Vietnam Pro" pitchFamily="34" charset="-122"/>
+                <a:cs typeface="Be Vietnam Pro" pitchFamily="34" charset="-120"/>
+              </a:rPr>
+              <a:t> MDN</a:t>
+            </a:r>
+            <a:r>
+              <a:rPr lang="en-US" sz="1950" dirty="0" spc="-15" kern="0">
+                <a:solidFill>
+                  <a:srgbClr val="9AA0B5"/>
+                </a:solidFill>
+                <a:latin typeface="Be Vietnam Pro" pitchFamily="34" charset="0"/>
+                <a:ea typeface="Be Vietnam Pro" pitchFamily="34" charset="-122"/>
+                <a:cs typeface="Be Vietnam Pro" pitchFamily="34" charset="-120"/>
+              </a:rPr>
+              <a:t> và</a:t>
             </a:r>
             <a:r>
               <a:rPr lang="en-US" sz="1950" dirty="0" spc="0" kern="0">
@@ -4462,10 +4539,10 @@
                 <a:ea typeface="Be Vietnam Pro" pitchFamily="34" charset="-122"/>
                 <a:cs typeface="Be Vietnam Pro" pitchFamily="34" charset="-120"/>
               </a:rPr>
-              <a:t> Hình</a:t>
-            </a:r>
-            <a:r>
-              <a:rPr lang="en-US" sz="1950" dirty="0" spc="2" kern="0">
+              <a:t> kiến</a:t>
+            </a:r>
+            <a:r>
+              <a:rPr lang="en-US" sz="1950" dirty="0" spc="5" kern="0">
                 <a:solidFill>
                   <a:srgbClr val="9AA0B5"/>
                 </a:solidFill>
@@ -4473,10 +4550,10 @@
                 <a:ea typeface="Be Vietnam Pro" pitchFamily="34" charset="-122"/>
                 <a:cs typeface="Be Vietnam Pro" pitchFamily="34" charset="-120"/>
               </a:rPr>
-              <a:t> minh</a:t>
-            </a:r>
-            <a:r>
-              <a:rPr lang="en-US" sz="1950" dirty="0" spc="-3" kern="0">
+              <a:t> thức</a:t>
+            </a:r>
+            <a:r>
+              <a:rPr lang="en-US" sz="1950" dirty="0" spc="1" kern="0">
                 <a:solidFill>
                   <a:srgbClr val="9AA0B5"/>
                 </a:solidFill>
@@ -4484,10 +4561,10 @@
                 <a:ea typeface="Be Vietnam Pro" pitchFamily="34" charset="-122"/>
                 <a:cs typeface="Be Vietnam Pro" pitchFamily="34" charset="-120"/>
               </a:rPr>
-              <a:t> họa</a:t>
-            </a:r>
-            <a:r>
-              <a:rPr lang="en-US" sz="1950" dirty="0" spc="-2" kern="0">
+              <a:t> chung</a:t>
+            </a:r>
+            <a:r>
+              <a:rPr lang="en-US" sz="1950" dirty="0" spc="-1" kern="0">
                 <a:solidFill>
                   <a:srgbClr val="9AA0B5"/>
                 </a:solidFill>
@@ -4495,10 +4572,10 @@
                 <a:ea typeface="Be Vietnam Pro" pitchFamily="34" charset="-122"/>
                 <a:cs typeface="Be Vietnam Pro" pitchFamily="34" charset="-120"/>
               </a:rPr>
-              <a:t> là</a:t>
-            </a:r>
-            <a:r>
-              <a:rPr lang="en-US" sz="1950" dirty="0" spc="-4" kern="0">
+              <a:t> của</a:t>
+            </a:r>
+            <a:r>
+              <a:rPr lang="en-US" sz="1950" dirty="0" spc="6" kern="0">
                 <a:solidFill>
                   <a:srgbClr val="9AA0B5"/>
                 </a:solidFill>
@@ -4506,10 +4583,10 @@
                 <a:ea typeface="Be Vietnam Pro" pitchFamily="34" charset="-122"/>
                 <a:cs typeface="Be Vietnam Pro" pitchFamily="34" charset="-120"/>
               </a:rPr>
-              <a:t> thiết</a:t>
-            </a:r>
-            <a:r>
-              <a:rPr lang="en-US" sz="1950" dirty="0" spc="-32" kern="0">
+              <a:t> người</a:t>
+            </a:r>
+            <a:r>
+              <a:rPr lang="en-US" sz="1950" dirty="0" spc="0" kern="0">
                 <a:solidFill>
                   <a:srgbClr val="9AA0B5"/>
                 </a:solidFill>
@@ -4517,10 +4594,10 @@
                 <a:ea typeface="Be Vietnam Pro" pitchFamily="34" charset="-122"/>
                 <a:cs typeface="Be Vietnam Pro" pitchFamily="34" charset="-120"/>
               </a:rPr>
-              <a:t> kế</a:t>
-            </a:r>
-            <a:r>
-              <a:rPr lang="en-US" sz="1950" dirty="0" spc="-1" kern="0">
+              <a:t> biên</a:t>
+            </a:r>
+            <a:r>
+              <a:rPr lang="en-US" sz="1950" dirty="0" spc="-5" kern="0">
                 <a:solidFill>
                   <a:srgbClr val="9AA0B5"/>
                 </a:solidFill>
@@ -4528,7 +4605,7 @@
                 <a:ea typeface="Be Vietnam Pro" pitchFamily="34" charset="-122"/>
                 <a:cs typeface="Be Vietnam Pro" pitchFamily="34" charset="-120"/>
               </a:rPr>
-              <a:t> mới.</a:t>
+              <a:t> soạn.</a:t>
             </a:r>
             <a:endParaRPr lang="en-US" sz="1950" dirty="0"/>
           </a:p>
@@ -7248,7 +7325,7 @@
               <a:buNone/>
             </a:pPr>
             <a:r>
-              <a:rPr lang="en-US" sz="3300" b="1" dirty="0" spc="-3" kern="0">
+              <a:rPr lang="en-US" sz="3300" b="1" dirty="0" spc="-80" kern="0">
                 <a:solidFill>
                   <a:srgbClr val="1F3FD1"/>
                 </a:solidFill>
@@ -7256,10 +7333,10 @@
                 <a:ea typeface="Be Vietnam Pro" pitchFamily="34" charset="-122"/>
                 <a:cs typeface="Be Vietnam Pro" pitchFamily="34" charset="-120"/>
               </a:rPr>
-              <a:t>Giữ</a:t>
-            </a:r>
-            <a:r>
-              <a:rPr lang="en-US" sz="3300" b="1" dirty="0" spc="-15" kern="0">
+              <a:t>Trả</a:t>
+            </a:r>
+            <a:r>
+              <a:rPr lang="en-US" sz="3300" b="1" dirty="0" spc="1" kern="0">
                 <a:solidFill>
                   <a:srgbClr val="1F3FD1"/>
                 </a:solidFill>
@@ -7267,10 +7344,10 @@
                 <a:ea typeface="Be Vietnam Pro" pitchFamily="34" charset="-122"/>
                 <a:cs typeface="Be Vietnam Pro" pitchFamily="34" charset="-120"/>
               </a:rPr>
-              <a:t> trang</a:t>
-            </a:r>
-            <a:r>
-              <a:rPr lang="en-US" sz="3300" b="1" dirty="0" spc="-25" kern="0">
+              <a:t> lời</a:t>
+            </a:r>
+            <a:r>
+              <a:rPr lang="en-US" sz="3300" b="1" dirty="0" spc="5" kern="0">
                 <a:solidFill>
                   <a:srgbClr val="1F3FD1"/>
                 </a:solidFill>
@@ -7278,7 +7355,18 @@
                 <a:ea typeface="Be Vietnam Pro" pitchFamily="34" charset="-122"/>
                 <a:cs typeface="Be Vietnam Pro" pitchFamily="34" charset="-120"/>
               </a:rPr>
-              <a:t> web</a:t>
+              <a:t> trình</a:t>
+            </a:r>
+            <a:r>
+              <a:rPr lang="en-US" sz="3300" b="1" dirty="0" spc="-23" kern="0">
+                <a:solidFill>
+                  <a:srgbClr val="1F3FD1"/>
+                </a:solidFill>
+                <a:latin typeface="Be Vietnam Pro" pitchFamily="34" charset="0"/>
+                <a:ea typeface="Be Vietnam Pro" pitchFamily="34" charset="-122"/>
+                <a:cs typeface="Be Vietnam Pro" pitchFamily="34" charset="-120"/>
+              </a:rPr>
+              <a:t> duyệt</a:t>
             </a:r>
             <a:endParaRPr lang="en-US" sz="3300" dirty="0"/>
           </a:p>
@@ -7312,15 +7400,92 @@
               <a:buNone/>
             </a:pPr>
             <a:r>
-              <a:rPr lang="en-US" sz="2850" dirty="0" spc="60" kern="0">
-                <a:solidFill>
-                  <a:srgbClr val="14161C"/>
-                </a:solidFill>
-                <a:latin typeface="Be Vietnam Pro" pitchFamily="34" charset="0"/>
-                <a:ea typeface="Be Vietnam Pro" pitchFamily="34" charset="-122"/>
-                <a:cs typeface="Be Vietnam Pro" pitchFamily="34" charset="-120"/>
-              </a:rPr>
-              <a:t>Gửi</a:t>
+              <a:rPr lang="en-US" sz="2850" dirty="0" spc="6" kern="0">
+                <a:solidFill>
+                  <a:srgbClr val="14161C"/>
+                </a:solidFill>
+                <a:latin typeface="Be Vietnam Pro" pitchFamily="34" charset="0"/>
+                <a:ea typeface="Be Vietnam Pro" pitchFamily="34" charset="-122"/>
+                <a:cs typeface="Be Vietnam Pro" pitchFamily="34" charset="-120"/>
+              </a:rPr>
+              <a:t>Chương</a:t>
+            </a:r>
+            <a:r>
+              <a:rPr lang="en-US" sz="2850" dirty="0" spc="10" kern="0">
+                <a:solidFill>
+                  <a:srgbClr val="14161C"/>
+                </a:solidFill>
+                <a:latin typeface="Be Vietnam Pro" pitchFamily="34" charset="0"/>
+                <a:ea typeface="Be Vietnam Pro" pitchFamily="34" charset="-122"/>
+                <a:cs typeface="Be Vietnam Pro" pitchFamily="34" charset="-120"/>
+              </a:rPr>
+              <a:t> trình</a:t>
+            </a:r>
+            <a:r>
+              <a:rPr lang="en-US" sz="2850" dirty="0" spc="-28" kern="0">
+                <a:solidFill>
+                  <a:srgbClr val="14161C"/>
+                </a:solidFill>
+                <a:latin typeface="Be Vietnam Pro" pitchFamily="34" charset="0"/>
+                <a:ea typeface="Be Vietnam Pro" pitchFamily="34" charset="-122"/>
+                <a:cs typeface="Be Vietnam Pro" pitchFamily="34" charset="-120"/>
+              </a:rPr>
+              <a:t> trả</a:t>
+            </a:r>
+            <a:r>
+              <a:rPr lang="en-US" sz="2850" dirty="0" spc="1" kern="0">
+                <a:solidFill>
+                  <a:srgbClr val="14161C"/>
+                </a:solidFill>
+                <a:latin typeface="Be Vietnam Pro" pitchFamily="34" charset="0"/>
+                <a:ea typeface="Be Vietnam Pro" pitchFamily="34" charset="-122"/>
+                <a:cs typeface="Be Vietnam Pro" pitchFamily="34" charset="-120"/>
+              </a:rPr>
+              <a:t> lời</a:t>
+            </a:r>
+            <a:r>
+              <a:rPr lang="en-US" sz="2850" dirty="0" spc="-24" kern="0">
+                <a:solidFill>
+                  <a:srgbClr val="14161C"/>
+                </a:solidFill>
+                <a:latin typeface="Be Vietnam Pro" pitchFamily="34" charset="0"/>
+                <a:ea typeface="Be Vietnam Pro" pitchFamily="34" charset="-122"/>
+                <a:cs typeface="Be Vietnam Pro" pitchFamily="34" charset="-120"/>
+              </a:rPr>
+              <a:t> yêu</a:t>
+            </a:r>
+            <a:r>
+              <a:rPr lang="en-US" sz="2850" dirty="0" spc="0" kern="0">
+                <a:solidFill>
+                  <a:srgbClr val="14161C"/>
+                </a:solidFill>
+                <a:latin typeface="Be Vietnam Pro" pitchFamily="34" charset="0"/>
+                <a:ea typeface="Be Vietnam Pro" pitchFamily="34" charset="-122"/>
+                <a:cs typeface="Be Vietnam Pro" pitchFamily="34" charset="-120"/>
+              </a:rPr>
+              <a:t> cầu</a:t>
+            </a:r>
+            <a:r>
+              <a:rPr lang="en-US" sz="2850" dirty="0" spc="-5" kern="0">
+                <a:solidFill>
+                  <a:srgbClr val="14161C"/>
+                </a:solidFill>
+                <a:latin typeface="Be Vietnam Pro" pitchFamily="34" charset="0"/>
+                <a:ea typeface="Be Vietnam Pro" pitchFamily="34" charset="-122"/>
+                <a:cs typeface="Be Vietnam Pro" pitchFamily="34" charset="-120"/>
+              </a:rPr>
+              <a:t> bằng</a:t>
+            </a:r>
+            <a:r>
+              <a:rPr lang="en-US" sz="2850" dirty="0" spc="0" kern="0">
+                <a:solidFill>
+                  <a:srgbClr val="14161C"/>
+                </a:solidFill>
+                <a:latin typeface="Be Vietnam Pro" pitchFamily="34" charset="0"/>
+                <a:ea typeface="Be Vietnam Pro" pitchFamily="34" charset="-122"/>
+                <a:cs typeface="Be Vietnam Pro" pitchFamily="34" charset="-120"/>
+              </a:rPr>
+              <a:t> nội</a:t>
             </a:r>
             <a:r>
               <a:rPr lang="en-US" sz="2850" dirty="0" spc="-1" kern="0">
@@ -7331,40 +7496,7 @@
                 <a:ea typeface="Be Vietnam Pro" pitchFamily="34" charset="-122"/>
                 <a:cs typeface="Be Vietnam Pro" pitchFamily="34" charset="-120"/>
               </a:rPr>
-              <a:t> nội dung</a:t>
-            </a:r>
-            <a:r>
-              <a:rPr lang="en-US" sz="2850" dirty="0" spc="-15" kern="0">
-                <a:solidFill>
-                  <a:srgbClr val="14161C"/>
-                </a:solidFill>
-                <a:latin typeface="Be Vietnam Pro" pitchFamily="34" charset="0"/>
-                <a:ea typeface="Be Vietnam Pro" pitchFamily="34" charset="-122"/>
-                <a:cs typeface="Be Vietnam Pro" pitchFamily="34" charset="-120"/>
-              </a:rPr>
-              <a:t> tới</a:t>
-            </a:r>
-            <a:r>
-              <a:rPr lang="en-US" sz="2850" dirty="0" spc="-11" kern="0">
-                <a:solidFill>
-                  <a:srgbClr val="14161C"/>
-                </a:solidFill>
-                <a:latin typeface="Be Vietnam Pro" pitchFamily="34" charset="0"/>
-                <a:ea typeface="Be Vietnam Pro" pitchFamily="34" charset="-122"/>
-                <a:cs typeface="Be Vietnam Pro" pitchFamily="34" charset="-120"/>
-              </a:rPr>
-              <a:t> máy</a:t>
-            </a:r>
-            <a:r>
-              <a:rPr lang="en-US" sz="2850" dirty="0" spc="-1" kern="0">
-                <a:solidFill>
-                  <a:srgbClr val="14161C"/>
-                </a:solidFill>
-                <a:latin typeface="Be Vietnam Pro" pitchFamily="34" charset="0"/>
-                <a:ea typeface="Be Vietnam Pro" pitchFamily="34" charset="-122"/>
-                <a:cs typeface="Be Vietnam Pro" pitchFamily="34" charset="-120"/>
-              </a:rPr>
-              <a:t> khách</a:t>
+              <a:t> dung</a:t>
             </a:r>
             <a:r>
               <a:rPr lang="en-US" sz="2850" dirty="0" spc="1" kern="0">
@@ -7375,7 +7507,7 @@
                 <a:ea typeface="Be Vietnam Pro" pitchFamily="34" charset="-122"/>
                 <a:cs typeface="Be Vietnam Pro" pitchFamily="34" charset="-120"/>
               </a:rPr>
-              <a:t> qua</a:t>
+              <a:t> của</a:t>
             </a:r>
             <a:r>
               <a:rPr lang="en-US" sz="2850" dirty="0" spc="-16" kern="0">
@@ -7386,7 +7518,7 @@
                 <a:ea typeface="Be Vietnam Pro" pitchFamily="34" charset="-122"/>
                 <a:cs typeface="Be Vietnam Pro" pitchFamily="34" charset="-120"/>
               </a:rPr>
-              <a:t> Internet.</a:t>
+              <a:t> trang.</a:t>
             </a:r>
             <a:endParaRPr lang="en-US" sz="2850" dirty="0"/>
           </a:p>
@@ -8013,6 +8145,39 @@
               <a:t> web</a:t>
             </a:r>
             <a:r>
+              <a:rPr lang="en-US" sz="1800" dirty="0" spc="-17" kern="0">
+                <a:solidFill>
+                  <a:srgbClr val="6B6A66"/>
+                </a:solidFill>
+                <a:latin typeface="Be Vietnam Pro" pitchFamily="34" charset="0"/>
+                <a:ea typeface="Be Vietnam Pro" pitchFamily="34" charset="-122"/>
+                <a:cs typeface="Be Vietnam Pro" pitchFamily="34" charset="-120"/>
+              </a:rPr>
+              <a:t> trả</a:t>
+            </a:r>
+            <a:r>
+              <a:rPr lang="en-US" sz="1800" dirty="0" spc="-1" kern="0">
+                <a:solidFill>
+                  <a:srgbClr val="6B6A66"/>
+                </a:solidFill>
+                <a:latin typeface="Be Vietnam Pro" pitchFamily="34" charset="0"/>
+                <a:ea typeface="Be Vietnam Pro" pitchFamily="34" charset="-122"/>
+                <a:cs typeface="Be Vietnam Pro" pitchFamily="34" charset="-120"/>
+              </a:rPr>
+              <a:t> lời</a:t>
+            </a:r>
+            <a:r>
+              <a:rPr lang="en-US" sz="1800" dirty="0" spc="-18" kern="0">
+                <a:solidFill>
+                  <a:srgbClr val="6B6A66"/>
+                </a:solidFill>
+                <a:latin typeface="Be Vietnam Pro" pitchFamily="34" charset="0"/>
+                <a:ea typeface="Be Vietnam Pro" pitchFamily="34" charset="-122"/>
+                <a:cs typeface="Be Vietnam Pro" pitchFamily="34" charset="-120"/>
+              </a:rPr>
+              <a:t> yêu</a:t>
+            </a:r>
+            <a:r>
               <a:rPr lang="en-US" sz="1800" dirty="0" spc="0" kern="0">
                 <a:solidFill>
                   <a:srgbClr val="6B6A66"/>
@@ -8021,10 +8186,10 @@
                 <a:ea typeface="Be Vietnam Pro" pitchFamily="34" charset="-122"/>
                 <a:cs typeface="Be Vietnam Pro" pitchFamily="34" charset="-120"/>
               </a:rPr>
-              <a:t> giữ</a:t>
-            </a:r>
-            <a:r>
-              <a:rPr lang="en-US" sz="1800" dirty="0" spc="-13" kern="0">
+              <a:t> cầu</a:t>
+            </a:r>
+            <a:r>
+              <a:rPr lang="en-US" sz="1800" dirty="0" spc="-4" kern="0">
                 <a:solidFill>
                   <a:srgbClr val="6B6A66"/>
                 </a:solidFill>
@@ -8032,10 +8197,10 @@
                 <a:ea typeface="Be Vietnam Pro" pitchFamily="34" charset="-122"/>
                 <a:cs typeface="Be Vietnam Pro" pitchFamily="34" charset="-120"/>
               </a:rPr>
-              <a:t> trang</a:t>
-            </a:r>
-            <a:r>
-              <a:rPr lang="en-US" sz="1800" dirty="0" spc="-7" kern="0">
+              <a:t> bằng</a:t>
+            </a:r>
+            <a:r>
+              <a:rPr lang="en-US" sz="1800" dirty="0" spc="-1" kern="0">
                 <a:solidFill>
                   <a:srgbClr val="6B6A66"/>
                 </a:solidFill>
@@ -8043,10 +8208,10 @@
                 <a:ea typeface="Be Vietnam Pro" pitchFamily="34" charset="-122"/>
                 <a:cs typeface="Be Vietnam Pro" pitchFamily="34" charset="-120"/>
               </a:rPr>
-              <a:t> web</a:t>
-            </a:r>
-            <a:r>
-              <a:rPr lang="en-US" sz="1800" dirty="0" spc="-11" kern="0">
+              <a:t> nội</a:t>
+            </a:r>
+            <a:r>
+              <a:rPr lang="en-US" sz="1800" dirty="0" spc="-4" kern="0">
                 <a:solidFill>
                   <a:srgbClr val="6B6A66"/>
                 </a:solidFill>
@@ -8054,10 +8219,10 @@
                 <a:ea typeface="Be Vietnam Pro" pitchFamily="34" charset="-122"/>
                 <a:cs typeface="Be Vietnam Pro" pitchFamily="34" charset="-120"/>
               </a:rPr>
-              <a:t> và</a:t>
-            </a:r>
-            <a:r>
-              <a:rPr lang="en-US" sz="1800" dirty="0" spc="28" kern="0">
+              <a:t> dung</a:t>
+            </a:r>
+            <a:r>
+              <a:rPr lang="en-US" sz="1800" dirty="0" spc="3" kern="0">
                 <a:solidFill>
                   <a:srgbClr val="6B6A66"/>
                 </a:solidFill>
@@ -8065,10 +8230,10 @@
                 <a:ea typeface="Be Vietnam Pro" pitchFamily="34" charset="-122"/>
                 <a:cs typeface="Be Vietnam Pro" pitchFamily="34" charset="-120"/>
               </a:rPr>
-              <a:t> gửi</a:t>
-            </a:r>
-            <a:r>
-              <a:rPr lang="en-US" sz="1800" dirty="0" spc="-1" kern="0">
+              <a:t> của</a:t>
+            </a:r>
+            <a:r>
+              <a:rPr lang="en-US" sz="1800" dirty="0" spc="-10" kern="0">
                 <a:solidFill>
                   <a:srgbClr val="6B6A66"/>
                 </a:solidFill>
@@ -8076,29 +8241,7 @@
                 <a:ea typeface="Be Vietnam Pro" pitchFamily="34" charset="-122"/>
                 <a:cs typeface="Be Vietnam Pro" pitchFamily="34" charset="-120"/>
               </a:rPr>
-              <a:t> nội</a:t>
-            </a:r>
-            <a:r>
-              <a:rPr lang="en-US" sz="1800" dirty="0" spc="-3" kern="0">
-                <a:solidFill>
-                  <a:srgbClr val="6B6A66"/>
-                </a:solidFill>
-                <a:latin typeface="Be Vietnam Pro" pitchFamily="34" charset="0"/>
-                <a:ea typeface="Be Vietnam Pro" pitchFamily="34" charset="-122"/>
-                <a:cs typeface="Be Vietnam Pro" pitchFamily="34" charset="-120"/>
-              </a:rPr>
-              <a:t> dung</a:t>
-            </a:r>
-            <a:r>
-              <a:rPr lang="en-US" sz="1800" dirty="0" spc="19" kern="0">
-                <a:solidFill>
-                  <a:srgbClr val="6B6A66"/>
-                </a:solidFill>
-                <a:latin typeface="Be Vietnam Pro" pitchFamily="34" charset="0"/>
-                <a:ea typeface="Be Vietnam Pro" pitchFamily="34" charset="-122"/>
-                <a:cs typeface="Be Vietnam Pro" pitchFamily="34" charset="-120"/>
-              </a:rPr>
-              <a:t> đi.</a:t>
+              <a:t> trang.</a:t>
             </a:r>
             <a:endParaRPr lang="en-US" sz="1800" dirty="0"/>
           </a:p>
@@ -8754,7 +8897,7 @@
               <a:t>Giữ</a:t>
             </a:r>
             <a:r>
-              <a:rPr lang="en-US" sz="3300" b="1" dirty="0" spc="-6" kern="0">
+              <a:rPr lang="en-US" sz="3300" b="1" dirty="0" spc="-1" kern="0">
                 <a:solidFill>
                   <a:srgbClr val="1F3FD1"/>
                 </a:solidFill>
@@ -8762,7 +8905,7 @@
                 <a:ea typeface="Be Vietnam Pro" pitchFamily="34" charset="-122"/>
                 <a:cs typeface="Be Vietnam Pro" pitchFamily="34" charset="-120"/>
               </a:rPr>
-              <a:t> nội</a:t>
+              <a:t> bản</a:t>
             </a:r>
             <a:r>
               <a:rPr lang="en-US" sz="3300" b="1" dirty="0" spc="-4" kern="0">
@@ -8773,18 +8916,7 @@
                 <a:ea typeface="Be Vietnam Pro" pitchFamily="34" charset="-122"/>
                 <a:cs typeface="Be Vietnam Pro" pitchFamily="34" charset="-120"/>
               </a:rPr>
-              <a:t> dung</a:t>
-            </a:r>
-            <a:r>
-              <a:rPr lang="en-US" sz="3300" b="1" dirty="0" spc="-12" kern="0">
-                <a:solidFill>
-                  <a:srgbClr val="1F3FD1"/>
-                </a:solidFill>
-                <a:latin typeface="Be Vietnam Pro" pitchFamily="34" charset="0"/>
-                <a:ea typeface="Be Vietnam Pro" pitchFamily="34" charset="-122"/>
-                <a:cs typeface="Be Vietnam Pro" pitchFamily="34" charset="-120"/>
-              </a:rPr>
-              <a:t> gốc</a:t>
+              <a:t> chính</a:t>
             </a:r>
             <a:endParaRPr lang="en-US" sz="3300" dirty="0"/>
           </a:p>
@@ -8818,6 +8950,17 @@
               <a:buNone/>
             </a:pPr>
             <a:r>
+              <a:rPr lang="en-US" sz="2850" dirty="0" spc="-40" kern="0">
+                <a:solidFill>
+                  <a:srgbClr val="14161C"/>
+                </a:solidFill>
+                <a:latin typeface="Be Vietnam Pro" pitchFamily="34" charset="0"/>
+                <a:ea typeface="Be Vietnam Pro" pitchFamily="34" charset="-122"/>
+                <a:cs typeface="Be Vietnam Pro" pitchFamily="34" charset="-120"/>
+              </a:rPr>
+              <a:t>Lớp</a:t>
+            </a:r>
+            <a:r>
               <a:rPr lang="en-US" sz="2850" dirty="0" spc="-1" kern="0">
                 <a:solidFill>
                   <a:srgbClr val="14161C"/>
@@ -8826,84 +8969,7 @@
                 <a:ea typeface="Be Vietnam Pro" pitchFamily="34" charset="-122"/>
                 <a:cs typeface="Be Vietnam Pro" pitchFamily="34" charset="-120"/>
               </a:rPr>
-              <a:t>Nội</a:t>
-            </a:r>
-            <a:r>
-              <a:rPr lang="en-US" sz="2850" dirty="0" spc="-2" kern="0">
-                <a:solidFill>
-                  <a:srgbClr val="14161C"/>
-                </a:solidFill>
-                <a:latin typeface="Be Vietnam Pro" pitchFamily="34" charset="0"/>
-                <a:ea typeface="Be Vietnam Pro" pitchFamily="34" charset="-122"/>
-                <a:cs typeface="Be Vietnam Pro" pitchFamily="34" charset="-120"/>
-              </a:rPr>
-              <a:t> dung</a:t>
-            </a:r>
-            <a:r>
-              <a:rPr lang="en-US" sz="2850" dirty="0" spc="9" kern="0">
-                <a:solidFill>
-                  <a:srgbClr val="14161C"/>
-                </a:solidFill>
-                <a:latin typeface="Be Vietnam Pro" pitchFamily="34" charset="0"/>
-                <a:ea typeface="Be Vietnam Pro" pitchFamily="34" charset="-122"/>
-                <a:cs typeface="Be Vietnam Pro" pitchFamily="34" charset="-120"/>
-              </a:rPr>
-              <a:t> được</a:t>
-            </a:r>
-            <a:r>
-              <a:rPr lang="en-US" sz="2850" dirty="0" spc="25" kern="0">
-                <a:solidFill>
-                  <a:srgbClr val="14161C"/>
-                </a:solidFill>
-                <a:latin typeface="Be Vietnam Pro" pitchFamily="34" charset="0"/>
-                <a:ea typeface="Be Vietnam Pro" pitchFamily="34" charset="-122"/>
-                <a:cs typeface="Be Vietnam Pro" pitchFamily="34" charset="-120"/>
-              </a:rPr>
-              <a:t> lưu</a:t>
-            </a:r>
-            <a:r>
-              <a:rPr lang="en-US" sz="2850" dirty="0" spc="-1" kern="0">
-                <a:solidFill>
-                  <a:srgbClr val="14161C"/>
-                </a:solidFill>
-                <a:latin typeface="Be Vietnam Pro" pitchFamily="34" charset="0"/>
-                <a:ea typeface="Be Vietnam Pro" pitchFamily="34" charset="-122"/>
-                <a:cs typeface="Be Vietnam Pro" pitchFamily="34" charset="-120"/>
-              </a:rPr>
-              <a:t> nhớ</a:t>
-            </a:r>
-            <a:r>
-              <a:rPr lang="en-US" sz="2850" dirty="0" spc="-16" kern="0">
-                <a:solidFill>
-                  <a:srgbClr val="14161C"/>
-                </a:solidFill>
-                <a:latin typeface="Be Vietnam Pro" pitchFamily="34" charset="0"/>
-                <a:ea typeface="Be Vietnam Pro" pitchFamily="34" charset="-122"/>
-                <a:cs typeface="Be Vietnam Pro" pitchFamily="34" charset="-120"/>
-              </a:rPr>
-              <a:t> tạm và</a:t>
-            </a:r>
-            <a:r>
-              <a:rPr lang="en-US" sz="2850" dirty="0" spc="-13" kern="0">
-                <a:solidFill>
-                  <a:srgbClr val="14161C"/>
-                </a:solidFill>
-                <a:latin typeface="Be Vietnam Pro" pitchFamily="34" charset="0"/>
-                <a:ea typeface="Be Vietnam Pro" pitchFamily="34" charset="-122"/>
-                <a:cs typeface="Be Vietnam Pro" pitchFamily="34" charset="-120"/>
-              </a:rPr>
-              <a:t> phát</a:t>
-            </a:r>
-            <a:r>
-              <a:rPr lang="en-US" sz="2850" dirty="0" spc="-15" kern="0">
-                <a:solidFill>
-                  <a:srgbClr val="14161C"/>
-                </a:solidFill>
-                <a:latin typeface="Be Vietnam Pro" pitchFamily="34" charset="0"/>
-                <a:ea typeface="Be Vietnam Pro" pitchFamily="34" charset="-122"/>
-                <a:cs typeface="Be Vietnam Pro" pitchFamily="34" charset="-120"/>
-              </a:rPr>
-              <a:t> tới</a:t>
+              <a:t> phân</a:t>
             </a:r>
             <a:r>
               <a:rPr lang="en-US" sz="2850" dirty="0" spc="0" kern="0">
@@ -8914,29 +8980,18 @@
                 <a:ea typeface="Be Vietnam Pro" pitchFamily="34" charset="-122"/>
                 <a:cs typeface="Be Vietnam Pro" pitchFamily="34" charset="-120"/>
               </a:rPr>
-              <a:t> các</a:t>
-            </a:r>
-            <a:r>
-              <a:rPr lang="en-US" sz="2850" dirty="0" spc="-11" kern="0">
-                <a:solidFill>
-                  <a:srgbClr val="14161C"/>
-                </a:solidFill>
-                <a:latin typeface="Be Vietnam Pro" pitchFamily="34" charset="0"/>
-                <a:ea typeface="Be Vietnam Pro" pitchFamily="34" charset="-122"/>
-                <a:cs typeface="Be Vietnam Pro" pitchFamily="34" charset="-120"/>
-              </a:rPr>
-              <a:t> máy</a:t>
-            </a:r>
-            <a:r>
-              <a:rPr lang="en-US" sz="2850" dirty="0" spc="-1" kern="0">
-                <a:solidFill>
-                  <a:srgbClr val="14161C"/>
-                </a:solidFill>
-                <a:latin typeface="Be Vietnam Pro" pitchFamily="34" charset="0"/>
-                <a:ea typeface="Be Vietnam Pro" pitchFamily="34" charset="-122"/>
-                <a:cs typeface="Be Vietnam Pro" pitchFamily="34" charset="-120"/>
-              </a:rPr>
-              <a:t> chủ</a:t>
+              <a:t> phối</a:t>
+            </a:r>
+            <a:r>
+              <a:rPr lang="en-US" sz="2850" dirty="0" spc="1" kern="0">
+                <a:solidFill>
+                  <a:srgbClr val="14161C"/>
+                </a:solidFill>
+                <a:latin typeface="Be Vietnam Pro" pitchFamily="34" charset="0"/>
+                <a:ea typeface="Be Vietnam Pro" pitchFamily="34" charset="-122"/>
+                <a:cs typeface="Be Vietnam Pro" pitchFamily="34" charset="-120"/>
+              </a:rPr>
+              <a:t> như</a:t>
             </a:r>
             <a:r>
               <a:rPr lang="en-US" sz="2850" dirty="0" spc="0" kern="0">
@@ -8947,7 +9002,62 @@
                 <a:ea typeface="Be Vietnam Pro" pitchFamily="34" charset="-122"/>
                 <a:cs typeface="Be Vietnam Pro" pitchFamily="34" charset="-120"/>
               </a:rPr>
-              <a:t> biên.</a:t>
+              <a:t> CDN giữ</a:t>
+            </a:r>
+            <a:r>
+              <a:rPr lang="en-US" sz="2850" dirty="0" spc="-5" kern="0">
+                <a:solidFill>
+                  <a:srgbClr val="14161C"/>
+                </a:solidFill>
+                <a:latin typeface="Be Vietnam Pro" pitchFamily="34" charset="0"/>
+                <a:ea typeface="Be Vietnam Pro" pitchFamily="34" charset="-122"/>
+                <a:cs typeface="Be Vietnam Pro" pitchFamily="34" charset="-120"/>
+              </a:rPr>
+              <a:t> bản</a:t>
+            </a:r>
+            <a:r>
+              <a:rPr lang="en-US" sz="2850" dirty="0" spc="-4" kern="0">
+                <a:solidFill>
+                  <a:srgbClr val="14161C"/>
+                </a:solidFill>
+                <a:latin typeface="Be Vietnam Pro" pitchFamily="34" charset="0"/>
+                <a:ea typeface="Be Vietnam Pro" pitchFamily="34" charset="-122"/>
+                <a:cs typeface="Be Vietnam Pro" pitchFamily="34" charset="-120"/>
+              </a:rPr>
+              <a:t> sao</a:t>
+            </a:r>
+            <a:r>
+              <a:rPr lang="en-US" sz="2850" dirty="0" spc="1" kern="0">
+                <a:solidFill>
+                  <a:srgbClr val="14161C"/>
+                </a:solidFill>
+                <a:latin typeface="Be Vietnam Pro" pitchFamily="34" charset="0"/>
+                <a:ea typeface="Be Vietnam Pro" pitchFamily="34" charset="-122"/>
+                <a:cs typeface="Be Vietnam Pro" pitchFamily="34" charset="-120"/>
+              </a:rPr>
+              <a:t> ở</a:t>
+            </a:r>
+            <a:r>
+              <a:rPr lang="en-US" sz="2850" dirty="0" spc="0" kern="0">
+                <a:solidFill>
+                  <a:srgbClr val="14161C"/>
+                </a:solidFill>
+                <a:latin typeface="Be Vietnam Pro" pitchFamily="34" charset="0"/>
+                <a:ea typeface="Be Vietnam Pro" pitchFamily="34" charset="-122"/>
+                <a:cs typeface="Be Vietnam Pro" pitchFamily="34" charset="-120"/>
+              </a:rPr>
+              <a:t> nhiều</a:t>
+            </a:r>
+            <a:r>
+              <a:rPr lang="en-US" sz="2850" dirty="0" spc="2" kern="0">
+                <a:solidFill>
+                  <a:srgbClr val="14161C"/>
+                </a:solidFill>
+                <a:latin typeface="Be Vietnam Pro" pitchFamily="34" charset="0"/>
+                <a:ea typeface="Be Vietnam Pro" pitchFamily="34" charset="-122"/>
+                <a:cs typeface="Be Vietnam Pro" pitchFamily="34" charset="-120"/>
+              </a:rPr>
+              <a:t> nơi.</a:t>
             </a:r>
             <a:endParaRPr lang="en-US" sz="2850" dirty="0"/>
           </a:p>
@@ -8993,6 +9103,39 @@
               <a:t>Để</a:t>
             </a:r>
             <a:r>
+              <a:rPr lang="en-US" sz="2250" b="1" dirty="0" spc="-5" kern="0">
+                <a:solidFill>
+                  <a:srgbClr val="F3EEE3"/>
+                </a:solidFill>
+                <a:latin typeface="Be Vietnam Pro" pitchFamily="34" charset="0"/>
+                <a:ea typeface="Be Vietnam Pro" pitchFamily="34" charset="-122"/>
+                <a:cs typeface="Be Vietnam Pro" pitchFamily="34" charset="-120"/>
+              </a:rPr>
+              <a:t> máy</a:t>
+            </a:r>
+            <a:r>
+              <a:rPr lang="en-US" sz="2250" b="1" dirty="0" spc="4" kern="0">
+                <a:solidFill>
+                  <a:srgbClr val="F3EEE3"/>
+                </a:solidFill>
+                <a:latin typeface="Be Vietnam Pro" pitchFamily="34" charset="0"/>
+                <a:ea typeface="Be Vietnam Pro" pitchFamily="34" charset="-122"/>
+                <a:cs typeface="Be Vietnam Pro" pitchFamily="34" charset="-120"/>
+              </a:rPr>
+              <a:t> ở</a:t>
+            </a:r>
+            <a:r>
+              <a:rPr lang="en-US" sz="2250" b="1" dirty="0" spc="-3" kern="0">
+                <a:solidFill>
+                  <a:srgbClr val="F3EEE3"/>
+                </a:solidFill>
+                <a:latin typeface="Be Vietnam Pro" pitchFamily="34" charset="0"/>
+                <a:ea typeface="Be Vietnam Pro" pitchFamily="34" charset="-122"/>
+                <a:cs typeface="Be Vietnam Pro" pitchFamily="34" charset="-120"/>
+              </a:rPr>
+              <a:t> gần</a:t>
+            </a:r>
+            <a:r>
               <a:rPr lang="en-US" sz="2250" b="1" dirty="0" spc="9" kern="0">
                 <a:solidFill>
                   <a:srgbClr val="F3EEE3"/>
@@ -9004,7 +9147,7 @@
               <a:t> người</a:t>
             </a:r>
             <a:r>
-              <a:rPr lang="en-US" sz="2250" b="1" dirty="0" spc="-3" kern="0">
+              <a:rPr lang="en-US" sz="2250" b="1" dirty="0" spc="-2" kern="0">
                 <a:solidFill>
                   <a:srgbClr val="F3EEE3"/>
                 </a:solidFill>
@@ -9015,7 +9158,7 @@
               <a:t> dùng</a:t>
             </a:r>
             <a:r>
-              <a:rPr lang="en-US" sz="2250" b="1" dirty="0" spc="0" kern="0">
+              <a:rPr lang="en-US" sz="2250" b="1" dirty="0" spc="-10" kern="0">
                 <a:solidFill>
                   <a:srgbClr val="F3EEE3"/>
                 </a:solidFill>
@@ -9023,10 +9166,10 @@
                 <a:ea typeface="Be Vietnam Pro" pitchFamily="34" charset="-122"/>
                 <a:cs typeface="Be Vietnam Pro" pitchFamily="34" charset="-120"/>
               </a:rPr>
-              <a:t> nhận</a:t>
-            </a:r>
-            <a:r>
-              <a:rPr lang="en-US" sz="2250" b="1" dirty="0" spc="1" kern="0">
+              <a:t> trả</a:t>
+            </a:r>
+            <a:r>
+              <a:rPr lang="en-US" sz="2250" b="1" dirty="0" spc="4" kern="0">
                 <a:solidFill>
                   <a:srgbClr val="F3EEE3"/>
                 </a:solidFill>
@@ -9034,18 +9177,7 @@
                 <a:ea typeface="Be Vietnam Pro" pitchFamily="34" charset="-122"/>
                 <a:cs typeface="Be Vietnam Pro" pitchFamily="34" charset="-120"/>
               </a:rPr>
-              <a:t> nhanh</a:t>
-            </a:r>
-            <a:r>
-              <a:rPr lang="en-US" sz="2250" b="1" dirty="0" spc="0" kern="0">
-                <a:solidFill>
-                  <a:srgbClr val="F3EEE3"/>
-                </a:solidFill>
-                <a:latin typeface="Be Vietnam Pro" pitchFamily="34" charset="0"/>
-                <a:ea typeface="Be Vietnam Pro" pitchFamily="34" charset="-122"/>
-                <a:cs typeface="Be Vietnam Pro" pitchFamily="34" charset="-120"/>
-              </a:rPr>
-              <a:t> hơn</a:t>
+              <a:t> lời</a:t>
             </a:r>
             <a:endParaRPr lang="en-US" sz="2250" dirty="0"/>
           </a:p>
@@ -9162,17 +9294,6 @@
               <a:t>Gốc</a:t>
             </a:r>
             <a:r>
-              <a:rPr lang="en-US" sz="2700" dirty="0" spc="-1" kern="0">
-                <a:solidFill>
-                  <a:srgbClr val="14161C"/>
-                </a:solidFill>
-                <a:latin typeface="Be Vietnam Pro" pitchFamily="34" charset="0"/>
-                <a:ea typeface="Be Vietnam Pro" pitchFamily="34" charset="-122"/>
-                <a:cs typeface="Be Vietnam Pro" pitchFamily="34" charset="-120"/>
-              </a:rPr>
-              <a:t> là</a:t>
-            </a:r>
-            <a:r>
               <a:rPr lang="en-US" sz="2700" dirty="0" spc="-2" kern="0">
                 <a:solidFill>
                   <a:srgbClr val="14161C"/>
@@ -9181,7 +9302,18 @@
                 <a:ea typeface="Be Vietnam Pro" pitchFamily="34" charset="-122"/>
                 <a:cs typeface="Be Vietnam Pro" pitchFamily="34" charset="-120"/>
               </a:rPr>
-              <a:t> nguồn</a:t>
+              <a:t> giữ</a:t>
+            </a:r>
+            <a:r>
+              <a:rPr lang="en-US" sz="2700" dirty="0" spc="-6" kern="0">
+                <a:solidFill>
+                  <a:srgbClr val="14161C"/>
+                </a:solidFill>
+                <a:latin typeface="Be Vietnam Pro" pitchFamily="34" charset="0"/>
+                <a:ea typeface="Be Vietnam Pro" pitchFamily="34" charset="-122"/>
+                <a:cs typeface="Be Vietnam Pro" pitchFamily="34" charset="-120"/>
+              </a:rPr>
+              <a:t> bản</a:t>
             </a:r>
             <a:r>
               <a:rPr lang="en-US" sz="2700" dirty="0" spc="0" kern="0">
@@ -9192,95 +9324,40 @@
                 <a:ea typeface="Be Vietnam Pro" pitchFamily="34" charset="-122"/>
                 <a:cs typeface="Be Vietnam Pro" pitchFamily="34" charset="-120"/>
               </a:rPr>
-              <a:t> trung</a:t>
-            </a:r>
-            <a:r>
-              <a:rPr lang="en-US" sz="2700" dirty="0" spc="-10" kern="0">
-                <a:solidFill>
-                  <a:srgbClr val="14161C"/>
-                </a:solidFill>
-                <a:latin typeface="Be Vietnam Pro" pitchFamily="34" charset="0"/>
-                <a:ea typeface="Be Vietnam Pro" pitchFamily="34" charset="-122"/>
-                <a:cs typeface="Be Vietnam Pro" pitchFamily="34" charset="-120"/>
-              </a:rPr>
-              <a:t> tâm;</a:t>
-            </a:r>
-            <a:r>
-              <a:rPr lang="en-US" sz="2700" dirty="0" spc="-3" kern="0">
-                <a:solidFill>
-                  <a:srgbClr val="14161C"/>
-                </a:solidFill>
-                <a:latin typeface="Be Vietnam Pro" pitchFamily="34" charset="0"/>
-                <a:ea typeface="Be Vietnam Pro" pitchFamily="34" charset="-122"/>
-                <a:cs typeface="Be Vietnam Pro" pitchFamily="34" charset="-120"/>
-              </a:rPr>
-              <a:t> biên</a:t>
-            </a:r>
-            <a:r>
-              <a:rPr lang="en-US" sz="2700" dirty="0" spc="0" kern="0">
-                <a:solidFill>
-                  <a:srgbClr val="14161C"/>
-                </a:solidFill>
-                <a:latin typeface="Be Vietnam Pro" pitchFamily="34" charset="0"/>
-                <a:ea typeface="Be Vietnam Pro" pitchFamily="34" charset="-122"/>
-                <a:cs typeface="Be Vietnam Pro" pitchFamily="34" charset="-120"/>
-              </a:rPr>
-              <a:t> là</a:t>
-            </a:r>
-            <a:r>
-              <a:rPr lang="en-US" sz="2700" dirty="0" spc="-3" kern="0">
-                <a:solidFill>
-                  <a:srgbClr val="14161C"/>
-                </a:solidFill>
-                <a:latin typeface="Be Vietnam Pro" pitchFamily="34" charset="0"/>
-                <a:ea typeface="Be Vietnam Pro" pitchFamily="34" charset="-122"/>
-                <a:cs typeface="Be Vietnam Pro" pitchFamily="34" charset="-120"/>
-              </a:rPr>
-              <a:t> nơi</a:t>
-            </a:r>
-            <a:r>
-              <a:rPr lang="en-US" sz="2700" dirty="0" spc="-11" kern="0">
-                <a:solidFill>
-                  <a:srgbClr val="14161C"/>
-                </a:solidFill>
-                <a:latin typeface="Be Vietnam Pro" pitchFamily="34" charset="0"/>
-                <a:ea typeface="Be Vietnam Pro" pitchFamily="34" charset="-122"/>
-                <a:cs typeface="Be Vietnam Pro" pitchFamily="34" charset="-120"/>
-              </a:rPr>
-              <a:t> phát</a:t>
-            </a:r>
-            <a:r>
-              <a:rPr lang="en-US" sz="2700" dirty="0" spc="-13" kern="0">
-                <a:solidFill>
-                  <a:srgbClr val="14161C"/>
-                </a:solidFill>
-                <a:latin typeface="Be Vietnam Pro" pitchFamily="34" charset="0"/>
-                <a:ea typeface="Be Vietnam Pro" pitchFamily="34" charset="-122"/>
-                <a:cs typeface="Be Vietnam Pro" pitchFamily="34" charset="-120"/>
-              </a:rPr>
-              <a:t> tới</a:t>
-            </a:r>
-            <a:r>
-              <a:rPr lang="en-US" sz="2700" dirty="0" spc="6" kern="0">
-                <a:solidFill>
-                  <a:srgbClr val="14161C"/>
-                </a:solidFill>
-                <a:latin typeface="Be Vietnam Pro" pitchFamily="34" charset="0"/>
-                <a:ea typeface="Be Vietnam Pro" pitchFamily="34" charset="-122"/>
-                <a:cs typeface="Be Vietnam Pro" pitchFamily="34" charset="-120"/>
-              </a:rPr>
-              <a:t> người</a:t>
-            </a:r>
-            <a:r>
-              <a:rPr lang="en-US" sz="2700" dirty="0" spc="-3" kern="0">
-                <a:solidFill>
-                  <a:srgbClr val="14161C"/>
-                </a:solidFill>
-                <a:latin typeface="Be Vietnam Pro" pitchFamily="34" charset="0"/>
-                <a:ea typeface="Be Vietnam Pro" pitchFamily="34" charset="-122"/>
-                <a:cs typeface="Be Vietnam Pro" pitchFamily="34" charset="-120"/>
-              </a:rPr>
-              <a:t> dùng.</a:t>
+              <a:t> chính;</a:t>
+            </a:r>
+            <a:r>
+              <a:rPr lang="en-US" sz="2700" dirty="0" spc="-2" kern="0">
+                <a:solidFill>
+                  <a:srgbClr val="14161C"/>
+                </a:solidFill>
+                <a:latin typeface="Be Vietnam Pro" pitchFamily="34" charset="0"/>
+                <a:ea typeface="Be Vietnam Pro" pitchFamily="34" charset="-122"/>
+                <a:cs typeface="Be Vietnam Pro" pitchFamily="34" charset="-120"/>
+              </a:rPr>
+              <a:t> lớp phân phối giữ</a:t>
+            </a:r>
+            <a:r>
+              <a:rPr lang="en-US" sz="2700" dirty="0" spc="-6" kern="0">
+                <a:solidFill>
+                  <a:srgbClr val="14161C"/>
+                </a:solidFill>
+                <a:latin typeface="Be Vietnam Pro" pitchFamily="34" charset="0"/>
+                <a:ea typeface="Be Vietnam Pro" pitchFamily="34" charset="-122"/>
+                <a:cs typeface="Be Vietnam Pro" pitchFamily="34" charset="-120"/>
+              </a:rPr>
+              <a:t> bản</a:t>
+            </a:r>
+            <a:r>
+              <a:rPr lang="en-US" sz="2700" dirty="0" spc="-9" kern="0">
+                <a:solidFill>
+                  <a:srgbClr val="14161C"/>
+                </a:solidFill>
+                <a:latin typeface="Be Vietnam Pro" pitchFamily="34" charset="0"/>
+                <a:ea typeface="Be Vietnam Pro" pitchFamily="34" charset="-122"/>
+                <a:cs typeface="Be Vietnam Pro" pitchFamily="34" charset="-120"/>
+              </a:rPr>
+              <a:t> sao.</a:t>
             </a:r>
             <a:endParaRPr lang="en-US" sz="2700" dirty="0"/>
           </a:p>
@@ -9478,7 +9555,7 @@
               <a:buNone/>
             </a:pPr>
             <a:r>
-              <a:rPr lang="en-US" sz="1950" b="1" dirty="0" spc="35" kern="0">
+              <a:rPr lang="en-US" sz="1950" b="1" dirty="0" spc="-3" kern="0">
                 <a:solidFill>
                   <a:srgbClr val="1F3FD1"/>
                 </a:solidFill>
@@ -9486,29 +9563,7 @@
                 <a:ea typeface="Be Vietnam Pro" pitchFamily="34" charset="-122"/>
                 <a:cs typeface="Be Vietnam Pro" pitchFamily="34" charset="-120"/>
               </a:rPr>
-              <a:t>lưu</a:t>
-            </a:r>
-            <a:r>
-              <a:rPr lang="en-US" sz="1950" b="1" dirty="0" spc="-4" kern="0">
-                <a:solidFill>
-                  <a:srgbClr val="1F3FD1"/>
-                </a:solidFill>
-                <a:latin typeface="Be Vietnam Pro" pitchFamily="34" charset="0"/>
-                <a:ea typeface="Be Vietnam Pro" pitchFamily="34" charset="-122"/>
-                <a:cs typeface="Be Vietnam Pro" pitchFamily="34" charset="-120"/>
-              </a:rPr>
-              <a:t> nhớ</a:t>
-            </a:r>
-            <a:r>
-              <a:rPr lang="en-US" sz="1950" b="1" dirty="0" spc="-1" kern="0">
-                <a:solidFill>
-                  <a:srgbClr val="1F3FD1"/>
-                </a:solidFill>
-                <a:latin typeface="Be Vietnam Pro" pitchFamily="34" charset="0"/>
-                <a:ea typeface="Be Vietnam Pro" pitchFamily="34" charset="-122"/>
-                <a:cs typeface="Be Vietnam Pro" pitchFamily="34" charset="-120"/>
-              </a:rPr>
-              <a:t> tạm</a:t>
+              <a:t>sao chép</a:t>
             </a:r>
             <a:endParaRPr lang="en-US" sz="1950" dirty="0"/>
           </a:p>
@@ -9548,15 +9603,15 @@
               <a:buNone/>
             </a:pPr>
             <a:r>
-              <a:rPr lang="en-US" sz="2250" b="1" dirty="0" spc="-11" kern="0">
-                <a:solidFill>
-                  <a:srgbClr val="14161C"/>
-                </a:solidFill>
-                <a:latin typeface="Be Vietnam Pro" pitchFamily="34" charset="0"/>
-                <a:ea typeface="Be Vietnam Pro" pitchFamily="34" charset="-122"/>
-                <a:cs typeface="Be Vietnam Pro" pitchFamily="34" charset="-120"/>
-              </a:rPr>
-              <a:t>Máy</a:t>
+              <a:rPr lang="en-US" sz="2250" b="1" dirty="0" spc="1" kern="0">
+                <a:solidFill>
+                  <a:srgbClr val="14161C"/>
+                </a:solidFill>
+                <a:latin typeface="Be Vietnam Pro" pitchFamily="34" charset="0"/>
+                <a:ea typeface="Be Vietnam Pro" pitchFamily="34" charset="-122"/>
+                <a:cs typeface="Be Vietnam Pro" pitchFamily="34" charset="-120"/>
+              </a:rPr>
+              <a:t>Bản</a:t>
             </a:r>
             <a:r>
               <a:rPr lang="en-US" sz="2250" b="1" dirty="0" spc="4" kern="0">
@@ -9567,18 +9622,7 @@
                 <a:ea typeface="Be Vietnam Pro" pitchFamily="34" charset="-122"/>
                 <a:cs typeface="Be Vietnam Pro" pitchFamily="34" charset="-120"/>
               </a:rPr>
-              <a:t> chủ</a:t>
-            </a:r>
-            <a:r>
-              <a:rPr lang="en-US" sz="2250" b="1" dirty="0" spc="-1" kern="0">
-                <a:solidFill>
-                  <a:srgbClr val="14161C"/>
-                </a:solidFill>
-                <a:latin typeface="Be Vietnam Pro" pitchFamily="34" charset="0"/>
-                <a:ea typeface="Be Vietnam Pro" pitchFamily="34" charset="-122"/>
-                <a:cs typeface="Be Vietnam Pro" pitchFamily="34" charset="-120"/>
-              </a:rPr>
-              <a:t> biên</a:t>
+              <a:t> sao</a:t>
             </a:r>
             <a:endParaRPr lang="en-US" sz="2250" dirty="0"/>
           </a:p>
@@ -9618,15 +9662,15 @@
               <a:buNone/>
             </a:pPr>
             <a:r>
-              <a:rPr lang="en-US" sz="2250" b="1" dirty="0" spc="-11" kern="0">
-                <a:solidFill>
-                  <a:srgbClr val="14161C"/>
-                </a:solidFill>
-                <a:latin typeface="Be Vietnam Pro" pitchFamily="34" charset="0"/>
-                <a:ea typeface="Be Vietnam Pro" pitchFamily="34" charset="-122"/>
-                <a:cs typeface="Be Vietnam Pro" pitchFamily="34" charset="-120"/>
-              </a:rPr>
-              <a:t>Máy</a:t>
+              <a:rPr lang="en-US" sz="2250" b="1" dirty="0" spc="1" kern="0">
+                <a:solidFill>
+                  <a:srgbClr val="14161C"/>
+                </a:solidFill>
+                <a:latin typeface="Be Vietnam Pro" pitchFamily="34" charset="0"/>
+                <a:ea typeface="Be Vietnam Pro" pitchFamily="34" charset="-122"/>
+                <a:cs typeface="Be Vietnam Pro" pitchFamily="34" charset="-120"/>
+              </a:rPr>
+              <a:t>Bản</a:t>
             </a:r>
             <a:r>
               <a:rPr lang="en-US" sz="2250" b="1" dirty="0" spc="4" kern="0">
@@ -9637,18 +9681,7 @@
                 <a:ea typeface="Be Vietnam Pro" pitchFamily="34" charset="-122"/>
                 <a:cs typeface="Be Vietnam Pro" pitchFamily="34" charset="-120"/>
               </a:rPr>
-              <a:t> chủ</a:t>
-            </a:r>
-            <a:r>
-              <a:rPr lang="en-US" sz="2250" b="1" dirty="0" spc="-1" kern="0">
-                <a:solidFill>
-                  <a:srgbClr val="14161C"/>
-                </a:solidFill>
-                <a:latin typeface="Be Vietnam Pro" pitchFamily="34" charset="0"/>
-                <a:ea typeface="Be Vietnam Pro" pitchFamily="34" charset="-122"/>
-                <a:cs typeface="Be Vietnam Pro" pitchFamily="34" charset="-120"/>
-              </a:rPr>
-              <a:t> biên</a:t>
+              <a:t> sao</a:t>
             </a:r>
             <a:endParaRPr lang="en-US" sz="2250" dirty="0"/>
           </a:p>
@@ -9688,15 +9721,15 @@
               <a:buNone/>
             </a:pPr>
             <a:r>
-              <a:rPr lang="en-US" sz="2250" b="1" dirty="0" spc="-11" kern="0">
-                <a:solidFill>
-                  <a:srgbClr val="14161C"/>
-                </a:solidFill>
-                <a:latin typeface="Be Vietnam Pro" pitchFamily="34" charset="0"/>
-                <a:ea typeface="Be Vietnam Pro" pitchFamily="34" charset="-122"/>
-                <a:cs typeface="Be Vietnam Pro" pitchFamily="34" charset="-120"/>
-              </a:rPr>
-              <a:t>Máy</a:t>
+              <a:rPr lang="en-US" sz="2250" b="1" dirty="0" spc="1" kern="0">
+                <a:solidFill>
+                  <a:srgbClr val="14161C"/>
+                </a:solidFill>
+                <a:latin typeface="Be Vietnam Pro" pitchFamily="34" charset="0"/>
+                <a:ea typeface="Be Vietnam Pro" pitchFamily="34" charset="-122"/>
+                <a:cs typeface="Be Vietnam Pro" pitchFamily="34" charset="-120"/>
+              </a:rPr>
+              <a:t>Bản</a:t>
             </a:r>
             <a:r>
               <a:rPr lang="en-US" sz="2250" b="1" dirty="0" spc="4" kern="0">
@@ -9707,18 +9740,7 @@
                 <a:ea typeface="Be Vietnam Pro" pitchFamily="34" charset="-122"/>
                 <a:cs typeface="Be Vietnam Pro" pitchFamily="34" charset="-120"/>
               </a:rPr>
-              <a:t> chủ</a:t>
-            </a:r>
-            <a:r>
-              <a:rPr lang="en-US" sz="2250" b="1" dirty="0" spc="-1" kern="0">
-                <a:solidFill>
-                  <a:srgbClr val="14161C"/>
-                </a:solidFill>
-                <a:latin typeface="Be Vietnam Pro" pitchFamily="34" charset="0"/>
-                <a:ea typeface="Be Vietnam Pro" pitchFamily="34" charset="-122"/>
-                <a:cs typeface="Be Vietnam Pro" pitchFamily="34" charset="-120"/>
-              </a:rPr>
-              <a:t> biên</a:t>
+              <a:t> sao</a:t>
             </a:r>
             <a:endParaRPr lang="en-US" sz="2250" dirty="0"/>
           </a:p>
@@ -9824,7 +9846,7 @@
               <a:buNone/>
             </a:pPr>
             <a:r>
-              <a:rPr lang="en-US" sz="1950" b="1" dirty="0" spc="-7" kern="0">
+              <a:rPr lang="en-US" sz="1950" b="1" dirty="0" spc="-11" kern="0">
                 <a:solidFill>
                   <a:srgbClr val="1F3FD1"/>
                 </a:solidFill>
@@ -9832,7 +9854,7 @@
                 <a:ea typeface="Be Vietnam Pro" pitchFamily="34" charset="-122"/>
                 <a:cs typeface="Be Vietnam Pro" pitchFamily="34" charset="-120"/>
               </a:rPr>
-              <a:t>phát</a:t>
+              <a:t>trả</a:t>
             </a:r>
             <a:r>
               <a:rPr lang="en-US" sz="1950" b="1" dirty="0" spc="0" kern="0">
@@ -9843,7 +9865,7 @@
                 <a:ea typeface="Be Vietnam Pro" pitchFamily="34" charset="-122"/>
                 <a:cs typeface="Be Vietnam Pro" pitchFamily="34" charset="-120"/>
               </a:rPr>
-              <a:t> tới</a:t>
+              <a:t> lời</a:t>
             </a:r>
             <a:endParaRPr lang="en-US" sz="1950" dirty="0"/>
           </a:p>
@@ -10083,6 +10105,17 @@
               <a:t> giữ</a:t>
             </a:r>
             <a:r>
+              <a:rPr lang="en-US" sz="1950" dirty="0" spc="-3" kern="0">
+                <a:solidFill>
+                  <a:srgbClr val="6B6A66"/>
+                </a:solidFill>
+                <a:latin typeface="Be Vietnam Pro" pitchFamily="34" charset="0"/>
+                <a:ea typeface="Be Vietnam Pro" pitchFamily="34" charset="-122"/>
+                <a:cs typeface="Be Vietnam Pro" pitchFamily="34" charset="-120"/>
+              </a:rPr>
+              <a:t> bản</a:t>
+            </a:r>
+            <a:r>
               <a:rPr lang="en-US" sz="1950" dirty="0" spc="0" kern="0">
                 <a:solidFill>
                   <a:srgbClr val="6B6A66"/>
@@ -10091,7 +10124,62 @@
                 <a:ea typeface="Be Vietnam Pro" pitchFamily="34" charset="-122"/>
                 <a:cs typeface="Be Vietnam Pro" pitchFamily="34" charset="-120"/>
               </a:rPr>
-              <a:t> nội</a:t>
+              <a:t> chính;</a:t>
+            </a:r>
+            <a:r>
+              <a:rPr lang="en-US" sz="1950" dirty="0" spc="-7" kern="0">
+                <a:solidFill>
+                  <a:srgbClr val="6B6A66"/>
+                </a:solidFill>
+                <a:latin typeface="Be Vietnam Pro" pitchFamily="34" charset="0"/>
+                <a:ea typeface="Be Vietnam Pro" pitchFamily="34" charset="-122"/>
+                <a:cs typeface="Be Vietnam Pro" pitchFamily="34" charset="-120"/>
+              </a:rPr>
+              <a:t> máy</a:t>
+            </a:r>
+            <a:r>
+              <a:rPr lang="en-US" sz="1950" dirty="0" spc="-1" kern="0">
+                <a:solidFill>
+                  <a:srgbClr val="6B6A66"/>
+                </a:solidFill>
+                <a:latin typeface="Be Vietnam Pro" pitchFamily="34" charset="0"/>
+                <a:ea typeface="Be Vietnam Pro" pitchFamily="34" charset="-122"/>
+                <a:cs typeface="Be Vietnam Pro" pitchFamily="34" charset="-120"/>
+              </a:rPr>
+              <a:t> chủ</a:t>
+            </a:r>
+            <a:r>
+              <a:rPr lang="en-US" sz="1950" dirty="0" spc="-3" kern="0">
+                <a:solidFill>
+                  <a:srgbClr val="6B6A66"/>
+                </a:solidFill>
+                <a:latin typeface="Be Vietnam Pro" pitchFamily="34" charset="0"/>
+                <a:ea typeface="Be Vietnam Pro" pitchFamily="34" charset="-122"/>
+                <a:cs typeface="Be Vietnam Pro" pitchFamily="34" charset="-120"/>
+              </a:rPr>
+              <a:t> ở lớp</a:t>
+            </a:r>
+            <a:r>
+              <a:rPr lang="en-US" sz="1950" dirty="0" spc="0" kern="0">
+                <a:solidFill>
+                  <a:srgbClr val="6B6A66"/>
+                </a:solidFill>
+                <a:latin typeface="Be Vietnam Pro" pitchFamily="34" charset="0"/>
+                <a:ea typeface="Be Vietnam Pro" pitchFamily="34" charset="-122"/>
+                <a:cs typeface="Be Vietnam Pro" pitchFamily="34" charset="-120"/>
+              </a:rPr>
+              <a:t> phân</a:t>
+            </a:r>
+            <a:r>
+              <a:rPr lang="en-US" sz="1950" dirty="0" spc="-2" kern="0">
+                <a:solidFill>
+                  <a:srgbClr val="6B6A66"/>
+                </a:solidFill>
+                <a:latin typeface="Be Vietnam Pro" pitchFamily="34" charset="0"/>
+                <a:ea typeface="Be Vietnam Pro" pitchFamily="34" charset="-122"/>
+                <a:cs typeface="Be Vietnam Pro" pitchFamily="34" charset="-120"/>
+              </a:rPr>
+              <a:t> phối</a:t>
             </a:r>
             <a:r>
               <a:rPr lang="en-US" sz="1950" dirty="0" spc="2" kern="0">
@@ -10102,10 +10190,10 @@
                 <a:ea typeface="Be Vietnam Pro" pitchFamily="34" charset="-122"/>
                 <a:cs typeface="Be Vietnam Pro" pitchFamily="34" charset="-120"/>
               </a:rPr>
-              <a:t> dung</a:t>
-            </a:r>
-            <a:r>
-              <a:rPr lang="en-US" sz="1950" dirty="0" spc="1" kern="0">
+              <a:t> giữ</a:t>
+            </a:r>
+            <a:r>
+              <a:rPr lang="en-US" sz="1950" dirty="0" spc="-3" kern="0">
                 <a:solidFill>
                   <a:srgbClr val="6B6A66"/>
                 </a:solidFill>
@@ -10113,10 +10201,10 @@
                 <a:ea typeface="Be Vietnam Pro" pitchFamily="34" charset="-122"/>
                 <a:cs typeface="Be Vietnam Pro" pitchFamily="34" charset="-120"/>
               </a:rPr>
-              <a:t> trung</a:t>
-            </a:r>
-            <a:r>
-              <a:rPr lang="en-US" sz="1950" dirty="0" spc="-7" kern="0">
+              <a:t> bản</a:t>
+            </a:r>
+            <a:r>
+              <a:rPr lang="en-US" sz="1950" dirty="0" spc="-4" kern="0">
                 <a:solidFill>
                   <a:srgbClr val="6B6A66"/>
                 </a:solidFill>
@@ -10124,95 +10212,7 @@
                 <a:ea typeface="Be Vietnam Pro" pitchFamily="34" charset="-122"/>
                 <a:cs typeface="Be Vietnam Pro" pitchFamily="34" charset="-120"/>
               </a:rPr>
-              <a:t> tâm; máy</a:t>
-            </a:r>
-            <a:r>
-              <a:rPr lang="en-US" sz="1950" dirty="0" spc="-1" kern="0">
-                <a:solidFill>
-                  <a:srgbClr val="6B6A66"/>
-                </a:solidFill>
-                <a:latin typeface="Be Vietnam Pro" pitchFamily="34" charset="0"/>
-                <a:ea typeface="Be Vietnam Pro" pitchFamily="34" charset="-122"/>
-                <a:cs typeface="Be Vietnam Pro" pitchFamily="34" charset="-120"/>
-              </a:rPr>
-              <a:t> chủ</a:t>
-            </a:r>
-            <a:r>
-              <a:rPr lang="en-US" sz="1950" dirty="0" spc="0" kern="0">
-                <a:solidFill>
-                  <a:srgbClr val="6B6A66"/>
-                </a:solidFill>
-                <a:latin typeface="Be Vietnam Pro" pitchFamily="34" charset="0"/>
-                <a:ea typeface="Be Vietnam Pro" pitchFamily="34" charset="-122"/>
-                <a:cs typeface="Be Vietnam Pro" pitchFamily="34" charset="-120"/>
-              </a:rPr>
-              <a:t> biên</a:t>
-            </a:r>
-            <a:r>
-              <a:rPr lang="en-US" sz="1950" dirty="0" spc="2" kern="0">
-                <a:solidFill>
-                  <a:srgbClr val="6B6A66"/>
-                </a:solidFill>
-                <a:latin typeface="Be Vietnam Pro" pitchFamily="34" charset="0"/>
-                <a:ea typeface="Be Vietnam Pro" pitchFamily="34" charset="-122"/>
-                <a:cs typeface="Be Vietnam Pro" pitchFamily="34" charset="-120"/>
-              </a:rPr>
-              <a:t> giữ</a:t>
-            </a:r>
-            <a:r>
-              <a:rPr lang="en-US" sz="1950" dirty="0" spc="-3" kern="0">
-                <a:solidFill>
-                  <a:srgbClr val="6B6A66"/>
-                </a:solidFill>
-                <a:latin typeface="Be Vietnam Pro" pitchFamily="34" charset="0"/>
-                <a:ea typeface="Be Vietnam Pro" pitchFamily="34" charset="-122"/>
-                <a:cs typeface="Be Vietnam Pro" pitchFamily="34" charset="-120"/>
-              </a:rPr>
-              <a:t> bản</a:t>
-            </a:r>
-            <a:r>
-              <a:rPr lang="en-US" sz="1950" dirty="0" spc="13" kern="0">
-                <a:solidFill>
-                  <a:srgbClr val="6B6A66"/>
-                </a:solidFill>
-                <a:latin typeface="Be Vietnam Pro" pitchFamily="34" charset="0"/>
-                <a:ea typeface="Be Vietnam Pro" pitchFamily="34" charset="-122"/>
-                <a:cs typeface="Be Vietnam Pro" pitchFamily="34" charset="-120"/>
-              </a:rPr>
-              <a:t> đã</a:t>
-            </a:r>
-            <a:r>
-              <a:rPr lang="en-US" sz="1950" dirty="0" spc="14" kern="0">
-                <a:solidFill>
-                  <a:srgbClr val="6B6A66"/>
-                </a:solidFill>
-                <a:latin typeface="Be Vietnam Pro" pitchFamily="34" charset="0"/>
-                <a:ea typeface="Be Vietnam Pro" pitchFamily="34" charset="-122"/>
-                <a:cs typeface="Be Vietnam Pro" pitchFamily="34" charset="-120"/>
-              </a:rPr>
-              <a:t> lưu</a:t>
-            </a:r>
-            <a:r>
-              <a:rPr lang="en-US" sz="1950" dirty="0" spc="0" kern="0">
-                <a:solidFill>
-                  <a:srgbClr val="6B6A66"/>
-                </a:solidFill>
-                <a:latin typeface="Be Vietnam Pro" pitchFamily="34" charset="0"/>
-                <a:ea typeface="Be Vietnam Pro" pitchFamily="34" charset="-122"/>
-                <a:cs typeface="Be Vietnam Pro" pitchFamily="34" charset="-120"/>
-              </a:rPr>
-              <a:t> nhớ</a:t>
-            </a:r>
-            <a:r>
-              <a:rPr lang="en-US" sz="1950" dirty="0" spc="-9" kern="0">
-                <a:solidFill>
-                  <a:srgbClr val="6B6A66"/>
-                </a:solidFill>
-                <a:latin typeface="Be Vietnam Pro" pitchFamily="34" charset="0"/>
-                <a:ea typeface="Be Vietnam Pro" pitchFamily="34" charset="-122"/>
-                <a:cs typeface="Be Vietnam Pro" pitchFamily="34" charset="-120"/>
-              </a:rPr>
-              <a:t> tạm.</a:t>
+              <a:t> sao.</a:t>
             </a:r>
             <a:endParaRPr lang="en-US" sz="1950" dirty="0"/>
           </a:p>
@@ -10921,15 +10921,81 @@
               <a:buNone/>
             </a:pPr>
             <a:r>
-              <a:rPr lang="en-US" sz="2850" dirty="0" spc="-39" kern="0">
-                <a:solidFill>
-                  <a:srgbClr val="14161C"/>
-                </a:solidFill>
-                <a:latin typeface="Be Vietnam Pro" pitchFamily="34" charset="0"/>
-                <a:ea typeface="Be Vietnam Pro" pitchFamily="34" charset="-122"/>
-                <a:cs typeface="Be Vietnam Pro" pitchFamily="34" charset="-120"/>
-              </a:rPr>
-              <a:t>Làm</a:t>
+              <a:rPr lang="en-US" sz="2850" dirty="0" spc="-3" kern="0">
+                <a:solidFill>
+                  <a:srgbClr val="14161C"/>
+                </a:solidFill>
+                <a:latin typeface="Be Vietnam Pro" pitchFamily="34" charset="0"/>
+                <a:ea typeface="Be Vietnam Pro" pitchFamily="34" charset="-122"/>
+                <a:cs typeface="Be Vietnam Pro" pitchFamily="34" charset="-120"/>
+              </a:rPr>
+              <a:t>Chặn</a:t>
+            </a:r>
+            <a:r>
+              <a:rPr lang="en-US" sz="2850" dirty="0" spc="-24" kern="0">
+                <a:solidFill>
+                  <a:srgbClr val="14161C"/>
+                </a:solidFill>
+                <a:latin typeface="Be Vietnam Pro" pitchFamily="34" charset="0"/>
+                <a:ea typeface="Be Vietnam Pro" pitchFamily="34" charset="-122"/>
+                <a:cs typeface="Be Vietnam Pro" pitchFamily="34" charset="-120"/>
+              </a:rPr>
+              <a:t> yêu</a:t>
+            </a:r>
+            <a:r>
+              <a:rPr lang="en-US" sz="2850" dirty="0" spc="1" kern="0">
+                <a:solidFill>
+                  <a:srgbClr val="14161C"/>
+                </a:solidFill>
+                <a:latin typeface="Be Vietnam Pro" pitchFamily="34" charset="0"/>
+                <a:ea typeface="Be Vietnam Pro" pitchFamily="34" charset="-122"/>
+                <a:cs typeface="Be Vietnam Pro" pitchFamily="34" charset="-120"/>
+              </a:rPr>
+              <a:t> cầu</a:t>
+            </a:r>
+            <a:r>
+              <a:rPr lang="en-US" sz="2850" dirty="0" spc="-27" kern="0">
+                <a:solidFill>
+                  <a:srgbClr val="14161C"/>
+                </a:solidFill>
+                <a:latin typeface="Be Vietnam Pro" pitchFamily="34" charset="0"/>
+                <a:ea typeface="Be Vietnam Pro" pitchFamily="34" charset="-122"/>
+                <a:cs typeface="Be Vietnam Pro" pitchFamily="34" charset="-120"/>
+              </a:rPr>
+              <a:t> rồi trả</a:t>
+            </a:r>
+            <a:r>
+              <a:rPr lang="en-US" sz="2850" dirty="0" spc="1" kern="0">
+                <a:solidFill>
+                  <a:srgbClr val="14161C"/>
+                </a:solidFill>
+                <a:latin typeface="Be Vietnam Pro" pitchFamily="34" charset="0"/>
+                <a:ea typeface="Be Vietnam Pro" pitchFamily="34" charset="-122"/>
+                <a:cs typeface="Be Vietnam Pro" pitchFamily="34" charset="-120"/>
+              </a:rPr>
+              <a:t> lời,</a:t>
+            </a:r>
+            <a:r>
+              <a:rPr lang="en-US" sz="2850" dirty="0" spc="-15" kern="0">
+                <a:solidFill>
+                  <a:srgbClr val="14161C"/>
+                </a:solidFill>
+                <a:latin typeface="Be Vietnam Pro" pitchFamily="34" charset="0"/>
+                <a:ea typeface="Be Vietnam Pro" pitchFamily="34" charset="-122"/>
+                <a:cs typeface="Be Vietnam Pro" pitchFamily="34" charset="-120"/>
+              </a:rPr>
+              <a:t> chuyển</a:t>
+            </a:r>
+            <a:r>
+              <a:rPr lang="en-US" sz="2850" dirty="0" spc="40" kern="0">
+                <a:solidFill>
+                  <a:srgbClr val="14161C"/>
+                </a:solidFill>
+                <a:latin typeface="Be Vietnam Pro" pitchFamily="34" charset="0"/>
+                <a:ea typeface="Be Vietnam Pro" pitchFamily="34" charset="-122"/>
+                <a:cs typeface="Be Vietnam Pro" pitchFamily="34" charset="-120"/>
+              </a:rPr>
+              <a:t> đi</a:t>
             </a:r>
             <a:r>
               <a:rPr lang="en-US" sz="2850" dirty="0" spc="-2" kern="0">
@@ -10940,117 +11006,18 @@
                 <a:ea typeface="Be Vietnam Pro" pitchFamily="34" charset="-122"/>
                 <a:cs typeface="Be Vietnam Pro" pitchFamily="34" charset="-120"/>
               </a:rPr>
-              <a:t> cổng</a:t>
-            </a:r>
-            <a:r>
-              <a:rPr lang="en-US" sz="2850" dirty="0" spc="-1" kern="0">
-                <a:solidFill>
-                  <a:srgbClr val="14161C"/>
-                </a:solidFill>
-                <a:latin typeface="Be Vietnam Pro" pitchFamily="34" charset="0"/>
-                <a:ea typeface="Be Vietnam Pro" pitchFamily="34" charset="-122"/>
-                <a:cs typeface="Be Vietnam Pro" pitchFamily="34" charset="-120"/>
-              </a:rPr>
-              <a:t> trung</a:t>
-            </a:r>
-            <a:r>
-              <a:rPr lang="en-US" sz="2850" dirty="0" spc="1" kern="0">
-                <a:solidFill>
-                  <a:srgbClr val="14161C"/>
-                </a:solidFill>
-                <a:latin typeface="Be Vietnam Pro" pitchFamily="34" charset="0"/>
-                <a:ea typeface="Be Vietnam Pro" pitchFamily="34" charset="-122"/>
-                <a:cs typeface="Be Vietnam Pro" pitchFamily="34" charset="-120"/>
-              </a:rPr>
-              <a:t> gian</a:t>
-            </a:r>
-            <a:r>
-              <a:rPr lang="en-US" sz="2850" dirty="0" spc="9" kern="0">
-                <a:solidFill>
-                  <a:srgbClr val="14161C"/>
-                </a:solidFill>
-                <a:latin typeface="Be Vietnam Pro" pitchFamily="34" charset="0"/>
-                <a:ea typeface="Be Vietnam Pro" pitchFamily="34" charset="-122"/>
-                <a:cs typeface="Be Vietnam Pro" pitchFamily="34" charset="-120"/>
-              </a:rPr>
-              <a:t> giữa</a:t>
-            </a:r>
-            <a:r>
-              <a:rPr lang="en-US" sz="2850" dirty="0" spc="-11" kern="0">
-                <a:solidFill>
-                  <a:srgbClr val="14161C"/>
-                </a:solidFill>
-                <a:latin typeface="Be Vietnam Pro" pitchFamily="34" charset="0"/>
-                <a:ea typeface="Be Vietnam Pro" pitchFamily="34" charset="-122"/>
-                <a:cs typeface="Be Vietnam Pro" pitchFamily="34" charset="-120"/>
-              </a:rPr>
-              <a:t> máy</a:t>
-            </a:r>
-            <a:r>
-              <a:rPr lang="en-US" sz="2850" dirty="0" spc="-1" kern="0">
-                <a:solidFill>
-                  <a:srgbClr val="14161C"/>
-                </a:solidFill>
-                <a:latin typeface="Be Vietnam Pro" pitchFamily="34" charset="0"/>
-                <a:ea typeface="Be Vietnam Pro" pitchFamily="34" charset="-122"/>
-                <a:cs typeface="Be Vietnam Pro" pitchFamily="34" charset="-120"/>
-              </a:rPr>
-              <a:t> khách</a:t>
-            </a:r>
-            <a:r>
-              <a:rPr lang="en-US" sz="2850" dirty="0" spc="-16" kern="0">
-                <a:solidFill>
-                  <a:srgbClr val="14161C"/>
-                </a:solidFill>
-                <a:latin typeface="Be Vietnam Pro" pitchFamily="34" charset="0"/>
-                <a:ea typeface="Be Vietnam Pro" pitchFamily="34" charset="-122"/>
-                <a:cs typeface="Be Vietnam Pro" pitchFamily="34" charset="-120"/>
-              </a:rPr>
-              <a:t> và</a:t>
-            </a:r>
-            <a:r>
-              <a:rPr lang="en-US" sz="2850" dirty="0" spc="-1" kern="0">
-                <a:solidFill>
-                  <a:srgbClr val="14161C"/>
-                </a:solidFill>
-                <a:latin typeface="Be Vietnam Pro" pitchFamily="34" charset="0"/>
-                <a:ea typeface="Be Vietnam Pro" pitchFamily="34" charset="-122"/>
-                <a:cs typeface="Be Vietnam Pro" pitchFamily="34" charset="-120"/>
-              </a:rPr>
-              <a:t> các</a:t>
-            </a:r>
-            <a:r>
-              <a:rPr lang="en-US" sz="2850" dirty="0" spc="-11" kern="0">
-                <a:solidFill>
-                  <a:srgbClr val="14161C"/>
-                </a:solidFill>
-                <a:latin typeface="Be Vietnam Pro" pitchFamily="34" charset="0"/>
-                <a:ea typeface="Be Vietnam Pro" pitchFamily="34" charset="-122"/>
-                <a:cs typeface="Be Vietnam Pro" pitchFamily="34" charset="-120"/>
-              </a:rPr>
-              <a:t> máy</a:t>
-            </a:r>
-            <a:r>
-              <a:rPr lang="en-US" sz="2850" dirty="0" spc="0" kern="0">
-                <a:solidFill>
-                  <a:srgbClr val="14161C"/>
-                </a:solidFill>
-                <a:latin typeface="Be Vietnam Pro" pitchFamily="34" charset="0"/>
-                <a:ea typeface="Be Vietnam Pro" pitchFamily="34" charset="-122"/>
-                <a:cs typeface="Be Vietnam Pro" pitchFamily="34" charset="-120"/>
-              </a:rPr>
-              <a:t> chủ</a:t>
-            </a:r>
-            <a:r>
-              <a:rPr lang="en-US" sz="2850" dirty="0" spc="-1" kern="0">
-                <a:solidFill>
-                  <a:srgbClr val="14161C"/>
-                </a:solidFill>
-                <a:latin typeface="Be Vietnam Pro" pitchFamily="34" charset="0"/>
-                <a:ea typeface="Be Vietnam Pro" pitchFamily="34" charset="-122"/>
-                <a:cs typeface="Be Vietnam Pro" pitchFamily="34" charset="-120"/>
-              </a:rPr>
-              <a:t> khác.</a:t>
+              <a:t> hoặc</a:t>
+            </a:r>
+            <a:r>
+              <a:rPr lang="en-US" sz="2850" dirty="0" spc="10" kern="0">
+                <a:solidFill>
+                  <a:srgbClr val="14161C"/>
+                </a:solidFill>
+                <a:latin typeface="Be Vietnam Pro" pitchFamily="34" charset="0"/>
+                <a:ea typeface="Be Vietnam Pro" pitchFamily="34" charset="-122"/>
+                <a:cs typeface="Be Vietnam Pro" pitchFamily="34" charset="-120"/>
+              </a:rPr>
+              <a:t> sửa.</a:t>
             </a:r>
             <a:endParaRPr lang="en-US" sz="2850" dirty="0"/>
           </a:p>
@@ -11085,7 +11052,7 @@
               <a:buNone/>
             </a:pPr>
             <a:r>
-              <a:rPr lang="en-US" sz="2250" b="1" dirty="0" spc="-6" kern="0">
+              <a:rPr lang="en-US" sz="2250" b="1" dirty="0" spc="-7" kern="0">
                 <a:solidFill>
                   <a:srgbClr val="F3EEE3"/>
                 </a:solidFill>
@@ -11093,7 +11060,7 @@
                 <a:ea typeface="Be Vietnam Pro" pitchFamily="34" charset="-122"/>
                 <a:cs typeface="Be Vietnam Pro" pitchFamily="34" charset="-120"/>
               </a:rPr>
-              <a:t>Cổng</a:t>
+              <a:t>Bên</a:t>
             </a:r>
             <a:r>
               <a:rPr lang="en-US" sz="2250" b="1" dirty="0" spc="-3" kern="0">
@@ -11221,17 +11188,6 @@
               <a:buNone/>
             </a:pPr>
             <a:r>
-              <a:rPr lang="en-US" sz="2700" dirty="0" spc="-5" kern="0">
-                <a:solidFill>
-                  <a:srgbClr val="14161C"/>
-                </a:solidFill>
-                <a:latin typeface="Be Vietnam Pro" pitchFamily="34" charset="0"/>
-                <a:ea typeface="Be Vietnam Pro" pitchFamily="34" charset="-122"/>
-                <a:cs typeface="Be Vietnam Pro" pitchFamily="34" charset="-120"/>
-              </a:rPr>
-              <a:t>Ba</a:t>
-            </a:r>
-            <a:r>
               <a:rPr lang="en-US" sz="2700" dirty="0" spc="-1" kern="0">
                 <a:solidFill>
                   <a:srgbClr val="14161C"/>
@@ -11240,7 +11196,7 @@
                 <a:ea typeface="Be Vietnam Pro" pitchFamily="34" charset="-122"/>
                 <a:cs typeface="Be Vietnam Pro" pitchFamily="34" charset="-120"/>
               </a:rPr>
-              <a:t> lợi ích</a:t>
+              <a:t>Hai kiểu</a:t>
             </a:r>
             <a:r>
               <a:rPr lang="en-US" sz="2700" dirty="0" spc="-2" kern="0">
@@ -11251,29 +11207,29 @@
                 <a:ea typeface="Be Vietnam Pro" pitchFamily="34" charset="-122"/>
                 <a:cs typeface="Be Vietnam Pro" pitchFamily="34" charset="-120"/>
               </a:rPr>
-              <a:t> nguồn nêu:</a:t>
-            </a:r>
-            <a:r>
-              <a:rPr lang="en-US" sz="2700" dirty="0" spc="-6" kern="0">
-                <a:solidFill>
-                  <a:srgbClr val="14161C"/>
-                </a:solidFill>
-                <a:latin typeface="Be Vietnam Pro" pitchFamily="34" charset="0"/>
-                <a:ea typeface="Be Vietnam Pro" pitchFamily="34" charset="-122"/>
-                <a:cs typeface="Be Vietnam Pro" pitchFamily="34" charset="-120"/>
-              </a:rPr>
-              <a:t> bảo</a:t>
-            </a:r>
-            <a:r>
-              <a:rPr lang="en-US" sz="2700" dirty="0" spc="-10" kern="0">
-                <a:solidFill>
-                  <a:srgbClr val="14161C"/>
-                </a:solidFill>
-                <a:latin typeface="Be Vietnam Pro" pitchFamily="34" charset="0"/>
-                <a:ea typeface="Be Vietnam Pro" pitchFamily="34" charset="-122"/>
-                <a:cs typeface="Be Vietnam Pro" pitchFamily="34" charset="-120"/>
-              </a:rPr>
-              <a:t> mật,</a:t>
+              <a:t> chính:</a:t>
+            </a:r>
+            <a:r>
+              <a:rPr lang="en-US" sz="2700" dirty="0" spc="-34" kern="0">
+                <a:solidFill>
+                  <a:srgbClr val="14161C"/>
+                </a:solidFill>
+                <a:latin typeface="Be Vietnam Pro" pitchFamily="34" charset="0"/>
+                <a:ea typeface="Be Vietnam Pro" pitchFamily="34" charset="-122"/>
+                <a:cs typeface="Be Vietnam Pro" pitchFamily="34" charset="-120"/>
+              </a:rPr>
+              <a:t> proxy</a:t>
+            </a:r>
+            <a:r>
+              <a:rPr lang="en-US" sz="2700" dirty="0" spc="-15" kern="0">
+                <a:solidFill>
+                  <a:srgbClr val="14161C"/>
+                </a:solidFill>
+                <a:latin typeface="Be Vietnam Pro" pitchFamily="34" charset="0"/>
+                <a:ea typeface="Be Vietnam Pro" pitchFamily="34" charset="-122"/>
+                <a:cs typeface="Be Vietnam Pro" pitchFamily="34" charset="-120"/>
+              </a:rPr>
+              <a:t> chuyển</a:t>
             </a:r>
             <a:r>
               <a:rPr lang="en-US" sz="2700" dirty="0" spc="-1" kern="0">
@@ -11284,29 +11240,40 @@
                 <a:ea typeface="Be Vietnam Pro" pitchFamily="34" charset="-122"/>
                 <a:cs typeface="Be Vietnam Pro" pitchFamily="34" charset="-120"/>
               </a:rPr>
-              <a:t> hiệu năng,</a:t>
-            </a:r>
-            <a:r>
-              <a:rPr lang="en-US" sz="2700" dirty="0" spc="-2" kern="0">
-                <a:solidFill>
-                  <a:srgbClr val="14161C"/>
-                </a:solidFill>
-                <a:latin typeface="Be Vietnam Pro" pitchFamily="34" charset="0"/>
-                <a:ea typeface="Be Vietnam Pro" pitchFamily="34" charset="-122"/>
-                <a:cs typeface="Be Vietnam Pro" pitchFamily="34" charset="-120"/>
-              </a:rPr>
-              <a:t> ẩn</a:t>
-            </a:r>
-            <a:r>
-              <a:rPr lang="en-US" sz="2700" dirty="0" spc="-3" kern="0">
-                <a:solidFill>
-                  <a:srgbClr val="14161C"/>
-                </a:solidFill>
-                <a:latin typeface="Be Vietnam Pro" pitchFamily="34" charset="0"/>
-                <a:ea typeface="Be Vietnam Pro" pitchFamily="34" charset="-122"/>
-                <a:cs typeface="Be Vietnam Pro" pitchFamily="34" charset="-120"/>
-              </a:rPr>
-              <a:t> danh.</a:t>
+              <a:t> tiếp</a:t>
+            </a:r>
+            <a:r>
+              <a:rPr lang="en-US" sz="2700" dirty="0" spc="-17" kern="0">
+                <a:solidFill>
+                  <a:srgbClr val="14161C"/>
+                </a:solidFill>
+                <a:latin typeface="Be Vietnam Pro" pitchFamily="34" charset="0"/>
+                <a:ea typeface="Be Vietnam Pro" pitchFamily="34" charset="-122"/>
+                <a:cs typeface="Be Vietnam Pro" pitchFamily="34" charset="-120"/>
+              </a:rPr>
+              <a:t> và</a:t>
+            </a:r>
+            <a:r>
+              <a:rPr lang="en-US" sz="2700" dirty="0" spc="-35" kern="0">
+                <a:solidFill>
+                  <a:srgbClr val="14161C"/>
+                </a:solidFill>
+                <a:latin typeface="Be Vietnam Pro" pitchFamily="34" charset="0"/>
+                <a:ea typeface="Be Vietnam Pro" pitchFamily="34" charset="-122"/>
+                <a:cs typeface="Be Vietnam Pro" pitchFamily="34" charset="-120"/>
+              </a:rPr>
+              <a:t> proxy</a:t>
+            </a:r>
+            <a:r>
+              <a:rPr lang="en-US" sz="2700" dirty="0" spc="6" kern="0">
+                <a:solidFill>
+                  <a:srgbClr val="14161C"/>
+                </a:solidFill>
+                <a:latin typeface="Be Vietnam Pro" pitchFamily="34" charset="0"/>
+                <a:ea typeface="Be Vietnam Pro" pitchFamily="34" charset="-122"/>
+                <a:cs typeface="Be Vietnam Pro" pitchFamily="34" charset="-120"/>
+              </a:rPr>
+              <a:t> ngược.</a:t>
             </a:r>
             <a:endParaRPr lang="en-US" sz="2700" dirty="0"/>
           </a:p>
@@ -11789,7 +11756,7 @@
                 <a:ea typeface="Be Vietnam Pro" pitchFamily="34" charset="-122"/>
                 <a:cs typeface="Be Vietnam Pro" pitchFamily="34" charset="-120"/>
               </a:rPr>
-              <a:t> THỂ THÊM</a:t>
+              <a:t> THỂ</a:t>
             </a:r>
             <a:endParaRPr lang="en-US" sz="1800" dirty="0"/>
           </a:p>
@@ -11829,26 +11796,26 @@
               <a:buNone/>
             </a:pPr>
             <a:r>
-              <a:rPr lang="en-US" sz="2250" b="1" dirty="0" spc="5" kern="0">
-                <a:solidFill>
-                  <a:srgbClr val="14161C"/>
-                </a:solidFill>
-                <a:latin typeface="Be Vietnam Pro" pitchFamily="34" charset="0"/>
-                <a:ea typeface="Be Vietnam Pro" pitchFamily="34" charset="-122"/>
-                <a:cs typeface="Be Vietnam Pro" pitchFamily="34" charset="-120"/>
-              </a:rPr>
-              <a:t>bảo</a:t>
-            </a:r>
-            <a:r>
-              <a:rPr lang="en-US" sz="2250" b="1" dirty="0" spc="-5" kern="0">
-                <a:solidFill>
-                  <a:srgbClr val="14161C"/>
-                </a:solidFill>
-                <a:latin typeface="Be Vietnam Pro" pitchFamily="34" charset="0"/>
-                <a:ea typeface="Be Vietnam Pro" pitchFamily="34" charset="-122"/>
-                <a:cs typeface="Be Vietnam Pro" pitchFamily="34" charset="-120"/>
-              </a:rPr>
-              <a:t> mật</a:t>
+              <a:rPr lang="en-US" sz="2250" b="1" dirty="0" spc="-12" kern="0">
+                <a:solidFill>
+                  <a:srgbClr val="14161C"/>
+                </a:solidFill>
+                <a:latin typeface="Be Vietnam Pro" pitchFamily="34" charset="0"/>
+                <a:ea typeface="Be Vietnam Pro" pitchFamily="34" charset="-122"/>
+                <a:cs typeface="Be Vietnam Pro" pitchFamily="34" charset="-120"/>
+              </a:rPr>
+              <a:t>chuyển</a:t>
+            </a:r>
+            <a:r>
+              <a:rPr lang="en-US" sz="2250" b="1" dirty="0" spc="23" kern="0">
+                <a:solidFill>
+                  <a:srgbClr val="14161C"/>
+                </a:solidFill>
+                <a:latin typeface="Be Vietnam Pro" pitchFamily="34" charset="0"/>
+                <a:ea typeface="Be Vietnam Pro" pitchFamily="34" charset="-122"/>
+                <a:cs typeface="Be Vietnam Pro" pitchFamily="34" charset="-120"/>
+              </a:rPr>
+              <a:t> đi</a:t>
             </a:r>
             <a:endParaRPr lang="en-US" sz="2250" dirty="0"/>
           </a:p>
@@ -11888,6 +11855,17 @@
               <a:buNone/>
             </a:pPr>
             <a:r>
+              <a:rPr lang="en-US" sz="2250" b="1" dirty="0" spc="-15" kern="0">
+                <a:solidFill>
+                  <a:srgbClr val="14161C"/>
+                </a:solidFill>
+                <a:latin typeface="Be Vietnam Pro" pitchFamily="34" charset="0"/>
+                <a:ea typeface="Be Vietnam Pro" pitchFamily="34" charset="-122"/>
+                <a:cs typeface="Be Vietnam Pro" pitchFamily="34" charset="-120"/>
+              </a:rPr>
+              <a:t>trả</a:t>
+            </a:r>
+            <a:r>
               <a:rPr lang="en-US" sz="2250" b="1" dirty="0" spc="2" kern="0">
                 <a:solidFill>
                   <a:srgbClr val="14161C"/>
@@ -11896,18 +11874,29 @@
                 <a:ea typeface="Be Vietnam Pro" pitchFamily="34" charset="-122"/>
                 <a:cs typeface="Be Vietnam Pro" pitchFamily="34" charset="-120"/>
               </a:rPr>
-              <a:t>hiệu</a:t>
-            </a:r>
-            <a:r>
-              <a:rPr lang="en-US" sz="2250" b="1" dirty="0" spc="-5" kern="0">
-                <a:solidFill>
-                  <a:srgbClr val="14161C"/>
-                </a:solidFill>
-                <a:latin typeface="Be Vietnam Pro" pitchFamily="34" charset="0"/>
-                <a:ea typeface="Be Vietnam Pro" pitchFamily="34" charset="-122"/>
-                <a:cs typeface="Be Vietnam Pro" pitchFamily="34" charset="-120"/>
-              </a:rPr>
-              <a:t> năng</a:t>
+              <a:t> từ</a:t>
+            </a:r>
+            <a:r>
+              <a:rPr lang="en-US" sz="2250" b="1" dirty="0" spc="1" kern="0">
+                <a:solidFill>
+                  <a:srgbClr val="14161C"/>
+                </a:solidFill>
+                <a:latin typeface="Be Vietnam Pro" pitchFamily="34" charset="0"/>
+                <a:ea typeface="Be Vietnam Pro" pitchFamily="34" charset="-122"/>
+                <a:cs typeface="Be Vietnam Pro" pitchFamily="34" charset="-120"/>
+              </a:rPr>
+              <a:t> bộ</a:t>
+            </a:r>
+            <a:r>
+              <a:rPr lang="en-US" sz="2250" b="1" dirty="0" spc="4" kern="0">
+                <a:solidFill>
+                  <a:srgbClr val="14161C"/>
+                </a:solidFill>
+                <a:latin typeface="Be Vietnam Pro" pitchFamily="34" charset="0"/>
+                <a:ea typeface="Be Vietnam Pro" pitchFamily="34" charset="-122"/>
+                <a:cs typeface="Be Vietnam Pro" pitchFamily="34" charset="-120"/>
+              </a:rPr>
+              <a:t> đệm</a:t>
             </a:r>
             <a:endParaRPr lang="en-US" sz="2250" dirty="0"/>
           </a:p>
@@ -11947,15 +11936,26 @@
               <a:buNone/>
             </a:pPr>
             <a:r>
-              <a:rPr lang="en-US" sz="2250" b="1" dirty="0" spc="3" kern="0">
-                <a:solidFill>
-                  <a:srgbClr val="14161C"/>
-                </a:solidFill>
-                <a:latin typeface="Be Vietnam Pro" pitchFamily="34" charset="0"/>
-                <a:ea typeface="Be Vietnam Pro" pitchFamily="34" charset="-122"/>
-                <a:cs typeface="Be Vietnam Pro" pitchFamily="34" charset="-120"/>
-              </a:rPr>
-              <a:t>ẩn</a:t>
+              <a:rPr lang="en-US" sz="2250" b="1" dirty="0" spc="17" kern="0">
+                <a:solidFill>
+                  <a:srgbClr val="14161C"/>
+                </a:solidFill>
+                <a:latin typeface="Be Vietnam Pro" pitchFamily="34" charset="0"/>
+                <a:ea typeface="Be Vietnam Pro" pitchFamily="34" charset="-122"/>
+                <a:cs typeface="Be Vietnam Pro" pitchFamily="34" charset="-120"/>
+              </a:rPr>
+              <a:t>sửa</a:t>
+            </a:r>
+            <a:r>
+              <a:rPr lang="en-US" sz="2250" b="1" dirty="0" spc="-15" kern="0">
+                <a:solidFill>
+                  <a:srgbClr val="14161C"/>
+                </a:solidFill>
+                <a:latin typeface="Be Vietnam Pro" pitchFamily="34" charset="0"/>
+                <a:ea typeface="Be Vietnam Pro" pitchFamily="34" charset="-122"/>
+                <a:cs typeface="Be Vietnam Pro" pitchFamily="34" charset="-120"/>
+              </a:rPr>
+              <a:t> yêu</a:t>
             </a:r>
             <a:r>
               <a:rPr lang="en-US" sz="2250" b="1" dirty="0" spc="2" kern="0">
@@ -11966,7 +11966,7 @@
                 <a:ea typeface="Be Vietnam Pro" pitchFamily="34" charset="-122"/>
                 <a:cs typeface="Be Vietnam Pro" pitchFamily="34" charset="-120"/>
               </a:rPr>
-              <a:t> danh</a:t>
+              <a:t> cầu</a:t>
             </a:r>
             <a:endParaRPr lang="en-US" sz="2250" dirty="0"/>
           </a:p>
@@ -12000,6 +12000,94 @@
               <a:buNone/>
             </a:pPr>
             <a:r>
+              <a:rPr lang="en-US" sz="1950" dirty="0" spc="-25" kern="0">
+                <a:solidFill>
+                  <a:srgbClr val="6B6A66"/>
+                </a:solidFill>
+                <a:latin typeface="Be Vietnam Pro" pitchFamily="34" charset="0"/>
+                <a:ea typeface="Be Vietnam Pro" pitchFamily="34" charset="-122"/>
+                <a:cs typeface="Be Vietnam Pro" pitchFamily="34" charset="-120"/>
+              </a:rPr>
+              <a:t>Proxy</a:t>
+            </a:r>
+            <a:r>
+              <a:rPr lang="en-US" sz="1950" dirty="0" spc="4" kern="0">
+                <a:solidFill>
+                  <a:srgbClr val="6B6A66"/>
+                </a:solidFill>
+                <a:latin typeface="Be Vietnam Pro" pitchFamily="34" charset="0"/>
+                <a:ea typeface="Be Vietnam Pro" pitchFamily="34" charset="-122"/>
+                <a:cs typeface="Be Vietnam Pro" pitchFamily="34" charset="-120"/>
+              </a:rPr>
+              <a:t> ngược</a:t>
+            </a:r>
+            <a:r>
+              <a:rPr lang="en-US" sz="1950" dirty="0" spc="-9" kern="0">
+                <a:solidFill>
+                  <a:srgbClr val="6B6A66"/>
+                </a:solidFill>
+                <a:latin typeface="Be Vietnam Pro" pitchFamily="34" charset="0"/>
+                <a:ea typeface="Be Vietnam Pro" pitchFamily="34" charset="-122"/>
+                <a:cs typeface="Be Vietnam Pro" pitchFamily="34" charset="-120"/>
+              </a:rPr>
+              <a:t> chuyển</a:t>
+            </a:r>
+            <a:r>
+              <a:rPr lang="en-US" sz="1950" dirty="0" spc="-17" kern="0">
+                <a:solidFill>
+                  <a:srgbClr val="6B6A66"/>
+                </a:solidFill>
+                <a:latin typeface="Be Vietnam Pro" pitchFamily="34" charset="0"/>
+                <a:ea typeface="Be Vietnam Pro" pitchFamily="34" charset="-122"/>
+                <a:cs typeface="Be Vietnam Pro" pitchFamily="34" charset="-120"/>
+              </a:rPr>
+              <a:t> yêu</a:t>
+            </a:r>
+            <a:r>
+              <a:rPr lang="en-US" sz="1950" dirty="0" spc="-1" kern="0">
+                <a:solidFill>
+                  <a:srgbClr val="6B6A66"/>
+                </a:solidFill>
+                <a:latin typeface="Be Vietnam Pro" pitchFamily="34" charset="0"/>
+                <a:ea typeface="Be Vietnam Pro" pitchFamily="34" charset="-122"/>
+                <a:cs typeface="Be Vietnam Pro" pitchFamily="34" charset="-120"/>
+              </a:rPr>
+              <a:t> cầu từ</a:t>
+            </a:r>
+            <a:r>
+              <a:rPr lang="en-US" sz="1950" dirty="0" spc="-9" kern="0">
+                <a:solidFill>
+                  <a:srgbClr val="6B6A66"/>
+                </a:solidFill>
+                <a:latin typeface="Be Vietnam Pro" pitchFamily="34" charset="0"/>
+                <a:ea typeface="Be Vietnam Pro" pitchFamily="34" charset="-122"/>
+                <a:cs typeface="Be Vietnam Pro" pitchFamily="34" charset="-120"/>
+              </a:rPr>
+              <a:t> Internet</a:t>
+            </a:r>
+            <a:r>
+              <a:rPr lang="en-US" sz="1950" dirty="0" spc="-10" kern="0">
+                <a:solidFill>
+                  <a:srgbClr val="6B6A66"/>
+                </a:solidFill>
+                <a:latin typeface="Be Vietnam Pro" pitchFamily="34" charset="0"/>
+                <a:ea typeface="Be Vietnam Pro" pitchFamily="34" charset="-122"/>
+                <a:cs typeface="Be Vietnam Pro" pitchFamily="34" charset="-120"/>
+              </a:rPr>
+              <a:t> vào</a:t>
+            </a:r>
+            <a:r>
+              <a:rPr lang="en-US" sz="1950" dirty="0" spc="2" kern="0">
+                <a:solidFill>
+                  <a:srgbClr val="6B6A66"/>
+                </a:solidFill>
+                <a:latin typeface="Be Vietnam Pro" pitchFamily="34" charset="0"/>
+                <a:ea typeface="Be Vietnam Pro" pitchFamily="34" charset="-122"/>
+                <a:cs typeface="Be Vietnam Pro" pitchFamily="34" charset="-120"/>
+              </a:rPr>
+              <a:t> mạng</a:t>
+            </a:r>
+            <a:r>
               <a:rPr lang="en-US" sz="1950" dirty="0" spc="1" kern="0">
                 <a:solidFill>
                   <a:srgbClr val="6B6A66"/>
@@ -12008,10 +12096,10 @@
                 <a:ea typeface="Be Vietnam Pro" pitchFamily="34" charset="-122"/>
                 <a:cs typeface="Be Vietnam Pro" pitchFamily="34" charset="-120"/>
               </a:rPr>
-              <a:t>Ẩn</a:t>
-            </a:r>
-            <a:r>
-              <a:rPr lang="en-US" sz="1950" dirty="0" spc="-1" kern="0">
+              <a:t> nội</a:t>
+            </a:r>
+            <a:r>
+              <a:rPr lang="en-US" sz="1950" dirty="0" spc="-6" kern="0">
                 <a:solidFill>
                   <a:srgbClr val="6B6A66"/>
                 </a:solidFill>
@@ -12019,62 +12107,7 @@
                 <a:ea typeface="Be Vietnam Pro" pitchFamily="34" charset="-122"/>
                 <a:cs typeface="Be Vietnam Pro" pitchFamily="34" charset="-120"/>
               </a:rPr>
-              <a:t> danh:</a:t>
-            </a:r>
-            <a:r>
-              <a:rPr lang="en-US" sz="1950" dirty="0" spc="0" kern="0">
-                <a:solidFill>
-                  <a:srgbClr val="6B6A66"/>
-                </a:solidFill>
-                <a:latin typeface="Be Vietnam Pro" pitchFamily="34" charset="0"/>
-                <a:ea typeface="Be Vietnam Pro" pitchFamily="34" charset="-122"/>
-                <a:cs typeface="Be Vietnam Pro" pitchFamily="34" charset="-120"/>
-              </a:rPr>
-              <a:t> che danh</a:t>
-            </a:r>
-            <a:r>
-              <a:rPr lang="en-US" sz="1950" dirty="0" spc="1" kern="0">
-                <a:solidFill>
-                  <a:srgbClr val="6B6A66"/>
-                </a:solidFill>
-                <a:latin typeface="Be Vietnam Pro" pitchFamily="34" charset="0"/>
-                <a:ea typeface="Be Vietnam Pro" pitchFamily="34" charset="-122"/>
-                <a:cs typeface="Be Vietnam Pro" pitchFamily="34" charset="-120"/>
-              </a:rPr>
-              <a:t> tính</a:t>
-            </a:r>
-            <a:r>
-              <a:rPr lang="en-US" sz="1950" dirty="0" spc="-1" kern="0">
-                <a:solidFill>
-                  <a:srgbClr val="6B6A66"/>
-                </a:solidFill>
-                <a:latin typeface="Be Vietnam Pro" pitchFamily="34" charset="0"/>
-                <a:ea typeface="Be Vietnam Pro" pitchFamily="34" charset="-122"/>
-                <a:cs typeface="Be Vietnam Pro" pitchFamily="34" charset="-120"/>
-              </a:rPr>
-              <a:t> của</a:t>
-            </a:r>
-            <a:r>
-              <a:rPr lang="en-US" sz="1950" dirty="0" spc="6" kern="0">
-                <a:solidFill>
-                  <a:srgbClr val="6B6A66"/>
-                </a:solidFill>
-                <a:latin typeface="Be Vietnam Pro" pitchFamily="34" charset="0"/>
-                <a:ea typeface="Be Vietnam Pro" pitchFamily="34" charset="-122"/>
-                <a:cs typeface="Be Vietnam Pro" pitchFamily="34" charset="-120"/>
-              </a:rPr>
-              <a:t> người</a:t>
-            </a:r>
-            <a:r>
-              <a:rPr lang="en-US" sz="1950" dirty="0" spc="-9" kern="0">
-                <a:solidFill>
-                  <a:srgbClr val="6B6A66"/>
-                </a:solidFill>
-                <a:latin typeface="Be Vietnam Pro" pitchFamily="34" charset="0"/>
-                <a:ea typeface="Be Vietnam Pro" pitchFamily="34" charset="-122"/>
-                <a:cs typeface="Be Vietnam Pro" pitchFamily="34" charset="-120"/>
-              </a:rPr>
-              <a:t> gọi.</a:t>
+              <a:t> bộ.</a:t>
             </a:r>
             <a:endParaRPr lang="en-US" sz="1950" dirty="0"/>
           </a:p>
@@ -12794,17 +12827,6 @@
               <a:buNone/>
             </a:pPr>
             <a:r>
-              <a:rPr lang="en-US" sz="2850" dirty="0" spc="8" kern="0">
-                <a:solidFill>
-                  <a:srgbClr val="14161C"/>
-                </a:solidFill>
-                <a:latin typeface="Be Vietnam Pro" pitchFamily="34" charset="0"/>
-                <a:ea typeface="Be Vietnam Pro" pitchFamily="34" charset="-122"/>
-                <a:cs typeface="Be Vietnam Pro" pitchFamily="34" charset="-120"/>
-              </a:rPr>
-              <a:t>Người</a:t>
-            </a:r>
-            <a:r>
               <a:rPr lang="en-US" sz="2850" dirty="0" spc="-3" kern="0">
                 <a:solidFill>
                   <a:srgbClr val="14161C"/>
@@ -12813,7 +12835,51 @@
                 <a:ea typeface="Be Vietnam Pro" pitchFamily="34" charset="-122"/>
                 <a:cs typeface="Be Vietnam Pro" pitchFamily="34" charset="-120"/>
               </a:rPr>
-              <a:t> dùng</a:t>
+              <a:t>Hệ</a:t>
+            </a:r>
+            <a:r>
+              <a:rPr lang="en-US" sz="2850" dirty="0" spc="-2" kern="0">
+                <a:solidFill>
+                  <a:srgbClr val="14161C"/>
+                </a:solidFill>
+                <a:latin typeface="Be Vietnam Pro" pitchFamily="34" charset="0"/>
+                <a:ea typeface="Be Vietnam Pro" pitchFamily="34" charset="-122"/>
+                <a:cs typeface="Be Vietnam Pro" pitchFamily="34" charset="-120"/>
+              </a:rPr>
+              <a:t> thống</a:t>
+            </a:r>
+            <a:r>
+              <a:rPr lang="en-US" sz="2850" dirty="0" spc="-1" kern="0">
+                <a:solidFill>
+                  <a:srgbClr val="14161C"/>
+                </a:solidFill>
+                <a:latin typeface="Be Vietnam Pro" pitchFamily="34" charset="0"/>
+                <a:ea typeface="Be Vietnam Pro" pitchFamily="34" charset="-122"/>
+                <a:cs typeface="Be Vietnam Pro" pitchFamily="34" charset="-120"/>
+              </a:rPr>
+              <a:t> đặt</a:t>
+            </a:r>
+            <a:r>
+              <a:rPr lang="en-US" sz="2850" dirty="0" spc="-16" kern="0">
+                <a:solidFill>
+                  <a:srgbClr val="14161C"/>
+                </a:solidFill>
+                <a:latin typeface="Be Vietnam Pro" pitchFamily="34" charset="0"/>
+                <a:ea typeface="Be Vietnam Pro" pitchFamily="34" charset="-122"/>
+                <a:cs typeface="Be Vietnam Pro" pitchFamily="34" charset="-120"/>
+              </a:rPr>
+              <a:t> tên</a:t>
+            </a:r>
+            <a:r>
+              <a:rPr lang="en-US" sz="2850" dirty="0" spc="-1" kern="0">
+                <a:solidFill>
+                  <a:srgbClr val="14161C"/>
+                </a:solidFill>
+                <a:latin typeface="Be Vietnam Pro" pitchFamily="34" charset="0"/>
+                <a:ea typeface="Be Vietnam Pro" pitchFamily="34" charset="-122"/>
+                <a:cs typeface="Be Vietnam Pro" pitchFamily="34" charset="-120"/>
+              </a:rPr>
+              <a:t> phân cấp</a:t>
             </a:r>
             <a:r>
               <a:rPr lang="en-US" sz="2850" dirty="0" spc="1" kern="0">
@@ -12824,18 +12890,7 @@
                 <a:ea typeface="Be Vietnam Pro" pitchFamily="34" charset="-122"/>
                 <a:cs typeface="Be Vietnam Pro" pitchFamily="34" charset="-120"/>
               </a:rPr>
-              <a:t> truy</a:t>
-            </a:r>
-            <a:r>
-              <a:rPr lang="en-US" sz="2850" dirty="0" spc="0" kern="0">
-                <a:solidFill>
-                  <a:srgbClr val="14161C"/>
-                </a:solidFill>
-                <a:latin typeface="Be Vietnam Pro" pitchFamily="34" charset="0"/>
-                <a:ea typeface="Be Vietnam Pro" pitchFamily="34" charset="-122"/>
-                <a:cs typeface="Be Vietnam Pro" pitchFamily="34" charset="-120"/>
-              </a:rPr>
-              <a:t> cập</a:t>
+              <a:t> của</a:t>
             </a:r>
             <a:r>
               <a:rPr lang="en-US" sz="2850" dirty="0" spc="-16" kern="0">
@@ -12846,40 +12901,7 @@
                 <a:ea typeface="Be Vietnam Pro" pitchFamily="34" charset="-122"/>
                 <a:cs typeface="Be Vietnam Pro" pitchFamily="34" charset="-120"/>
               </a:rPr>
-              <a:t> website</a:t>
-            </a:r>
-            <a:r>
-              <a:rPr lang="en-US" sz="2850" dirty="0" spc="-4" kern="0">
-                <a:solidFill>
-                  <a:srgbClr val="14161C"/>
-                </a:solidFill>
-                <a:latin typeface="Be Vietnam Pro" pitchFamily="34" charset="0"/>
-                <a:ea typeface="Be Vietnam Pro" pitchFamily="34" charset="-122"/>
-                <a:cs typeface="Be Vietnam Pro" pitchFamily="34" charset="-120"/>
-              </a:rPr>
-              <a:t> bằng</a:t>
-            </a:r>
-            <a:r>
-              <a:rPr lang="en-US" sz="2850" dirty="0" spc="-16" kern="0">
-                <a:solidFill>
-                  <a:srgbClr val="14161C"/>
-                </a:solidFill>
-                <a:latin typeface="Be Vietnam Pro" pitchFamily="34" charset="0"/>
-                <a:ea typeface="Be Vietnam Pro" pitchFamily="34" charset="-122"/>
-                <a:cs typeface="Be Vietnam Pro" pitchFamily="34" charset="-120"/>
-              </a:rPr>
-              <a:t> tên</a:t>
-            </a:r>
-            <a:r>
-              <a:rPr lang="en-US" sz="2850" dirty="0" spc="0" kern="0">
-                <a:solidFill>
-                  <a:srgbClr val="14161C"/>
-                </a:solidFill>
-                <a:latin typeface="Be Vietnam Pro" pitchFamily="34" charset="0"/>
-                <a:ea typeface="Be Vietnam Pro" pitchFamily="34" charset="-122"/>
-                <a:cs typeface="Be Vietnam Pro" pitchFamily="34" charset="-120"/>
-              </a:rPr>
-              <a:t> dễ nhớ.</a:t>
+              <a:t> Internet.</a:t>
             </a:r>
             <a:endParaRPr lang="en-US" sz="2850" dirty="0"/>
           </a:p>
@@ -15037,6 +15059,28 @@
               <a:t>FTP</a:t>
             </a:r>
             <a:r>
+              <a:rPr lang="en-US" sz="2700" dirty="0" spc="-2" kern="0">
+                <a:solidFill>
+                  <a:srgbClr val="14161C"/>
+                </a:solidFill>
+                <a:latin typeface="Be Vietnam Pro" pitchFamily="34" charset="0"/>
+                <a:ea typeface="Be Vietnam Pro" pitchFamily="34" charset="-122"/>
+                <a:cs typeface="Be Vietnam Pro" pitchFamily="34" charset="-120"/>
+              </a:rPr>
+              <a:t> không mã</a:t>
+            </a:r>
+            <a:r>
+              <a:rPr lang="en-US" sz="2700" dirty="0" spc="-4" kern="0">
+                <a:solidFill>
+                  <a:srgbClr val="14161C"/>
+                </a:solidFill>
+                <a:latin typeface="Be Vietnam Pro" pitchFamily="34" charset="0"/>
+                <a:ea typeface="Be Vietnam Pro" pitchFamily="34" charset="-122"/>
+                <a:cs typeface="Be Vietnam Pro" pitchFamily="34" charset="-120"/>
+              </a:rPr>
+              <a:t> hóa, nên</a:t>
+            </a:r>
+            <a:r>
               <a:rPr lang="en-US" sz="2700" dirty="0" spc="-1" kern="0">
                 <a:solidFill>
                   <a:srgbClr val="14161C"/>
@@ -15045,106 +15089,51 @@
                 <a:ea typeface="Be Vietnam Pro" pitchFamily="34" charset="-122"/>
                 <a:cs typeface="Be Vietnam Pro" pitchFamily="34" charset="-120"/>
               </a:rPr>
-              <a:t> là quy</a:t>
-            </a:r>
-            <a:r>
-              <a:rPr lang="en-US" sz="2700" dirty="0" spc="11" kern="0">
-                <a:solidFill>
-                  <a:srgbClr val="14161C"/>
-                </a:solidFill>
-                <a:latin typeface="Be Vietnam Pro" pitchFamily="34" charset="0"/>
-                <a:ea typeface="Be Vietnam Pro" pitchFamily="34" charset="-122"/>
-                <a:cs typeface="Be Vietnam Pro" pitchFamily="34" charset="-120"/>
-              </a:rPr>
-              <a:t> ước</a:t>
-            </a:r>
-            <a:r>
-              <a:rPr lang="en-US" sz="2700" dirty="0" spc="-14" kern="0">
-                <a:solidFill>
-                  <a:srgbClr val="14161C"/>
-                </a:solidFill>
-                <a:latin typeface="Be Vietnam Pro" pitchFamily="34" charset="0"/>
-                <a:ea typeface="Be Vietnam Pro" pitchFamily="34" charset="-122"/>
-                <a:cs typeface="Be Vietnam Pro" pitchFamily="34" charset="-120"/>
-              </a:rPr>
-              <a:t> chuyển</a:t>
-            </a:r>
-            <a:r>
-              <a:rPr lang="en-US" sz="2700" dirty="0" spc="-15" kern="0">
-                <a:solidFill>
-                  <a:srgbClr val="14161C"/>
-                </a:solidFill>
-                <a:latin typeface="Be Vietnam Pro" pitchFamily="34" charset="0"/>
-                <a:ea typeface="Be Vietnam Pro" pitchFamily="34" charset="-122"/>
-                <a:cs typeface="Be Vietnam Pro" pitchFamily="34" charset="-120"/>
-              </a:rPr>
-              <a:t> tệp</a:t>
-            </a:r>
-            <a:r>
-              <a:rPr lang="en-US" sz="2700" dirty="0" spc="5" kern="0">
-                <a:solidFill>
-                  <a:srgbClr val="14161C"/>
-                </a:solidFill>
-                <a:latin typeface="Be Vietnam Pro" pitchFamily="34" charset="0"/>
-                <a:ea typeface="Be Vietnam Pro" pitchFamily="34" charset="-122"/>
-                <a:cs typeface="Be Vietnam Pro" pitchFamily="34" charset="-120"/>
-              </a:rPr>
-              <a:t> giữa</a:t>
-            </a:r>
-            <a:r>
-              <a:rPr lang="en-US" sz="2700" dirty="0" spc="-11" kern="0">
-                <a:solidFill>
-                  <a:srgbClr val="14161C"/>
-                </a:solidFill>
-                <a:latin typeface="Be Vietnam Pro" pitchFamily="34" charset="0"/>
-                <a:ea typeface="Be Vietnam Pro" pitchFamily="34" charset="-122"/>
-                <a:cs typeface="Be Vietnam Pro" pitchFamily="34" charset="-120"/>
-              </a:rPr>
-              <a:t> máy</a:t>
-            </a:r>
-            <a:r>
-              <a:rPr lang="en-US" sz="2700" dirty="0" spc="-1" kern="0">
-                <a:solidFill>
-                  <a:srgbClr val="14161C"/>
-                </a:solidFill>
-                <a:latin typeface="Be Vietnam Pro" pitchFamily="34" charset="0"/>
-                <a:ea typeface="Be Vietnam Pro" pitchFamily="34" charset="-122"/>
-                <a:cs typeface="Be Vietnam Pro" pitchFamily="34" charset="-120"/>
-              </a:rPr>
-              <a:t> khách</a:t>
-            </a:r>
-            <a:r>
-              <a:rPr lang="en-US" sz="2700" dirty="0" spc="-16" kern="0">
-                <a:solidFill>
-                  <a:srgbClr val="14161C"/>
-                </a:solidFill>
-                <a:latin typeface="Be Vietnam Pro" pitchFamily="34" charset="0"/>
-                <a:ea typeface="Be Vietnam Pro" pitchFamily="34" charset="-122"/>
-                <a:cs typeface="Be Vietnam Pro" pitchFamily="34" charset="-120"/>
-              </a:rPr>
-              <a:t> và</a:t>
-            </a:r>
-            <a:r>
-              <a:rPr lang="en-US" sz="2700" dirty="0" spc="-12" kern="0">
-                <a:solidFill>
-                  <a:srgbClr val="14161C"/>
-                </a:solidFill>
-                <a:latin typeface="Be Vietnam Pro" pitchFamily="34" charset="0"/>
-                <a:ea typeface="Be Vietnam Pro" pitchFamily="34" charset="-122"/>
-                <a:cs typeface="Be Vietnam Pro" pitchFamily="34" charset="-120"/>
-              </a:rPr>
-              <a:t> máy</a:t>
-            </a:r>
-            <a:r>
-              <a:rPr lang="en-US" sz="2700" dirty="0" spc="-1" kern="0">
-                <a:solidFill>
-                  <a:srgbClr val="14161C"/>
-                </a:solidFill>
-                <a:latin typeface="Be Vietnam Pro" pitchFamily="34" charset="0"/>
-                <a:ea typeface="Be Vietnam Pro" pitchFamily="34" charset="-122"/>
-                <a:cs typeface="Be Vietnam Pro" pitchFamily="34" charset="-120"/>
-              </a:rPr>
-              <a:t> chủ.</a:t>
+              <a:t> nhiều</a:t>
+            </a:r>
+            <a:r>
+              <a:rPr lang="en-US" sz="2700" dirty="0" spc="-3" kern="0">
+                <a:solidFill>
+                  <a:srgbClr val="14161C"/>
+                </a:solidFill>
+                <a:latin typeface="Be Vietnam Pro" pitchFamily="34" charset="0"/>
+                <a:ea typeface="Be Vietnam Pro" pitchFamily="34" charset="-122"/>
+                <a:cs typeface="Be Vietnam Pro" pitchFamily="34" charset="-120"/>
+              </a:rPr>
+              <a:t> nơi</a:t>
+            </a:r>
+            <a:r>
+              <a:rPr lang="en-US" sz="2700" dirty="0" spc="0" kern="0">
+                <a:solidFill>
+                  <a:srgbClr val="14161C"/>
+                </a:solidFill>
+                <a:latin typeface="Be Vietnam Pro" pitchFamily="34" charset="0"/>
+                <a:ea typeface="Be Vietnam Pro" pitchFamily="34" charset="-122"/>
+                <a:cs typeface="Be Vietnam Pro" pitchFamily="34" charset="-120"/>
+              </a:rPr>
+              <a:t> thôi</a:t>
+            </a:r>
+            <a:r>
+              <a:rPr lang="en-US" sz="2700" dirty="0" spc="-3" kern="0">
+                <a:solidFill>
+                  <a:srgbClr val="14161C"/>
+                </a:solidFill>
+                <a:latin typeface="Be Vietnam Pro" pitchFamily="34" charset="0"/>
+                <a:ea typeface="Be Vietnam Pro" pitchFamily="34" charset="-122"/>
+                <a:cs typeface="Be Vietnam Pro" pitchFamily="34" charset="-120"/>
+              </a:rPr>
+              <a:t> hỗ</a:t>
+            </a:r>
+            <a:r>
+              <a:rPr lang="en-US" sz="2700" dirty="0" spc="-23" kern="0">
+                <a:solidFill>
+                  <a:srgbClr val="14161C"/>
+                </a:solidFill>
+                <a:latin typeface="Be Vietnam Pro" pitchFamily="34" charset="0"/>
+                <a:ea typeface="Be Vietnam Pro" pitchFamily="34" charset="-122"/>
+                <a:cs typeface="Be Vietnam Pro" pitchFamily="34" charset="-120"/>
+              </a:rPr>
+              <a:t> trợ.</a:t>
             </a:r>
             <a:endParaRPr lang="en-US" sz="2700" dirty="0"/>
           </a:p>
@@ -15475,7 +15464,7 @@
               <a:buNone/>
             </a:pPr>
             <a:r>
-              <a:rPr lang="en-US" sz="1950" dirty="0" spc="35" kern="0">
+              <a:rPr lang="en-US" sz="1950" dirty="0" spc="3" kern="0">
                 <a:solidFill>
                   <a:srgbClr val="6B6A66"/>
                 </a:solidFill>
@@ -15483,7 +15472,29 @@
                 <a:ea typeface="Be Vietnam Pro" pitchFamily="34" charset="-122"/>
                 <a:cs typeface="Be Vietnam Pro" pitchFamily="34" charset="-120"/>
               </a:rPr>
-              <a:t>gửi,</a:t>
+              <a:t>SMTP</a:t>
+            </a:r>
+            <a:r>
+              <a:rPr lang="en-US" sz="1950" dirty="0" spc="34" kern="0">
+                <a:solidFill>
+                  <a:srgbClr val="6B6A66"/>
+                </a:solidFill>
+                <a:latin typeface="Be Vietnam Pro" pitchFamily="34" charset="0"/>
+                <a:ea typeface="Be Vietnam Pro" pitchFamily="34" charset="-122"/>
+                <a:cs typeface="Be Vietnam Pro" pitchFamily="34" charset="-120"/>
+              </a:rPr>
+              <a:t> gửi</a:t>
+            </a:r>
+            <a:r>
+              <a:rPr lang="en-US" sz="1950" dirty="0" spc="-2" kern="0">
+                <a:solidFill>
+                  <a:srgbClr val="6B6A66"/>
+                </a:solidFill>
+                <a:latin typeface="Be Vietnam Pro" pitchFamily="34" charset="0"/>
+                <a:ea typeface="Be Vietnam Pro" pitchFamily="34" charset="-122"/>
+                <a:cs typeface="Be Vietnam Pro" pitchFamily="34" charset="-120"/>
+              </a:rPr>
+              <a:t> thư</a:t>
             </a:r>
             <a:r>
               <a:rPr lang="en-US" sz="1950" dirty="0" spc="1" kern="0">
@@ -15494,7 +15505,18 @@
                 <a:ea typeface="Be Vietnam Pro" pitchFamily="34" charset="-122"/>
                 <a:cs typeface="Be Vietnam Pro" pitchFamily="34" charset="-120"/>
               </a:rPr>
-              <a:t> nhận</a:t>
+              <a:t> mới; IMAP</a:t>
+            </a:r>
+            <a:r>
+              <a:rPr lang="en-US" sz="1950" dirty="0" spc="-9" kern="0">
+                <a:solidFill>
+                  <a:srgbClr val="6B6A66"/>
+                </a:solidFill>
+                <a:latin typeface="Be Vietnam Pro" pitchFamily="34" charset="0"/>
+                <a:ea typeface="Be Vietnam Pro" pitchFamily="34" charset="-122"/>
+                <a:cs typeface="Be Vietnam Pro" pitchFamily="34" charset="-120"/>
+              </a:rPr>
+              <a:t> lấy</a:t>
             </a:r>
             <a:r>
               <a:rPr lang="en-US" sz="1950" dirty="0" spc="-15" kern="0">
@@ -15508,7 +15530,7 @@
               <a:t> và</a:t>
             </a:r>
             <a:r>
-              <a:rPr lang="en-US" sz="1950" dirty="0" spc="-9" kern="0">
+              <a:rPr lang="en-US" sz="1950" dirty="0" spc="14" kern="0">
                 <a:solidFill>
                   <a:srgbClr val="6B6A66"/>
                 </a:solidFill>
@@ -15516,10 +15538,10 @@
                 <a:ea typeface="Be Vietnam Pro" pitchFamily="34" charset="-122"/>
                 <a:cs typeface="Be Vietnam Pro" pitchFamily="34" charset="-120"/>
               </a:rPr>
-              <a:t> chuyển</a:t>
-            </a:r>
-            <a:r>
-              <a:rPr lang="en-US" sz="1950" dirty="0" spc="-2" kern="0">
+              <a:t> lưu</a:t>
+            </a:r>
+            <a:r>
+              <a:rPr lang="en-US" sz="1950" dirty="0" spc="-1" kern="0">
                 <a:solidFill>
                   <a:srgbClr val="6B6A66"/>
                 </a:solidFill>
@@ -15527,40 +15549,7 @@
                 <a:ea typeface="Be Vietnam Pro" pitchFamily="34" charset="-122"/>
                 <a:cs typeface="Be Vietnam Pro" pitchFamily="34" charset="-120"/>
               </a:rPr>
-              <a:t> tiếp</a:t>
-            </a:r>
-            <a:r>
-              <a:rPr lang="en-US" sz="1950" dirty="0" spc="-1" kern="0">
-                <a:solidFill>
-                  <a:srgbClr val="6B6A66"/>
-                </a:solidFill>
-                <a:latin typeface="Be Vietnam Pro" pitchFamily="34" charset="0"/>
-                <a:ea typeface="Be Vietnam Pro" pitchFamily="34" charset="-122"/>
-                <a:cs typeface="Be Vietnam Pro" pitchFamily="34" charset="-120"/>
-              </a:rPr>
               <a:t> thư</a:t>
-            </a:r>
-            <a:r>
-              <a:rPr lang="en-US" sz="1950" dirty="0" spc="17" kern="0">
-                <a:solidFill>
-                  <a:srgbClr val="6B6A66"/>
-                </a:solidFill>
-                <a:latin typeface="Be Vietnam Pro" pitchFamily="34" charset="0"/>
-                <a:ea typeface="Be Vietnam Pro" pitchFamily="34" charset="-122"/>
-                <a:cs typeface="Be Vietnam Pro" pitchFamily="34" charset="-120"/>
-              </a:rPr>
-              <a:t> điện</a:t>
-            </a:r>
-            <a:r>
-              <a:rPr lang="en-US" sz="1950" dirty="0" spc="-1" kern="0">
-                <a:solidFill>
-                  <a:srgbClr val="6B6A66"/>
-                </a:solidFill>
-                <a:latin typeface="Be Vietnam Pro" pitchFamily="34" charset="0"/>
-                <a:ea typeface="Be Vietnam Pro" pitchFamily="34" charset="-122"/>
-                <a:cs typeface="Be Vietnam Pro" pitchFamily="34" charset="-120"/>
-              </a:rPr>
-              <a:t> tử</a:t>
             </a:r>
             <a:endParaRPr lang="en-US" sz="1950" dirty="0"/>
           </a:p>
@@ -15860,7 +15849,7 @@
               <a:buNone/>
             </a:pPr>
             <a:r>
-              <a:rPr lang="en-US" sz="1950" dirty="0" spc="-10" kern="0">
+              <a:rPr lang="en-US" sz="1950" dirty="0" spc="-11" kern="0">
                 <a:solidFill>
                   <a:srgbClr val="6B6A66"/>
                 </a:solidFill>
@@ -15868,7 +15857,7 @@
                 <a:ea typeface="Be Vietnam Pro" pitchFamily="34" charset="-122"/>
                 <a:cs typeface="Be Vietnam Pro" pitchFamily="34" charset="-120"/>
               </a:rPr>
-              <a:t>truyền</a:t>
+              <a:t>chuyển</a:t>
             </a:r>
             <a:r>
               <a:rPr lang="en-US" sz="1950" dirty="0" spc="-12" kern="0">
@@ -15890,10 +15879,10 @@
                 <a:ea typeface="Be Vietnam Pro" pitchFamily="34" charset="-122"/>
                 <a:cs typeface="Be Vietnam Pro" pitchFamily="34" charset="-120"/>
               </a:rPr>
-              <a:t> qua</a:t>
-            </a:r>
-            <a:r>
-              <a:rPr lang="en-US" sz="1950" dirty="0" spc="2" kern="0">
+              <a:t> từ</a:t>
+            </a:r>
+            <a:r>
+              <a:rPr lang="en-US" sz="1950" dirty="0" spc="-7" kern="0">
                 <a:solidFill>
                   <a:srgbClr val="6B6A66"/>
                 </a:solidFill>
@@ -15901,7 +15890,40 @@
                 <a:ea typeface="Be Vietnam Pro" pitchFamily="34" charset="-122"/>
                 <a:cs typeface="Be Vietnam Pro" pitchFamily="34" charset="-120"/>
               </a:rPr>
-              <a:t> mạng</a:t>
+              <a:t> máy này</a:t>
+            </a:r>
+            <a:r>
+              <a:rPr lang="en-US" sz="1950" dirty="0" spc="-2" kern="0">
+                <a:solidFill>
+                  <a:srgbClr val="6B6A66"/>
+                </a:solidFill>
+                <a:latin typeface="Be Vietnam Pro" pitchFamily="34" charset="0"/>
+                <a:ea typeface="Be Vietnam Pro" pitchFamily="34" charset="-122"/>
+                <a:cs typeface="Be Vietnam Pro" pitchFamily="34" charset="-120"/>
+              </a:rPr>
+              <a:t> sang</a:t>
+            </a:r>
+            <a:r>
+              <a:rPr lang="en-US" sz="1950" dirty="0" spc="-7" kern="0">
+                <a:solidFill>
+                  <a:srgbClr val="6B6A66"/>
+                </a:solidFill>
+                <a:latin typeface="Be Vietnam Pro" pitchFamily="34" charset="0"/>
+                <a:ea typeface="Be Vietnam Pro" pitchFamily="34" charset="-122"/>
+                <a:cs typeface="Be Vietnam Pro" pitchFamily="34" charset="-120"/>
+              </a:rPr>
+              <a:t> máy</a:t>
+            </a:r>
+            <a:r>
+              <a:rPr lang="en-US" sz="1950" dirty="0" spc="-3" kern="0">
+                <a:solidFill>
+                  <a:srgbClr val="6B6A66"/>
+                </a:solidFill>
+                <a:latin typeface="Be Vietnam Pro" pitchFamily="34" charset="0"/>
+                <a:ea typeface="Be Vietnam Pro" pitchFamily="34" charset="-122"/>
+                <a:cs typeface="Be Vietnam Pro" pitchFamily="34" charset="-120"/>
+              </a:rPr>
+              <a:t> khác</a:t>
             </a:r>
             <a:endParaRPr lang="en-US" sz="1950" dirty="0"/>
           </a:p>
@@ -19061,6 +19083,17 @@
               <a:t> bản</a:t>
             </a:r>
             <a:r>
+              <a:rPr lang="en-US" sz="2550" dirty="0" spc="-8" kern="0">
+                <a:solidFill>
+                  <a:srgbClr val="14161C"/>
+                </a:solidFill>
+                <a:latin typeface="Be Vietnam Pro" pitchFamily="34" charset="0"/>
+                <a:ea typeface="Be Vietnam Pro" pitchFamily="34" charset="-122"/>
+                <a:cs typeface="Be Vietnam Pro" pitchFamily="34" charset="-120"/>
+              </a:rPr>
+              <a:t> sao</a:t>
+            </a:r>
+            <a:r>
               <a:rPr lang="en-US" sz="2550" dirty="0" spc="-1" kern="0">
                 <a:solidFill>
                   <a:srgbClr val="14161C"/>
@@ -19072,15 +19105,15 @@
               <a:t> ở</a:t>
             </a:r>
             <a:r>
-              <a:rPr lang="en-US" sz="2550" dirty="0" spc="-9" kern="0">
-                <a:solidFill>
-                  <a:srgbClr val="14161C"/>
-                </a:solidFill>
-                <a:latin typeface="Be Vietnam Pro" pitchFamily="34" charset="0"/>
-                <a:ea typeface="Be Vietnam Pro" pitchFamily="34" charset="-122"/>
-                <a:cs typeface="Be Vietnam Pro" pitchFamily="34" charset="-120"/>
-              </a:rPr>
-              <a:t> máy</a:t>
+              <a:rPr lang="en-US" sz="2550" dirty="0" spc="0" kern="0">
+                <a:solidFill>
+                  <a:srgbClr val="14161C"/>
+                </a:solidFill>
+                <a:latin typeface="Be Vietnam Pro" pitchFamily="34" charset="0"/>
+                <a:ea typeface="Be Vietnam Pro" pitchFamily="34" charset="-122"/>
+                <a:cs typeface="Be Vietnam Pro" pitchFamily="34" charset="-120"/>
+              </a:rPr>
+              <a:t> lớp phân</a:t>
             </a:r>
             <a:r>
               <a:rPr lang="en-US" sz="2550" dirty="0" spc="-1" kern="0">
@@ -19091,7 +19124,7 @@
                 <a:ea typeface="Be Vietnam Pro" pitchFamily="34" charset="-122"/>
                 <a:cs typeface="Be Vietnam Pro" pitchFamily="34" charset="-120"/>
               </a:rPr>
-              <a:t> chủ biên</a:t>
+              <a:t> phối</a:t>
             </a:r>
             <a:r>
               <a:rPr lang="en-US" sz="2550" dirty="0" spc="2" kern="0">
@@ -19105,18 +19138,18 @@
               <a:t> thì</a:t>
             </a:r>
             <a:r>
+              <a:rPr lang="en-US" sz="2550" dirty="0" spc="-1" kern="0">
+                <a:solidFill>
+                  <a:srgbClr val="14161C"/>
+                </a:solidFill>
+                <a:latin typeface="Be Vietnam Pro" pitchFamily="34" charset="0"/>
+                <a:ea typeface="Be Vietnam Pro" pitchFamily="34" charset="-122"/>
+                <a:cs typeface="Be Vietnam Pro" pitchFamily="34" charset="-120"/>
+              </a:rPr>
+              <a:t> nhận</a:t>
+            </a:r>
+            <a:r>
               <a:rPr lang="en-US" sz="2550" dirty="0" spc="0" kern="0">
-                <a:solidFill>
-                  <a:srgbClr val="14161C"/>
-                </a:solidFill>
-                <a:latin typeface="Be Vietnam Pro" pitchFamily="34" charset="0"/>
-                <a:ea typeface="Be Vietnam Pro" pitchFamily="34" charset="-122"/>
-                <a:cs typeface="Be Vietnam Pro" pitchFamily="34" charset="-120"/>
-              </a:rPr>
-              <a:t> nhận</a:t>
-            </a:r>
-            <a:r>
-              <a:rPr lang="en-US" sz="2550" dirty="0" spc="-2" kern="0">
                 <a:solidFill>
                   <a:srgbClr val="14161C"/>
                 </a:solidFill>

</xml_diff>

<commit_message>
Lessons sd-10-001 and sd-10-003: define origin server, IP address and cloud computing without the narrower models
Co-Authored-By: Claude Sonnet 5.5 <noreply@anthropic.com>
Claude-Session: https://claude.ai/code/session_01E4oCkXXqBf2c7oMUzFxEr2
</commit_message>
<xml_diff>
--- a/system-design-101/vi/lessons/sd-10-001/slides/sd-10-001.pptx
+++ b/system-design-101/vi/lessons/sd-10-001/slides/sd-10-001.pptx
@@ -3801,7 +3801,18 @@
                 <a:ea typeface="Be Vietnam Pro" pitchFamily="34" charset="-122"/>
                 <a:cs typeface="Be Vietnam Pro" pitchFamily="34" charset="-120"/>
               </a:rPr>
-              <a:t> IP</a:t>
+              <a:t> ở</a:t>
+            </a:r>
+            <a:r>
+              <a:rPr lang="en-US" sz="2550" dirty="0" spc="-9" kern="0">
+                <a:solidFill>
+                  <a:srgbClr val="F3EEE3"/>
+                </a:solidFill>
+                <a:latin typeface="Be Vietnam Pro" pitchFamily="34" charset="0"/>
+                <a:ea typeface="Be Vietnam Pro" pitchFamily="34" charset="-122"/>
+                <a:cs typeface="Be Vietnam Pro" pitchFamily="34" charset="-120"/>
+              </a:rPr>
+              <a:t> tầng</a:t>
             </a:r>
             <a:r>
               <a:rPr lang="en-US" sz="2550" dirty="0" spc="1" kern="0">
@@ -3812,10 +3823,10 @@
                 <a:ea typeface="Be Vietnam Pro" pitchFamily="34" charset="-122"/>
                 <a:cs typeface="Be Vietnam Pro" pitchFamily="34" charset="-120"/>
               </a:rPr>
-              <a:t> là</a:t>
-            </a:r>
-            <a:r>
-              <a:rPr lang="en-US" sz="2550" dirty="0" spc="-9" kern="0">
+              <a:t> mạng</a:t>
+            </a:r>
+            <a:r>
+              <a:rPr lang="en-US" sz="2550" dirty="0" spc="-2" kern="0">
                 <a:solidFill>
                   <a:srgbClr val="F3EEE3"/>
                 </a:solidFill>
@@ -3823,10 +3834,10 @@
                 <a:ea typeface="Be Vietnam Pro" pitchFamily="34" charset="-122"/>
                 <a:cs typeface="Be Vietnam Pro" pitchFamily="34" charset="-120"/>
               </a:rPr>
-              <a:t> dãy</a:t>
-            </a:r>
-            <a:r>
-              <a:rPr lang="en-US" sz="2550" dirty="0" spc="-11" kern="0">
+              <a:t> của</a:t>
+            </a:r>
+            <a:r>
+              <a:rPr lang="en-US" sz="2550" dirty="0" spc="-5" kern="0">
                 <a:solidFill>
                   <a:srgbClr val="F3EEE3"/>
                 </a:solidFill>
@@ -3834,7 +3845,18 @@
                 <a:ea typeface="Be Vietnam Pro" pitchFamily="34" charset="-122"/>
                 <a:cs typeface="Be Vietnam Pro" pitchFamily="34" charset="-120"/>
               </a:rPr>
-              <a:t> số</a:t>
+              <a:t> một</a:t>
+            </a:r>
+            <a:r>
+              <a:rPr lang="en-US" sz="2550" dirty="0" spc="0" kern="0">
+                <a:solidFill>
+                  <a:srgbClr val="F3EEE3"/>
+                </a:solidFill>
+                <a:latin typeface="Be Vietnam Pro" pitchFamily="34" charset="0"/>
+                <a:ea typeface="Be Vietnam Pro" pitchFamily="34" charset="-122"/>
+                <a:cs typeface="Be Vietnam Pro" pitchFamily="34" charset="-120"/>
+              </a:rPr>
+              <a:t> giao diện</a:t>
             </a:r>
             <a:r>
               <a:rPr lang="en-US" sz="2550" dirty="0" spc="1" kern="0">
@@ -3845,40 +3867,7 @@
                 <a:ea typeface="Be Vietnam Pro" pitchFamily="34" charset="-122"/>
                 <a:cs typeface="Be Vietnam Pro" pitchFamily="34" charset="-120"/>
               </a:rPr>
-              <a:t> chỉ</a:t>
-            </a:r>
-            <a:r>
-              <a:rPr lang="en-US" sz="2550" dirty="0" spc="-35" kern="0">
-                <a:solidFill>
-                  <a:srgbClr val="F3EEE3"/>
-                </a:solidFill>
-                <a:latin typeface="Be Vietnam Pro" pitchFamily="34" charset="0"/>
-                <a:ea typeface="Be Vietnam Pro" pitchFamily="34" charset="-122"/>
-                <a:cs typeface="Be Vietnam Pro" pitchFamily="34" charset="-120"/>
-              </a:rPr>
-              <a:t> ra</a:t>
-            </a:r>
-            <a:r>
-              <a:rPr lang="en-US" sz="2550" dirty="0" spc="-5" kern="0">
-                <a:solidFill>
-                  <a:srgbClr val="F3EEE3"/>
-                </a:solidFill>
-                <a:latin typeface="Be Vietnam Pro" pitchFamily="34" charset="0"/>
-                <a:ea typeface="Be Vietnam Pro" pitchFamily="34" charset="-122"/>
-                <a:cs typeface="Be Vietnam Pro" pitchFamily="34" charset="-120"/>
-              </a:rPr>
-              <a:t> một</a:t>
-            </a:r>
-            <a:r>
-              <a:rPr lang="en-US" sz="2550" dirty="0" spc="-6" kern="0">
-                <a:solidFill>
-                  <a:srgbClr val="F3EEE3"/>
-                </a:solidFill>
-                <a:latin typeface="Be Vietnam Pro" pitchFamily="34" charset="0"/>
-                <a:ea typeface="Be Vietnam Pro" pitchFamily="34" charset="-122"/>
-                <a:cs typeface="Be Vietnam Pro" pitchFamily="34" charset="-120"/>
-              </a:rPr>
-              <a:t> máy.</a:t>
+              <a:t> mạng.</a:t>
             </a:r>
             <a:endParaRPr lang="en-US" sz="2550" dirty="0"/>
           </a:p>
@@ -4349,7 +4338,7 @@
               <a:t> điển</a:t>
             </a:r>
             <a:r>
-              <a:rPr lang="en-US" sz="2850" dirty="0" spc="-11" kern="0">
+              <a:rPr lang="en-US" sz="2850" dirty="0" spc="3" kern="0">
                 <a:solidFill>
                   <a:srgbClr val="F3EEE3"/>
                 </a:solidFill>
@@ -4357,10 +4346,10 @@
                 <a:ea typeface="Be Vietnam Pro" pitchFamily="34" charset="-122"/>
                 <a:cs typeface="Be Vietnam Pro" pitchFamily="34" charset="-120"/>
               </a:rPr>
-              <a:t> thuật</a:t>
-            </a:r>
-            <a:r>
-              <a:rPr lang="en-US" sz="2850" dirty="0" spc="-1" kern="0">
+              <a:t> MDN ·</a:t>
+            </a:r>
+            <a:r>
+              <a:rPr lang="en-US" sz="2850" dirty="0" spc="-12" kern="0">
                 <a:solidFill>
                   <a:srgbClr val="F3EEE3"/>
                 </a:solidFill>
@@ -4368,10 +4357,10 @@
                 <a:ea typeface="Be Vietnam Pro" pitchFamily="34" charset="-122"/>
                 <a:cs typeface="Be Vietnam Pro" pitchFamily="34" charset="-120"/>
               </a:rPr>
-              <a:t> ngữ</a:t>
-            </a:r>
-            <a:r>
-              <a:rPr lang="en-US" sz="2850" dirty="0" spc="2" kern="0">
+              <a:t> RFC</a:t>
+            </a:r>
+            <a:r>
+              <a:rPr lang="en-US" sz="2850" dirty="0" spc="0" kern="0">
                 <a:solidFill>
                   <a:srgbClr val="F3EEE3"/>
                 </a:solidFill>
@@ -4379,7 +4368,7 @@
                 <a:ea typeface="Be Vietnam Pro" pitchFamily="34" charset="-122"/>
                 <a:cs typeface="Be Vietnam Pro" pitchFamily="34" charset="-120"/>
               </a:rPr>
-              <a:t> MDN</a:t>
+              <a:t> 9110</a:t>
             </a:r>
             <a:endParaRPr lang="en-US" sz="2850" dirty="0"/>
           </a:p>
@@ -6056,7 +6045,7 @@
               <a:t> nội dung,</a:t>
             </a:r>
             <a:r>
-              <a:rPr lang="en-US" sz="2100" dirty="0" spc="1" kern="0">
+              <a:rPr lang="en-US" sz="2100" dirty="0" spc="-24" kern="0">
                 <a:solidFill>
                   <a:srgbClr val="6B6A66"/>
                 </a:solidFill>
@@ -6064,10 +6053,10 @@
                 <a:ea typeface="Be Vietnam Pro" pitchFamily="34" charset="-122"/>
                 <a:cs typeface="Be Vietnam Pro" pitchFamily="34" charset="-120"/>
               </a:rPr>
-              <a:t> giữ</a:t>
-            </a:r>
-            <a:r>
-              <a:rPr lang="en-US" sz="2100" dirty="0" spc="-5" kern="0">
+              <a:t> trả</a:t>
+            </a:r>
+            <a:r>
+              <a:rPr lang="en-US" sz="2100" dirty="0" spc="-2" kern="0">
                 <a:solidFill>
                   <a:srgbClr val="6B6A66"/>
                 </a:solidFill>
@@ -6075,10 +6064,10 @@
                 <a:ea typeface="Be Vietnam Pro" pitchFamily="34" charset="-122"/>
                 <a:cs typeface="Be Vietnam Pro" pitchFamily="34" charset="-120"/>
               </a:rPr>
-              <a:t> bản</a:t>
-            </a:r>
-            <a:r>
-              <a:rPr lang="en-US" sz="2100" dirty="0" spc="-13" kern="0">
+              <a:t> lời</a:t>
+            </a:r>
+            <a:r>
+              <a:rPr lang="en-US" sz="2100" dirty="0" spc="0" kern="0">
                 <a:solidFill>
                   <a:srgbClr val="6B6A66"/>
                 </a:solidFill>
@@ -6086,7 +6075,18 @@
                 <a:ea typeface="Be Vietnam Pro" pitchFamily="34" charset="-122"/>
                 <a:cs typeface="Be Vietnam Pro" pitchFamily="34" charset="-120"/>
               </a:rPr>
-              <a:t> gốc,</a:t>
+              <a:t> chính</a:t>
+            </a:r>
+            <a:r>
+              <a:rPr lang="en-US" sz="2100" dirty="0" spc="5" kern="0">
+                <a:solidFill>
+                  <a:srgbClr val="6B6A66"/>
+                </a:solidFill>
+                <a:latin typeface="Be Vietnam Pro" pitchFamily="34" charset="0"/>
+                <a:ea typeface="Be Vietnam Pro" pitchFamily="34" charset="-122"/>
+                <a:cs typeface="Be Vietnam Pro" pitchFamily="34" charset="-120"/>
+              </a:rPr>
+              <a:t> thức,</a:t>
             </a:r>
             <a:r>
               <a:rPr lang="en-US" sz="2100" dirty="0" spc="18" kern="0">
@@ -8886,7 +8886,7 @@
               <a:buNone/>
             </a:pPr>
             <a:r>
-              <a:rPr lang="en-US" sz="3300" b="1" dirty="0" spc="-3" kern="0">
+              <a:rPr lang="en-US" sz="3300" b="1" dirty="0" spc="-80" kern="0">
                 <a:solidFill>
                   <a:srgbClr val="1F3FD1"/>
                 </a:solidFill>
@@ -8894,10 +8894,10 @@
                 <a:ea typeface="Be Vietnam Pro" pitchFamily="34" charset="-122"/>
                 <a:cs typeface="Be Vietnam Pro" pitchFamily="34" charset="-120"/>
               </a:rPr>
-              <a:t>Giữ</a:t>
-            </a:r>
-            <a:r>
-              <a:rPr lang="en-US" sz="3300" b="1" dirty="0" spc="-1" kern="0">
+              <a:t>Trả</a:t>
+            </a:r>
+            <a:r>
+              <a:rPr lang="en-US" sz="3300" b="1" dirty="0" spc="1" kern="0">
                 <a:solidFill>
                   <a:srgbClr val="1F3FD1"/>
                 </a:solidFill>
@@ -8905,10 +8905,10 @@
                 <a:ea typeface="Be Vietnam Pro" pitchFamily="34" charset="-122"/>
                 <a:cs typeface="Be Vietnam Pro" pitchFamily="34" charset="-120"/>
               </a:rPr>
-              <a:t> bản</a:t>
-            </a:r>
-            <a:r>
-              <a:rPr lang="en-US" sz="3300" b="1" dirty="0" spc="-4" kern="0">
+              <a:t> lời</a:t>
+            </a:r>
+            <a:r>
+              <a:rPr lang="en-US" sz="3300" b="1" dirty="0" spc="-8" kern="0">
                 <a:solidFill>
                   <a:srgbClr val="1F3FD1"/>
                 </a:solidFill>
@@ -8916,7 +8916,29 @@
                 <a:ea typeface="Be Vietnam Pro" pitchFamily="34" charset="-122"/>
                 <a:cs typeface="Be Vietnam Pro" pitchFamily="34" charset="-120"/>
               </a:rPr>
-              <a:t> chính</a:t>
+              <a:t> có</a:t>
+            </a:r>
+            <a:r>
+              <a:rPr lang="en-US" sz="3300" b="1" dirty="0" spc="-6" kern="0">
+                <a:solidFill>
+                  <a:srgbClr val="1F3FD1"/>
+                </a:solidFill>
+                <a:latin typeface="Be Vietnam Pro" pitchFamily="34" charset="0"/>
+                <a:ea typeface="Be Vietnam Pro" pitchFamily="34" charset="-122"/>
+                <a:cs typeface="Be Vietnam Pro" pitchFamily="34" charset="-120"/>
+              </a:rPr>
+              <a:t> thẩm</a:t>
+            </a:r>
+            <a:r>
+              <a:rPr lang="en-US" sz="3300" b="1" dirty="0" spc="-21" kern="0">
+                <a:solidFill>
+                  <a:srgbClr val="1F3FD1"/>
+                </a:solidFill>
+                <a:latin typeface="Be Vietnam Pro" pitchFamily="34" charset="0"/>
+                <a:ea typeface="Be Vietnam Pro" pitchFamily="34" charset="-122"/>
+                <a:cs typeface="Be Vietnam Pro" pitchFamily="34" charset="-120"/>
+              </a:rPr>
+              <a:t> quyền</a:t>
             </a:r>
             <a:endParaRPr lang="en-US" sz="3300" dirty="0"/>
           </a:p>
@@ -9294,6 +9316,17 @@
               <a:t>Gốc</a:t>
             </a:r>
             <a:r>
+              <a:rPr lang="en-US" sz="2700" dirty="0" spc="-27" kern="0">
+                <a:solidFill>
+                  <a:srgbClr val="14161C"/>
+                </a:solidFill>
+                <a:latin typeface="Be Vietnam Pro" pitchFamily="34" charset="0"/>
+                <a:ea typeface="Be Vietnam Pro" pitchFamily="34" charset="-122"/>
+                <a:cs typeface="Be Vietnam Pro" pitchFamily="34" charset="-120"/>
+              </a:rPr>
+              <a:t> trả</a:t>
+            </a:r>
+            <a:r>
               <a:rPr lang="en-US" sz="2700" dirty="0" spc="-2" kern="0">
                 <a:solidFill>
                   <a:srgbClr val="14161C"/>
@@ -9302,43 +9335,76 @@
                 <a:ea typeface="Be Vietnam Pro" pitchFamily="34" charset="-122"/>
                 <a:cs typeface="Be Vietnam Pro" pitchFamily="34" charset="-120"/>
               </a:rPr>
+              <a:t> lời</a:t>
+            </a:r>
+            <a:r>
+              <a:rPr lang="en-US" sz="2700" dirty="0" spc="0" kern="0">
+                <a:solidFill>
+                  <a:srgbClr val="14161C"/>
+                </a:solidFill>
+                <a:latin typeface="Be Vietnam Pro" pitchFamily="34" charset="0"/>
+                <a:ea typeface="Be Vietnam Pro" pitchFamily="34" charset="-122"/>
+                <a:cs typeface="Be Vietnam Pro" pitchFamily="34" charset="-120"/>
+              </a:rPr>
+              <a:t> có thẩm</a:t>
+            </a:r>
+            <a:r>
+              <a:rPr lang="en-US" sz="2700" dirty="0" spc="-14" kern="0">
+                <a:solidFill>
+                  <a:srgbClr val="14161C"/>
+                </a:solidFill>
+                <a:latin typeface="Be Vietnam Pro" pitchFamily="34" charset="0"/>
+                <a:ea typeface="Be Vietnam Pro" pitchFamily="34" charset="-122"/>
+                <a:cs typeface="Be Vietnam Pro" pitchFamily="34" charset="-120"/>
+              </a:rPr>
+              <a:t> quyền;</a:t>
+            </a:r>
+            <a:r>
+              <a:rPr lang="en-US" sz="2700" dirty="0" spc="-3" kern="0">
+                <a:solidFill>
+                  <a:srgbClr val="14161C"/>
+                </a:solidFill>
+                <a:latin typeface="Be Vietnam Pro" pitchFamily="34" charset="0"/>
+                <a:ea typeface="Be Vietnam Pro" pitchFamily="34" charset="-122"/>
+                <a:cs typeface="Be Vietnam Pro" pitchFamily="34" charset="-120"/>
+              </a:rPr>
+              <a:t> lớp</a:t>
+            </a:r>
+            <a:r>
+              <a:rPr lang="en-US" sz="2700" dirty="0" spc="-1" kern="0">
+                <a:solidFill>
+                  <a:srgbClr val="14161C"/>
+                </a:solidFill>
+                <a:latin typeface="Be Vietnam Pro" pitchFamily="34" charset="0"/>
+                <a:ea typeface="Be Vietnam Pro" pitchFamily="34" charset="-122"/>
+                <a:cs typeface="Be Vietnam Pro" pitchFamily="34" charset="-120"/>
+              </a:rPr>
+              <a:t> phân</a:t>
+            </a:r>
+            <a:r>
+              <a:rPr lang="en-US" sz="2700" dirty="0" spc="-2" kern="0">
+                <a:solidFill>
+                  <a:srgbClr val="14161C"/>
+                </a:solidFill>
+                <a:latin typeface="Be Vietnam Pro" pitchFamily="34" charset="0"/>
+                <a:ea typeface="Be Vietnam Pro" pitchFamily="34" charset="-122"/>
+                <a:cs typeface="Be Vietnam Pro" pitchFamily="34" charset="-120"/>
+              </a:rPr>
+              <a:t> phối</a:t>
+            </a:r>
+            <a:r>
+              <a:rPr lang="en-US" sz="2700" dirty="0" spc="-3" kern="0">
+                <a:solidFill>
+                  <a:srgbClr val="14161C"/>
+                </a:solidFill>
+                <a:latin typeface="Be Vietnam Pro" pitchFamily="34" charset="0"/>
+                <a:ea typeface="Be Vietnam Pro" pitchFamily="34" charset="-122"/>
+                <a:cs typeface="Be Vietnam Pro" pitchFamily="34" charset="-120"/>
+              </a:rPr>
               <a:t> giữ</a:t>
             </a:r>
             <a:r>
-              <a:rPr lang="en-US" sz="2700" dirty="0" spc="-6" kern="0">
-                <a:solidFill>
-                  <a:srgbClr val="14161C"/>
-                </a:solidFill>
-                <a:latin typeface="Be Vietnam Pro" pitchFamily="34" charset="0"/>
-                <a:ea typeface="Be Vietnam Pro" pitchFamily="34" charset="-122"/>
-                <a:cs typeface="Be Vietnam Pro" pitchFamily="34" charset="-120"/>
-              </a:rPr>
-              <a:t> bản</a:t>
-            </a:r>
-            <a:r>
-              <a:rPr lang="en-US" sz="2700" dirty="0" spc="0" kern="0">
-                <a:solidFill>
-                  <a:srgbClr val="14161C"/>
-                </a:solidFill>
-                <a:latin typeface="Be Vietnam Pro" pitchFamily="34" charset="0"/>
-                <a:ea typeface="Be Vietnam Pro" pitchFamily="34" charset="-122"/>
-                <a:cs typeface="Be Vietnam Pro" pitchFamily="34" charset="-120"/>
-              </a:rPr>
-              <a:t> chính;</a:t>
-            </a:r>
-            <a:r>
-              <a:rPr lang="en-US" sz="2700" dirty="0" spc="-2" kern="0">
-                <a:solidFill>
-                  <a:srgbClr val="14161C"/>
-                </a:solidFill>
-                <a:latin typeface="Be Vietnam Pro" pitchFamily="34" charset="0"/>
-                <a:ea typeface="Be Vietnam Pro" pitchFamily="34" charset="-122"/>
-                <a:cs typeface="Be Vietnam Pro" pitchFamily="34" charset="-120"/>
-              </a:rPr>
-              <a:t> lớp phân phối giữ</a:t>
-            </a:r>
-            <a:r>
-              <a:rPr lang="en-US" sz="2700" dirty="0" spc="-6" kern="0">
+              <a:rPr lang="en-US" sz="2700" dirty="0" spc="-5" kern="0">
                 <a:solidFill>
                   <a:srgbClr val="14161C"/>
                 </a:solidFill>
@@ -10094,7 +10160,7 @@
               <a:t> gốc</a:t>
             </a:r>
             <a:r>
-              <a:rPr lang="en-US" sz="1950" dirty="0" spc="2" kern="0">
+              <a:rPr lang="en-US" sz="1950" dirty="0" spc="-11" kern="0">
                 <a:solidFill>
                   <a:srgbClr val="6B6A66"/>
                 </a:solidFill>
@@ -10102,7 +10168,40 @@
                 <a:ea typeface="Be Vietnam Pro" pitchFamily="34" charset="-122"/>
                 <a:cs typeface="Be Vietnam Pro" pitchFamily="34" charset="-120"/>
               </a:rPr>
-              <a:t> giữ</a:t>
+              <a:t> tạo</a:t>
+            </a:r>
+            <a:r>
+              <a:rPr lang="en-US" sz="1950" dirty="0" spc="-1" kern="0">
+                <a:solidFill>
+                  <a:srgbClr val="6B6A66"/>
+                </a:solidFill>
+                <a:latin typeface="Be Vietnam Pro" pitchFamily="34" charset="0"/>
+                <a:ea typeface="Be Vietnam Pro" pitchFamily="34" charset="-122"/>
+                <a:cs typeface="Be Vietnam Pro" pitchFamily="34" charset="-120"/>
+              </a:rPr>
+              <a:t> câu</a:t>
+            </a:r>
+            <a:r>
+              <a:rPr lang="en-US" sz="1950" dirty="0" spc="-20" kern="0">
+                <a:solidFill>
+                  <a:srgbClr val="6B6A66"/>
+                </a:solidFill>
+                <a:latin typeface="Be Vietnam Pro" pitchFamily="34" charset="0"/>
+                <a:ea typeface="Be Vietnam Pro" pitchFamily="34" charset="-122"/>
+                <a:cs typeface="Be Vietnam Pro" pitchFamily="34" charset="-120"/>
+              </a:rPr>
+              <a:t> trả</a:t>
+            </a:r>
+            <a:r>
+              <a:rPr lang="en-US" sz="1950" dirty="0" spc="-2" kern="0">
+                <a:solidFill>
+                  <a:srgbClr val="6B6A66"/>
+                </a:solidFill>
+                <a:latin typeface="Be Vietnam Pro" pitchFamily="34" charset="0"/>
+                <a:ea typeface="Be Vietnam Pro" pitchFamily="34" charset="-122"/>
+                <a:cs typeface="Be Vietnam Pro" pitchFamily="34" charset="-120"/>
+              </a:rPr>
+              <a:t> lời</a:t>
             </a:r>
             <a:r>
               <a:rPr lang="en-US" sz="1950" dirty="0" spc="-3" kern="0">
@@ -10113,7 +10212,7 @@
                 <a:ea typeface="Be Vietnam Pro" pitchFamily="34" charset="-122"/>
                 <a:cs typeface="Be Vietnam Pro" pitchFamily="34" charset="-120"/>
               </a:rPr>
-              <a:t> bản</a:t>
+              <a:t> có</a:t>
             </a:r>
             <a:r>
               <a:rPr lang="en-US" sz="1950" dirty="0" spc="0" kern="0">
@@ -10124,10 +10223,10 @@
                 <a:ea typeface="Be Vietnam Pro" pitchFamily="34" charset="-122"/>
                 <a:cs typeface="Be Vietnam Pro" pitchFamily="34" charset="-120"/>
               </a:rPr>
-              <a:t> chính;</a:t>
-            </a:r>
-            <a:r>
-              <a:rPr lang="en-US" sz="1950" dirty="0" spc="-7" kern="0">
+              <a:t> thẩm</a:t>
+            </a:r>
+            <a:r>
+              <a:rPr lang="en-US" sz="1950" dirty="0" spc="-9" kern="0">
                 <a:solidFill>
                   <a:srgbClr val="6B6A66"/>
                 </a:solidFill>
@@ -10135,6 +10234,17 @@
                 <a:ea typeface="Be Vietnam Pro" pitchFamily="34" charset="-122"/>
                 <a:cs typeface="Be Vietnam Pro" pitchFamily="34" charset="-120"/>
               </a:rPr>
+              <a:t> quyền;</a:t>
+            </a:r>
+            <a:r>
+              <a:rPr lang="en-US" sz="1950" dirty="0" spc="-8" kern="0">
+                <a:solidFill>
+                  <a:srgbClr val="6B6A66"/>
+                </a:solidFill>
+                <a:latin typeface="Be Vietnam Pro" pitchFamily="34" charset="0"/>
+                <a:ea typeface="Be Vietnam Pro" pitchFamily="34" charset="-122"/>
+                <a:cs typeface="Be Vietnam Pro" pitchFamily="34" charset="-120"/>
+              </a:rPr>
               <a:t> máy</a:t>
             </a:r>
             <a:r>
@@ -10149,6 +10259,17 @@
               <a:t> chủ</a:t>
             </a:r>
             <a:r>
+              <a:rPr lang="en-US" sz="1950" dirty="0" spc="-2" kern="0">
+                <a:solidFill>
+                  <a:srgbClr val="6B6A66"/>
+                </a:solidFill>
+                <a:latin typeface="Be Vietnam Pro" pitchFamily="34" charset="0"/>
+                <a:ea typeface="Be Vietnam Pro" pitchFamily="34" charset="-122"/>
+                <a:cs typeface="Be Vietnam Pro" pitchFamily="34" charset="-120"/>
+              </a:rPr>
+              <a:t> ở</a:t>
+            </a:r>
+            <a:r>
               <a:rPr lang="en-US" sz="1950" dirty="0" spc="-3" kern="0">
                 <a:solidFill>
                   <a:srgbClr val="6B6A66"/>
@@ -10157,7 +10278,7 @@
                 <a:ea typeface="Be Vietnam Pro" pitchFamily="34" charset="-122"/>
                 <a:cs typeface="Be Vietnam Pro" pitchFamily="34" charset="-120"/>
               </a:rPr>
-              <a:t> ở lớp</a:t>
+              <a:t> lớp</a:t>
             </a:r>
             <a:r>
               <a:rPr lang="en-US" sz="1950" dirty="0" spc="0" kern="0">
@@ -13116,6 +13237,94 @@
               <a:t> tra</a:t>
             </a:r>
             <a:r>
+              <a:rPr lang="en-US" sz="2700" dirty="0" spc="-15" kern="0">
+                <a:solidFill>
+                  <a:srgbClr val="14161C"/>
+                </a:solidFill>
+                <a:latin typeface="Be Vietnam Pro" pitchFamily="34" charset="0"/>
+                <a:ea typeface="Be Vietnam Pro" pitchFamily="34" charset="-122"/>
+                <a:cs typeface="Be Vietnam Pro" pitchFamily="34" charset="-120"/>
+              </a:rPr>
+              <a:t> tên</a:t>
+            </a:r>
+            <a:r>
+              <a:rPr lang="en-US" sz="2700" dirty="0" spc="-40" kern="0">
+                <a:solidFill>
+                  <a:srgbClr val="14161C"/>
+                </a:solidFill>
+                <a:latin typeface="Be Vietnam Pro" pitchFamily="34" charset="0"/>
+                <a:ea typeface="Be Vietnam Pro" pitchFamily="34" charset="-122"/>
+                <a:cs typeface="Be Vietnam Pro" pitchFamily="34" charset="-120"/>
+              </a:rPr>
+              <a:t> ra</a:t>
+            </a:r>
+            <a:r>
+              <a:rPr lang="en-US" sz="2700" dirty="0" spc="24" kern="0">
+                <a:solidFill>
+                  <a:srgbClr val="14161C"/>
+                </a:solidFill>
+                <a:latin typeface="Be Vietnam Pro" pitchFamily="34" charset="0"/>
+                <a:ea typeface="Be Vietnam Pro" pitchFamily="34" charset="-122"/>
+                <a:cs typeface="Be Vietnam Pro" pitchFamily="34" charset="-120"/>
+              </a:rPr>
+              <a:t> địa</a:t>
+            </a:r>
+            <a:r>
+              <a:rPr lang="en-US" sz="2700" dirty="0" spc="-1" kern="0">
+                <a:solidFill>
+                  <a:srgbClr val="14161C"/>
+                </a:solidFill>
+                <a:latin typeface="Be Vietnam Pro" pitchFamily="34" charset="0"/>
+                <a:ea typeface="Be Vietnam Pro" pitchFamily="34" charset="-122"/>
+                <a:cs typeface="Be Vietnam Pro" pitchFamily="34" charset="-120"/>
+              </a:rPr>
+              <a:t> chỉ</a:t>
+            </a:r>
+            <a:r>
+              <a:rPr lang="en-US" sz="2700" dirty="0" spc="0" kern="0">
+                <a:solidFill>
+                  <a:srgbClr val="14161C"/>
+                </a:solidFill>
+                <a:latin typeface="Be Vietnam Pro" pitchFamily="34" charset="0"/>
+                <a:ea typeface="Be Vietnam Pro" pitchFamily="34" charset="-122"/>
+                <a:cs typeface="Be Vietnam Pro" pitchFamily="34" charset="-120"/>
+              </a:rPr>
+              <a:t> IP,</a:t>
+            </a:r>
+            <a:r>
+              <a:rPr lang="en-US" sz="2700" dirty="0" spc="23" kern="0">
+                <a:solidFill>
+                  <a:srgbClr val="14161C"/>
+                </a:solidFill>
+                <a:latin typeface="Be Vietnam Pro" pitchFamily="34" charset="0"/>
+                <a:ea typeface="Be Vietnam Pro" pitchFamily="34" charset="-122"/>
+                <a:cs typeface="Be Vietnam Pro" pitchFamily="34" charset="-120"/>
+              </a:rPr>
+              <a:t> địa</a:t>
+            </a:r>
+            <a:r>
+              <a:rPr lang="en-US" sz="2700" dirty="0" spc="-1" kern="0">
+                <a:solidFill>
+                  <a:srgbClr val="14161C"/>
+                </a:solidFill>
+                <a:latin typeface="Be Vietnam Pro" pitchFamily="34" charset="0"/>
+                <a:ea typeface="Be Vietnam Pro" pitchFamily="34" charset="-122"/>
+                <a:cs typeface="Be Vietnam Pro" pitchFamily="34" charset="-120"/>
+              </a:rPr>
+              <a:t> chỉ</a:t>
+            </a:r>
+            <a:r>
+              <a:rPr lang="en-US" sz="2700" dirty="0" spc="-3" kern="0">
+                <a:solidFill>
+                  <a:srgbClr val="14161C"/>
+                </a:solidFill>
+                <a:latin typeface="Be Vietnam Pro" pitchFamily="34" charset="0"/>
+                <a:ea typeface="Be Vietnam Pro" pitchFamily="34" charset="-122"/>
+                <a:cs typeface="Be Vietnam Pro" pitchFamily="34" charset="-120"/>
+              </a:rPr>
+              <a:t> ở</a:t>
+            </a:r>
+            <a:r>
               <a:rPr lang="en-US" sz="2700" dirty="0" spc="-11" kern="0">
                 <a:solidFill>
                   <a:srgbClr val="14161C"/>
@@ -13124,29 +13333,7 @@
                 <a:ea typeface="Be Vietnam Pro" pitchFamily="34" charset="-122"/>
                 <a:cs typeface="Be Vietnam Pro" pitchFamily="34" charset="-120"/>
               </a:rPr>
-              <a:t> tên;</a:t>
-            </a:r>
-            <a:r>
-              <a:rPr lang="en-US" sz="2700" dirty="0" spc="24" kern="0">
-                <a:solidFill>
-                  <a:srgbClr val="14161C"/>
-                </a:solidFill>
-                <a:latin typeface="Be Vietnam Pro" pitchFamily="34" charset="0"/>
-                <a:ea typeface="Be Vietnam Pro" pitchFamily="34" charset="-122"/>
-                <a:cs typeface="Be Vietnam Pro" pitchFamily="34" charset="-120"/>
-              </a:rPr>
-              <a:t> địa</a:t>
-            </a:r>
-            <a:r>
-              <a:rPr lang="en-US" sz="2700" dirty="0" spc="-1" kern="0">
-                <a:solidFill>
-                  <a:srgbClr val="14161C"/>
-                </a:solidFill>
-                <a:latin typeface="Be Vietnam Pro" pitchFamily="34" charset="0"/>
-                <a:ea typeface="Be Vietnam Pro" pitchFamily="34" charset="-122"/>
-                <a:cs typeface="Be Vietnam Pro" pitchFamily="34" charset="-120"/>
-              </a:rPr>
-              <a:t> chỉ</a:t>
+              <a:t> tầng</a:t>
             </a:r>
             <a:r>
               <a:rPr lang="en-US" sz="2700" dirty="0" spc="-2" kern="0">
@@ -13157,73 +13344,7 @@
                 <a:ea typeface="Be Vietnam Pro" pitchFamily="34" charset="-122"/>
                 <a:cs typeface="Be Vietnam Pro" pitchFamily="34" charset="-120"/>
               </a:rPr>
-              <a:t> IP</a:t>
-            </a:r>
-            <a:r>
-              <a:rPr lang="en-US" sz="2700" dirty="0" spc="-1" kern="0">
-                <a:solidFill>
-                  <a:srgbClr val="14161C"/>
-                </a:solidFill>
-                <a:latin typeface="Be Vietnam Pro" pitchFamily="34" charset="0"/>
-                <a:ea typeface="Be Vietnam Pro" pitchFamily="34" charset="-122"/>
-                <a:cs typeface="Be Vietnam Pro" pitchFamily="34" charset="-120"/>
-              </a:rPr>
-              <a:t> là</a:t>
-            </a:r>
-            <a:r>
-              <a:rPr lang="en-US" sz="2700" dirty="0" spc="-12" kern="0">
-                <a:solidFill>
-                  <a:srgbClr val="14161C"/>
-                </a:solidFill>
-                <a:latin typeface="Be Vietnam Pro" pitchFamily="34" charset="0"/>
-                <a:ea typeface="Be Vietnam Pro" pitchFamily="34" charset="-122"/>
-                <a:cs typeface="Be Vietnam Pro" pitchFamily="34" charset="-120"/>
-              </a:rPr>
-              <a:t> dãy số</a:t>
-            </a:r>
-            <a:r>
-              <a:rPr lang="en-US" sz="2700" dirty="0" spc="-1" kern="0">
-                <a:solidFill>
-                  <a:srgbClr val="14161C"/>
-                </a:solidFill>
-                <a:latin typeface="Be Vietnam Pro" pitchFamily="34" charset="0"/>
-                <a:ea typeface="Be Vietnam Pro" pitchFamily="34" charset="-122"/>
-                <a:cs typeface="Be Vietnam Pro" pitchFamily="34" charset="-120"/>
-              </a:rPr>
-              <a:t> chỉ</a:t>
-            </a:r>
-            <a:r>
-              <a:rPr lang="en-US" sz="2700" dirty="0" spc="-40" kern="0">
-                <a:solidFill>
-                  <a:srgbClr val="14161C"/>
-                </a:solidFill>
-                <a:latin typeface="Be Vietnam Pro" pitchFamily="34" charset="0"/>
-                <a:ea typeface="Be Vietnam Pro" pitchFamily="34" charset="-122"/>
-                <a:cs typeface="Be Vietnam Pro" pitchFamily="34" charset="-120"/>
-              </a:rPr>
-              <a:t> ra</a:t>
-            </a:r>
-            <a:r>
-              <a:rPr lang="en-US" sz="2700" dirty="0" spc="-7" kern="0">
-                <a:solidFill>
-                  <a:srgbClr val="14161C"/>
-                </a:solidFill>
-                <a:latin typeface="Be Vietnam Pro" pitchFamily="34" charset="0"/>
-                <a:ea typeface="Be Vietnam Pro" pitchFamily="34" charset="-122"/>
-                <a:cs typeface="Be Vietnam Pro" pitchFamily="34" charset="-120"/>
-              </a:rPr>
-              <a:t> một</a:t>
-            </a:r>
-            <a:r>
-              <a:rPr lang="en-US" sz="2700" dirty="0" spc="-10" kern="0">
-                <a:solidFill>
-                  <a:srgbClr val="14161C"/>
-                </a:solidFill>
-                <a:latin typeface="Be Vietnam Pro" pitchFamily="34" charset="0"/>
-                <a:ea typeface="Be Vietnam Pro" pitchFamily="34" charset="-122"/>
-                <a:cs typeface="Be Vietnam Pro" pitchFamily="34" charset="-120"/>
-              </a:rPr>
-              <a:t> máy.</a:t>
+              <a:t> mạng.</a:t>
             </a:r>
             <a:endParaRPr lang="en-US" sz="2700" dirty="0"/>
           </a:p>
@@ -13709,7 +13830,7 @@
               <a:buNone/>
             </a:pPr>
             <a:r>
-              <a:rPr lang="en-US" sz="1950" dirty="0" spc="-12" kern="0">
+              <a:rPr lang="en-US" sz="1950" dirty="0" spc="28" kern="0">
                 <a:solidFill>
                   <a:srgbClr val="6B6A66"/>
                 </a:solidFill>
@@ -13717,10 +13838,10 @@
                 <a:ea typeface="Be Vietnam Pro" pitchFamily="34" charset="-122"/>
                 <a:cs typeface="Be Vietnam Pro" pitchFamily="34" charset="-120"/>
               </a:rPr>
-              <a:t>dãy</a:t>
-            </a:r>
-            <a:r>
-              <a:rPr lang="en-US" sz="1950" dirty="0" spc="-7" kern="0">
+              <a:t>địa</a:t>
+            </a:r>
+            <a:r>
+              <a:rPr lang="en-US" sz="1950" dirty="0" spc="-2" kern="0">
                 <a:solidFill>
                   <a:srgbClr val="6B6A66"/>
                 </a:solidFill>
@@ -13728,7 +13849,7 @@
                 <a:ea typeface="Be Vietnam Pro" pitchFamily="34" charset="-122"/>
                 <a:cs typeface="Be Vietnam Pro" pitchFamily="34" charset="-120"/>
               </a:rPr>
-              <a:t> số</a:t>
+              <a:t> chỉ</a:t>
             </a:r>
             <a:endParaRPr lang="en-US" sz="1950" dirty="0"/>
           </a:p>

</xml_diff>